<commit_message>
Publish verified interim Mini Gibson submission
</commit_message>
<xml_diff>
--- a/presentation/final-findings/mini-gibson-final-findings.pptx
+++ b/presentation/final-findings/mini-gibson-final-findings.pptx
@@ -2,18 +2,18 @@
 <file path=ppt/presentation.xml><?xml version="1.0" encoding="utf-8"?>
 <p:presentation xmlns:p="http://schemas.openxmlformats.org/presentationml/2006/main">
   <p:sldMasterIdLst>
-    <p:sldMasterId xmlns:r="http://schemas.openxmlformats.org/officeDocument/2006/relationships" id="2147483648" r:id="R84e6bb3b31764994"/>
+    <p:sldMasterId xmlns:r="http://schemas.openxmlformats.org/officeDocument/2006/relationships" id="2147483648" r:id="Rd92df3121d94483d"/>
   </p:sldMasterIdLst>
   <p:notesMasterIdLst>
-    <p:notesMasterId xmlns:r="http://schemas.openxmlformats.org/officeDocument/2006/relationships" r:id="R6be425e6b9104363"/>
+    <p:notesMasterId xmlns:r="http://schemas.openxmlformats.org/officeDocument/2006/relationships" r:id="R04424d0d45e54960"/>
   </p:notesMasterIdLst>
   <p:sldIdLst>
-    <p:sldId xmlns:r="http://schemas.openxmlformats.org/officeDocument/2006/relationships" id="256" r:id="R5156c8df373543df"/>
-    <p:sldId xmlns:r="http://schemas.openxmlformats.org/officeDocument/2006/relationships" id="257" r:id="R75297d17ebea416c"/>
-    <p:sldId xmlns:r="http://schemas.openxmlformats.org/officeDocument/2006/relationships" id="258" r:id="R865cd4472a244cc8"/>
-    <p:sldId xmlns:r="http://schemas.openxmlformats.org/officeDocument/2006/relationships" id="259" r:id="R7c373e104def447c"/>
-    <p:sldId xmlns:r="http://schemas.openxmlformats.org/officeDocument/2006/relationships" id="260" r:id="R18fa1beb405f41d4"/>
-    <p:sldId xmlns:r="http://schemas.openxmlformats.org/officeDocument/2006/relationships" id="261" r:id="R465004dfbdd64d92"/>
+    <p:sldId xmlns:r="http://schemas.openxmlformats.org/officeDocument/2006/relationships" id="256" r:id="R0087295a337c410c"/>
+    <p:sldId xmlns:r="http://schemas.openxmlformats.org/officeDocument/2006/relationships" id="257" r:id="Rd14cb8d24efb4352"/>
+    <p:sldId xmlns:r="http://schemas.openxmlformats.org/officeDocument/2006/relationships" id="258" r:id="R958eb2264ada438b"/>
+    <p:sldId xmlns:r="http://schemas.openxmlformats.org/officeDocument/2006/relationships" id="259" r:id="Rb22d64c770754630"/>
+    <p:sldId xmlns:r="http://schemas.openxmlformats.org/officeDocument/2006/relationships" id="260" r:id="R2790cfa1a22c46a4"/>
+    <p:sldId xmlns:r="http://schemas.openxmlformats.org/officeDocument/2006/relationships" id="261" r:id="R08c86a6463014750"/>
   </p:sldIdLst>
   <p:sldSz cx="12192000" cy="6858000"/>
   <p:notesSz cx="6858000" cy="9144000"/>
@@ -727,7 +727,7 @@
           <a:lstStyle xmlns:a="http://schemas.openxmlformats.org/drawingml/2006/main"/>
           <a:p xmlns:a="http://schemas.openxmlformats.org/drawingml/2006/main">
             <a:r>
-              <a:t>Source: docs/evidence/mini-gibson-successor-2026-10-18/. Final values should read 34/456 checked, 30 compatible, 4 incompatible. This compatibility preflight ran no models, agents, parsers, tests, or formal comparisons.</a:t>
+              <a:t>Interim submission: the frozen plan has 456 task packages, the 35-task final holdout is sealed, and the active compatibility preflight has produced no new model result. The matrix is not terminal; live compatibility counts are intentionally omitted. Source: docs/evidence/mini-gibson-successor-2026-10-18/PROTOCOL.md and the public R3 progress note.</a:t>
             </a:r>
           </a:p>
         </p:txBody>
@@ -844,7 +844,7 @@
           <p:cNvPr id="3" name="Title">
             <a:extLst xmlns:a="http://schemas.openxmlformats.org/drawingml/2006/main">
               <a:ext uri="{FF2B5EF4-FFF2-40B4-BE49-F238E27FC236}">
-                <a16:creationId xmlns:a16="http://schemas.microsoft.com/office/drawing/2014/main" id="{823481B8-C347-41C5-90CA-015EC565988F}"/>
+                <a16:creationId xmlns:a16="http://schemas.microsoft.com/office/drawing/2014/main" id="{CEA52C54-FF71-4B9A-8ED4-7DBDCDA9922F}"/>
               </a:ext>
             </a:extLst>
           </p:cNvPr>
@@ -1073,7 +1073,7 @@
           <p:cNvPr id="2" name="Subtitle">
             <a:extLst xmlns:a="http://schemas.openxmlformats.org/drawingml/2006/main">
               <a:ext uri="{FF2B5EF4-FFF2-40B4-BE49-F238E27FC236}">
-                <a16:creationId xmlns:a16="http://schemas.microsoft.com/office/drawing/2014/main" id="{FF0FEB0E-AAA4-43FC-8672-2092822E21DF}"/>
+                <a16:creationId xmlns:a16="http://schemas.microsoft.com/office/drawing/2014/main" id="{29011579-E047-47A2-93A9-50E88E02C75D}"/>
               </a:ext>
             </a:extLst>
           </p:cNvPr>
@@ -1319,7 +1319,7 @@
           <p:cNvPr id="2" name="Section title">
             <a:extLst xmlns:a="http://schemas.openxmlformats.org/drawingml/2006/main">
               <a:ext uri="{FF2B5EF4-FFF2-40B4-BE49-F238E27FC236}">
-                <a16:creationId xmlns:a16="http://schemas.microsoft.com/office/drawing/2014/main" id="{A1BCC865-6525-4B9D-A60E-C50856220FBB}"/>
+                <a16:creationId xmlns:a16="http://schemas.microsoft.com/office/drawing/2014/main" id="{E2E25C63-6FF2-4DE6-B7BB-E95F55E1798E}"/>
               </a:ext>
             </a:extLst>
           </p:cNvPr>
@@ -1565,7 +1565,7 @@
           <p:cNvPr id="3" name="Title">
             <a:extLst xmlns:a="http://schemas.openxmlformats.org/drawingml/2006/main">
               <a:ext uri="{FF2B5EF4-FFF2-40B4-BE49-F238E27FC236}">
-                <a16:creationId xmlns:a16="http://schemas.microsoft.com/office/drawing/2014/main" id="{AF79B3CC-FA2D-4374-AEF0-4FCF017A96F5}"/>
+                <a16:creationId xmlns:a16="http://schemas.microsoft.com/office/drawing/2014/main" id="{0498A94E-C513-44E0-8091-304BC5C2E18A}"/>
               </a:ext>
             </a:extLst>
           </p:cNvPr>
@@ -1794,7 +1794,7 @@
           <p:cNvPr id="2" name="Body">
             <a:extLst xmlns:a="http://schemas.openxmlformats.org/drawingml/2006/main">
               <a:ext uri="{FF2B5EF4-FFF2-40B4-BE49-F238E27FC236}">
-                <a16:creationId xmlns:a16="http://schemas.microsoft.com/office/drawing/2014/main" id="{7E1C5F82-CB6A-4FA8-BB65-CC86A5085F16}"/>
+                <a16:creationId xmlns:a16="http://schemas.microsoft.com/office/drawing/2014/main" id="{8885E0DA-51F9-4A61-BA93-AE6A83910D3F}"/>
               </a:ext>
             </a:extLst>
           </p:cNvPr>
@@ -2040,7 +2040,7 @@
           <p:cNvPr id="4" name="Title">
             <a:extLst xmlns:a="http://schemas.openxmlformats.org/drawingml/2006/main">
               <a:ext uri="{FF2B5EF4-FFF2-40B4-BE49-F238E27FC236}">
-                <a16:creationId xmlns:a16="http://schemas.microsoft.com/office/drawing/2014/main" id="{EB89D06F-5E70-4DAB-A496-6F5E49AD6E29}"/>
+                <a16:creationId xmlns:a16="http://schemas.microsoft.com/office/drawing/2014/main" id="{C27CDF30-41C2-49D7-A33F-D6AD3203107D}"/>
               </a:ext>
             </a:extLst>
           </p:cNvPr>
@@ -2269,7 +2269,7 @@
           <p:cNvPr id="2" name="Left column">
             <a:extLst xmlns:a="http://schemas.openxmlformats.org/drawingml/2006/main">
               <a:ext uri="{FF2B5EF4-FFF2-40B4-BE49-F238E27FC236}">
-                <a16:creationId xmlns:a16="http://schemas.microsoft.com/office/drawing/2014/main" id="{2B3AF221-37A9-426E-9CF5-3AAB5DEC8D17}"/>
+                <a16:creationId xmlns:a16="http://schemas.microsoft.com/office/drawing/2014/main" id="{B46854A0-D4E5-4A23-A9A7-E2BBD8E20301}"/>
               </a:ext>
             </a:extLst>
           </p:cNvPr>
@@ -2498,7 +2498,7 @@
           <p:cNvPr id="3" name="Right column">
             <a:extLst xmlns:a="http://schemas.openxmlformats.org/drawingml/2006/main">
               <a:ext uri="{FF2B5EF4-FFF2-40B4-BE49-F238E27FC236}">
-                <a16:creationId xmlns:a16="http://schemas.microsoft.com/office/drawing/2014/main" id="{1B231156-C410-41DB-BBBF-2149B417F9E1}"/>
+                <a16:creationId xmlns:a16="http://schemas.microsoft.com/office/drawing/2014/main" id="{4B54952A-9C4B-4490-B495-C6F44EEEB429}"/>
               </a:ext>
             </a:extLst>
           </p:cNvPr>
@@ -2744,7 +2744,7 @@
           <p:cNvPr id="3" name="Title">
             <a:extLst xmlns:a="http://schemas.openxmlformats.org/drawingml/2006/main">
               <a:ext uri="{FF2B5EF4-FFF2-40B4-BE49-F238E27FC236}">
-                <a16:creationId xmlns:a16="http://schemas.microsoft.com/office/drawing/2014/main" id="{1305E33B-D745-4251-B1ED-60EA057226C3}"/>
+                <a16:creationId xmlns:a16="http://schemas.microsoft.com/office/drawing/2014/main" id="{26C486F4-5743-410E-A0BE-DAA390F44BCD}"/>
               </a:ext>
             </a:extLst>
           </p:cNvPr>
@@ -2973,7 +2973,7 @@
           <p:cNvPr id="2" name="Left column">
             <a:extLst xmlns:a="http://schemas.openxmlformats.org/drawingml/2006/main">
               <a:ext uri="{FF2B5EF4-FFF2-40B4-BE49-F238E27FC236}">
-                <a16:creationId xmlns:a16="http://schemas.microsoft.com/office/drawing/2014/main" id="{F68BE1F1-F1DE-4255-BDC0-9E3ACF988ED5}"/>
+                <a16:creationId xmlns:a16="http://schemas.microsoft.com/office/drawing/2014/main" id="{9F65DE71-6B6A-4728-B697-731C75437DF9}"/>
               </a:ext>
             </a:extLst>
           </p:cNvPr>
@@ -3240,12 +3240,12 @@
   </p:cSld>
   <p:clrMap bg1="lt1" tx1="dk1" bg2="lt2" tx2="dk2" accent1="accent1" accent2="accent2" accent3="accent3" accent4="accent4" accent5="accent5" accent6="accent6" hlink="hlink" folHlink="folHlink"/>
   <p:sldLayoutIdLst>
-    <p:sldLayoutId xmlns:r="http://schemas.openxmlformats.org/officeDocument/2006/relationships" id="2147483649" r:id="R7369a00e7a974f89"/>
-    <p:sldLayoutId xmlns:r="http://schemas.openxmlformats.org/officeDocument/2006/relationships" id="2147483650" r:id="Reaefdd42c39b40fd"/>
-    <p:sldLayoutId xmlns:r="http://schemas.openxmlformats.org/officeDocument/2006/relationships" id="2147483651" r:id="Rc99a4a5351ce4428"/>
-    <p:sldLayoutId xmlns:r="http://schemas.openxmlformats.org/officeDocument/2006/relationships" id="2147483652" r:id="R2b229f063b3844b8"/>
-    <p:sldLayoutId xmlns:r="http://schemas.openxmlformats.org/officeDocument/2006/relationships" id="2147483653" r:id="Rc888e55da2fb4124"/>
-    <p:sldLayoutId xmlns:r="http://schemas.openxmlformats.org/officeDocument/2006/relationships" id="2147483654" r:id="Rf5647c5e6f904a9b"/>
+    <p:sldLayoutId xmlns:r="http://schemas.openxmlformats.org/officeDocument/2006/relationships" id="2147483649" r:id="Rf0a83f315a384925"/>
+    <p:sldLayoutId xmlns:r="http://schemas.openxmlformats.org/officeDocument/2006/relationships" id="2147483650" r:id="R72e724291e6245bd"/>
+    <p:sldLayoutId xmlns:r="http://schemas.openxmlformats.org/officeDocument/2006/relationships" id="2147483651" r:id="R60022d6f99214611"/>
+    <p:sldLayoutId xmlns:r="http://schemas.openxmlformats.org/officeDocument/2006/relationships" id="2147483652" r:id="R758234c3cc974ad1"/>
+    <p:sldLayoutId xmlns:r="http://schemas.openxmlformats.org/officeDocument/2006/relationships" id="2147483653" r:id="Rb19b1f9f2c064f95"/>
+    <p:sldLayoutId xmlns:r="http://schemas.openxmlformats.org/officeDocument/2006/relationships" id="2147483654" r:id="Ra7e793e2cb7a40a8"/>
   </p:sldLayoutIdLst>
   <p:txStyles>
     <p:titleStyle>
@@ -3840,7 +3840,7 @@
                   <c:v>Resolved issues</c:v>
                 </c:pt>
                 <c:pt idx="1">
-                  <c:v>Malformed responses</c:v>
+                  <c:v>Tasks with malformed response</c:v>
                 </c:pt>
               </c:strCache>
             </c:strRef>
@@ -3882,7 +3882,7 @@
                   <c:v>Resolved issues</c:v>
                 </c:pt>
                 <c:pt idx="1">
-                  <c:v>Malformed responses</c:v>
+                  <c:v>Tasks with malformed response</c:v>
                 </c:pt>
               </c:strCache>
             </c:strRef>
@@ -4092,7 +4092,7 @@
           <p:cNvPr id="9" name="">
             <a:extLst xmlns:a="http://schemas.openxmlformats.org/drawingml/2006/main">
               <a:ext uri="{FF2B5EF4-FFF2-40B4-BE49-F238E27FC236}">
-                <a16:creationId xmlns:a16="http://schemas.microsoft.com/office/drawing/2014/main" id="{9AA169F4-B82F-43A2-B070-51306C985E60}"/>
+                <a16:creationId xmlns:a16="http://schemas.microsoft.com/office/drawing/2014/main" id="{57FFEFF9-C4E0-499E-A225-72D982568A38}"/>
               </a:ext>
             </a:extLst>
           </p:cNvPr>
@@ -4102,7 +4102,7 @@
           <p:nvPr/>
         </p:nvPicPr>
         <p:blipFill>
-          <a:blip xmlns:r="http://schemas.openxmlformats.org/officeDocument/2006/relationships" xmlns:a="http://schemas.openxmlformats.org/drawingml/2006/main" r:embed="R37cb10a190ec404c"/>
+          <a:blip xmlns:r="http://schemas.openxmlformats.org/officeDocument/2006/relationships" xmlns:a="http://schemas.openxmlformats.org/drawingml/2006/main" r:embed="Rc8a0d434e4ab4d87"/>
           <a:srcRect xmlns:a="http://schemas.openxmlformats.org/drawingml/2006/main" l="0" t="27" r="0" b="27"/>
           <a:stretch xmlns:a="http://schemas.openxmlformats.org/drawingml/2006/main">
             <a:fillRect l="0" t="0" r="0" b="0"/>
@@ -4123,7 +4123,7 @@
           <p:cNvPr id="2" name="">
             <a:extLst xmlns:a="http://schemas.openxmlformats.org/drawingml/2006/main">
               <a:ext uri="{FF2B5EF4-FFF2-40B4-BE49-F238E27FC236}">
-                <a16:creationId xmlns:a16="http://schemas.microsoft.com/office/drawing/2014/main" id="{E265FA39-9601-4623-9371-ABFB1CFF53D0}"/>
+                <a16:creationId xmlns:a16="http://schemas.microsoft.com/office/drawing/2014/main" id="{9FCF48CA-131F-4812-BAE0-6F7C8A34D5CE}"/>
               </a:ext>
             </a:extLst>
           </p:cNvPr>
@@ -4133,7 +4133,7 @@
           <p:nvPr/>
         </p:nvPicPr>
         <p:blipFill>
-          <a:blip xmlns:r="http://schemas.openxmlformats.org/officeDocument/2006/relationships" xmlns:a="http://schemas.openxmlformats.org/drawingml/2006/main" r:embed="R4c5e6843723a4a3d"/>
+          <a:blip xmlns:r="http://schemas.openxmlformats.org/officeDocument/2006/relationships" xmlns:a="http://schemas.openxmlformats.org/drawingml/2006/main" r:embed="R59f84bd9c3bb41e6"/>
           <a:stretch xmlns:a="http://schemas.openxmlformats.org/drawingml/2006/main"/>
         </p:blipFill>
         <p:spPr>
@@ -4151,7 +4151,7 @@
           <p:cNvPr id="3" name="">
             <a:extLst xmlns:a="http://schemas.openxmlformats.org/drawingml/2006/main">
               <a:ext uri="{FF2B5EF4-FFF2-40B4-BE49-F238E27FC236}">
-                <a16:creationId xmlns:a16="http://schemas.microsoft.com/office/drawing/2014/main" id="{90329F6B-9474-417F-85B3-198A16514074}"/>
+                <a16:creationId xmlns:a16="http://schemas.microsoft.com/office/drawing/2014/main" id="{B6C797A1-12FB-49DA-A432-8FEE02615F79}"/>
               </a:ext>
             </a:extLst>
           </p:cNvPr>
@@ -4308,7 +4308,7 @@
           <p:cNvPr id="4" name="">
             <a:extLst xmlns:a="http://schemas.openxmlformats.org/drawingml/2006/main">
               <a:ext uri="{FF2B5EF4-FFF2-40B4-BE49-F238E27FC236}">
-                <a16:creationId xmlns:a16="http://schemas.microsoft.com/office/drawing/2014/main" id="{F7021943-D58E-4871-B7C2-C3FDCDFA13C6}"/>
+                <a16:creationId xmlns:a16="http://schemas.microsoft.com/office/drawing/2014/main" id="{E629CAAF-B0D9-4205-8E3B-E373F41EC800}"/>
               </a:ext>
             </a:extLst>
           </p:cNvPr>
@@ -4465,7 +4465,7 @@
           <p:cNvPr id="5" name="">
             <a:extLst xmlns:a="http://schemas.openxmlformats.org/drawingml/2006/main">
               <a:ext uri="{FF2B5EF4-FFF2-40B4-BE49-F238E27FC236}">
-                <a16:creationId xmlns:a16="http://schemas.microsoft.com/office/drawing/2014/main" id="{7BA70730-6E45-4B25-9C32-3BB3D73596BC}"/>
+                <a16:creationId xmlns:a16="http://schemas.microsoft.com/office/drawing/2014/main" id="{C0AEEFCD-D739-48C0-9654-F2DCE00BE693}"/>
               </a:ext>
             </a:extLst>
           </p:cNvPr>
@@ -4622,7 +4622,7 @@
           <p:cNvPr id="6" name="">
             <a:extLst xmlns:a="http://schemas.openxmlformats.org/drawingml/2006/main">
               <a:ext uri="{FF2B5EF4-FFF2-40B4-BE49-F238E27FC236}">
-                <a16:creationId xmlns:a16="http://schemas.microsoft.com/office/drawing/2014/main" id="{411898DA-9614-4BFB-BC54-CD35F29D4C78}"/>
+                <a16:creationId xmlns:a16="http://schemas.microsoft.com/office/drawing/2014/main" id="{2742784F-5694-442E-81DD-9E9324344DEC}"/>
               </a:ext>
             </a:extLst>
           </p:cNvPr>
@@ -4655,7 +4655,7 @@
           <p:cNvPr id="7" name="">
             <a:extLst xmlns:a="http://schemas.openxmlformats.org/drawingml/2006/main">
               <a:ext uri="{FF2B5EF4-FFF2-40B4-BE49-F238E27FC236}">
-                <a16:creationId xmlns:a16="http://schemas.microsoft.com/office/drawing/2014/main" id="{5E745355-2DA2-4557-81A2-5955010C6E70}"/>
+                <a16:creationId xmlns:a16="http://schemas.microsoft.com/office/drawing/2014/main" id="{26B94FA8-8E2A-4C17-B876-E398E2CBE629}"/>
               </a:ext>
             </a:extLst>
           </p:cNvPr>
@@ -4812,7 +4812,7 @@
           <p:cNvPr id="8" name="">
             <a:extLst xmlns:a="http://schemas.openxmlformats.org/drawingml/2006/main">
               <a:ext uri="{FF2B5EF4-FFF2-40B4-BE49-F238E27FC236}">
-                <a16:creationId xmlns:a16="http://schemas.microsoft.com/office/drawing/2014/main" id="{521BD45B-8DFC-433D-A5F3-260603700DB5}"/>
+                <a16:creationId xmlns:a16="http://schemas.microsoft.com/office/drawing/2014/main" id="{EEBD5D67-E833-4539-8FA5-70C9B7199703}"/>
               </a:ext>
             </a:extLst>
           </p:cNvPr>
@@ -4967,7 +4967,7 @@
     </p:spTree>
     <p:extLst>
       <p:ext uri="{BB962C8B-B14F-4D97-AF65-F5344CB8AC3E}">
-        <p14:creationId xmlns:p14="http://schemas.microsoft.com/office/powerpoint/2010/main" val="1941212259"/>
+        <p14:creationId xmlns:p14="http://schemas.microsoft.com/office/powerpoint/2010/main" val="2063065042"/>
       </p:ext>
     </p:extLst>
   </p:cSld>
@@ -4998,7 +4998,7 @@
           <p:cNvPr id="13" name="">
             <a:extLst xmlns:a="http://schemas.openxmlformats.org/drawingml/2006/main">
               <a:ext uri="{FF2B5EF4-FFF2-40B4-BE49-F238E27FC236}">
-                <a16:creationId xmlns:a16="http://schemas.microsoft.com/office/drawing/2014/main" id="{FA58CAB5-C50A-41BC-A022-F993E567137E}"/>
+                <a16:creationId xmlns:a16="http://schemas.microsoft.com/office/drawing/2014/main" id="{49A3B2E7-09CB-4877-AFCC-1A1BC2A47E9A}"/>
               </a:ext>
             </a:extLst>
           </p:cNvPr>
@@ -5155,7 +5155,7 @@
           <p:cNvPr id="2" name="">
             <a:extLst xmlns:a="http://schemas.openxmlformats.org/drawingml/2006/main">
               <a:ext uri="{FF2B5EF4-FFF2-40B4-BE49-F238E27FC236}">
-                <a16:creationId xmlns:a16="http://schemas.microsoft.com/office/drawing/2014/main" id="{4091CC5C-BB0E-4C94-852E-6BD3AA49656F}"/>
+                <a16:creationId xmlns:a16="http://schemas.microsoft.com/office/drawing/2014/main" id="{A2290C93-74A8-4918-B3EB-ADF40B7BC6C2}"/>
               </a:ext>
             </a:extLst>
           </p:cNvPr>
@@ -5312,7 +5312,7 @@
           <p:cNvPr id="3" name="">
             <a:extLst xmlns:a="http://schemas.openxmlformats.org/drawingml/2006/main">
               <a:ext uri="{FF2B5EF4-FFF2-40B4-BE49-F238E27FC236}">
-                <a16:creationId xmlns:a16="http://schemas.microsoft.com/office/drawing/2014/main" id="{9F915E4F-24FB-4396-975F-8052B24C16CB}"/>
+                <a16:creationId xmlns:a16="http://schemas.microsoft.com/office/drawing/2014/main" id="{70ED0BCE-352F-4D3D-990E-027CDC8276AE}"/>
               </a:ext>
             </a:extLst>
           </p:cNvPr>
@@ -5345,7 +5345,7 @@
           <p:cNvPr id="4" name="">
             <a:extLst xmlns:a="http://schemas.openxmlformats.org/drawingml/2006/main">
               <a:ext uri="{FF2B5EF4-FFF2-40B4-BE49-F238E27FC236}">
-                <a16:creationId xmlns:a16="http://schemas.microsoft.com/office/drawing/2014/main" id="{B37C4674-7812-4BEA-BBDD-D2822A94C978}"/>
+                <a16:creationId xmlns:a16="http://schemas.microsoft.com/office/drawing/2014/main" id="{B32D7DA9-30E7-449E-8B92-0DCECBC58EA7}"/>
               </a:ext>
             </a:extLst>
           </p:cNvPr>
@@ -5502,7 +5502,7 @@
           <p:cNvPr id="5" name="">
             <a:extLst xmlns:a="http://schemas.openxmlformats.org/drawingml/2006/main">
               <a:ext uri="{FF2B5EF4-FFF2-40B4-BE49-F238E27FC236}">
-                <a16:creationId xmlns:a16="http://schemas.microsoft.com/office/drawing/2014/main" id="{154C5723-3162-428F-81A9-C9AB23707ECF}"/>
+                <a16:creationId xmlns:a16="http://schemas.microsoft.com/office/drawing/2014/main" id="{FC32FF9E-CFF9-4455-ABEC-CAC9E6ED0FA6}"/>
               </a:ext>
             </a:extLst>
           </p:cNvPr>
@@ -5659,7 +5659,7 @@
           <p:cNvPr id="6" name="">
             <a:extLst xmlns:a="http://schemas.openxmlformats.org/drawingml/2006/main">
               <a:ext uri="{FF2B5EF4-FFF2-40B4-BE49-F238E27FC236}">
-                <a16:creationId xmlns:a16="http://schemas.microsoft.com/office/drawing/2014/main" id="{19822E57-C9FB-4E06-9458-395CB34A8DA5}"/>
+                <a16:creationId xmlns:a16="http://schemas.microsoft.com/office/drawing/2014/main" id="{515605CD-3A31-47C0-97F8-259C544943A9}"/>
               </a:ext>
             </a:extLst>
           </p:cNvPr>
@@ -5816,7 +5816,7 @@
           <p:cNvPr id="7" name="">
             <a:extLst xmlns:a="http://schemas.openxmlformats.org/drawingml/2006/main">
               <a:ext uri="{FF2B5EF4-FFF2-40B4-BE49-F238E27FC236}">
-                <a16:creationId xmlns:a16="http://schemas.microsoft.com/office/drawing/2014/main" id="{BC6EE8E5-A33A-479F-AC00-E6437A4EE0D3}"/>
+                <a16:creationId xmlns:a16="http://schemas.microsoft.com/office/drawing/2014/main" id="{3A63A7EC-001E-4A92-BA59-A4E7D412FA66}"/>
               </a:ext>
             </a:extLst>
           </p:cNvPr>
@@ -5973,7 +5973,7 @@
           <p:cNvPr id="8" name="">
             <a:extLst xmlns:a="http://schemas.openxmlformats.org/drawingml/2006/main">
               <a:ext uri="{FF2B5EF4-FFF2-40B4-BE49-F238E27FC236}">
-                <a16:creationId xmlns:a16="http://schemas.microsoft.com/office/drawing/2014/main" id="{5E2952EE-A361-43DE-9E4B-10D27C068191}"/>
+                <a16:creationId xmlns:a16="http://schemas.microsoft.com/office/drawing/2014/main" id="{37FAEA42-E5BC-4024-BC02-0580B955722B}"/>
               </a:ext>
             </a:extLst>
           </p:cNvPr>
@@ -5983,7 +5983,7 @@
           <p:nvPr/>
         </p:nvPicPr>
         <p:blipFill>
-          <a:blip xmlns:r="http://schemas.openxmlformats.org/officeDocument/2006/relationships" xmlns:a="http://schemas.openxmlformats.org/drawingml/2006/main" r:embed="R0811c24f407d4b1b"/>
+          <a:blip xmlns:r="http://schemas.openxmlformats.org/officeDocument/2006/relationships" xmlns:a="http://schemas.openxmlformats.org/drawingml/2006/main" r:embed="Rfa4a458091a04434"/>
           <a:srcRect xmlns:a="http://schemas.openxmlformats.org/drawingml/2006/main" l="0" t="8654" r="0" b="8654"/>
           <a:stretch xmlns:a="http://schemas.openxmlformats.org/drawingml/2006/main">
             <a:fillRect l="0" t="0" r="0" b="0"/>
@@ -6006,7 +6006,7 @@
           <p:cNvPr id="9" name="">
             <a:extLst xmlns:a="http://schemas.openxmlformats.org/drawingml/2006/main">
               <a:ext uri="{FF2B5EF4-FFF2-40B4-BE49-F238E27FC236}">
-                <a16:creationId xmlns:a16="http://schemas.microsoft.com/office/drawing/2014/main" id="{94745009-C1C6-4B07-8EB4-67A8445A0B12}"/>
+                <a16:creationId xmlns:a16="http://schemas.microsoft.com/office/drawing/2014/main" id="{E4DFFE1B-F9BA-4EE7-BA77-FB9ADA8A395C}"/>
               </a:ext>
             </a:extLst>
           </p:cNvPr>
@@ -6039,7 +6039,7 @@
           <p:cNvPr id="10" name="">
             <a:extLst xmlns:a="http://schemas.openxmlformats.org/drawingml/2006/main">
               <a:ext uri="{FF2B5EF4-FFF2-40B4-BE49-F238E27FC236}">
-                <a16:creationId xmlns:a16="http://schemas.microsoft.com/office/drawing/2014/main" id="{C58A002C-6796-4BF3-A3B3-50DA7941DD4E}"/>
+                <a16:creationId xmlns:a16="http://schemas.microsoft.com/office/drawing/2014/main" id="{3FB4FD6C-4DC2-4A46-8DAC-1C5F091755E9}"/>
               </a:ext>
             </a:extLst>
           </p:cNvPr>
@@ -6196,7 +6196,7 @@
           <p:cNvPr id="11" name="">
             <a:extLst xmlns:a="http://schemas.openxmlformats.org/drawingml/2006/main">
               <a:ext uri="{FF2B5EF4-FFF2-40B4-BE49-F238E27FC236}">
-                <a16:creationId xmlns:a16="http://schemas.microsoft.com/office/drawing/2014/main" id="{43C77103-16D8-43DE-94A2-E02BF33442C5}"/>
+                <a16:creationId xmlns:a16="http://schemas.microsoft.com/office/drawing/2014/main" id="{4CFC3403-5635-4B92-9F40-ECC2B9B6969C}"/>
               </a:ext>
             </a:extLst>
           </p:cNvPr>
@@ -6353,7 +6353,7 @@
           <p:cNvPr id="12" name="">
             <a:extLst xmlns:a="http://schemas.openxmlformats.org/drawingml/2006/main">
               <a:ext uri="{FF2B5EF4-FFF2-40B4-BE49-F238E27FC236}">
-                <a16:creationId xmlns:a16="http://schemas.microsoft.com/office/drawing/2014/main" id="{5DAB2D15-4772-41E4-8F29-93FB2B1F76AE}"/>
+                <a16:creationId xmlns:a16="http://schemas.microsoft.com/office/drawing/2014/main" id="{38149202-A256-4449-B17B-D1091485B5B5}"/>
               </a:ext>
             </a:extLst>
           </p:cNvPr>
@@ -6508,7 +6508,7 @@
     </p:spTree>
     <p:extLst>
       <p:ext uri="{BB962C8B-B14F-4D97-AF65-F5344CB8AC3E}">
-        <p14:creationId xmlns:p14="http://schemas.microsoft.com/office/powerpoint/2010/main" val="865123339"/>
+        <p14:creationId xmlns:p14="http://schemas.microsoft.com/office/powerpoint/2010/main" val="1523180938"/>
       </p:ext>
     </p:extLst>
   </p:cSld>
@@ -6539,7 +6539,7 @@
           <p:cNvPr id="17" name="">
             <a:extLst xmlns:a="http://schemas.openxmlformats.org/drawingml/2006/main">
               <a:ext uri="{FF2B5EF4-FFF2-40B4-BE49-F238E27FC236}">
-                <a16:creationId xmlns:a16="http://schemas.microsoft.com/office/drawing/2014/main" id="{DF96DBF7-3E75-4FEA-AE4C-338546E3053D}"/>
+                <a16:creationId xmlns:a16="http://schemas.microsoft.com/office/drawing/2014/main" id="{3A06CBB6-21D8-4F2B-9A44-53DF482C1D16}"/>
               </a:ext>
             </a:extLst>
           </p:cNvPr>
@@ -6696,7 +6696,7 @@
           <p:cNvPr id="2" name="">
             <a:extLst xmlns:a="http://schemas.openxmlformats.org/drawingml/2006/main">
               <a:ext uri="{FF2B5EF4-FFF2-40B4-BE49-F238E27FC236}">
-                <a16:creationId xmlns:a16="http://schemas.microsoft.com/office/drawing/2014/main" id="{A0F26EC4-9084-4530-8B6F-D906C76A1B54}"/>
+                <a16:creationId xmlns:a16="http://schemas.microsoft.com/office/drawing/2014/main" id="{D9D1C3EB-6EF1-463F-8303-3A028F3582BA}"/>
               </a:ext>
             </a:extLst>
           </p:cNvPr>
@@ -6853,7 +6853,7 @@
           <p:cNvPr id="3" name="">
             <a:extLst xmlns:a="http://schemas.openxmlformats.org/drawingml/2006/main">
               <a:ext uri="{FF2B5EF4-FFF2-40B4-BE49-F238E27FC236}">
-                <a16:creationId xmlns:a16="http://schemas.microsoft.com/office/drawing/2014/main" id="{6867FB94-6169-4E69-ABF2-6B8D0DAF1184}"/>
+                <a16:creationId xmlns:a16="http://schemas.microsoft.com/office/drawing/2014/main" id="{6AC2BB3A-B706-403F-A4A4-1E19F16621F7}"/>
               </a:ext>
             </a:extLst>
           </p:cNvPr>
@@ -6886,7 +6886,7 @@
           <p:cNvPr id="4" name="">
             <a:extLst xmlns:a="http://schemas.openxmlformats.org/drawingml/2006/main">
               <a:ext uri="{FF2B5EF4-FFF2-40B4-BE49-F238E27FC236}">
-                <a16:creationId xmlns:a16="http://schemas.microsoft.com/office/drawing/2014/main" id="{243BD487-2ADA-4D69-AFA5-F0FC250BEDB1}"/>
+                <a16:creationId xmlns:a16="http://schemas.microsoft.com/office/drawing/2014/main" id="{3324F6E9-CEAC-4BA3-8662-FC7FAE5A27BE}"/>
               </a:ext>
             </a:extLst>
           </p:cNvPr>
@@ -7043,7 +7043,7 @@
           <p:cNvPr id="5" name="">
             <a:extLst xmlns:a="http://schemas.openxmlformats.org/drawingml/2006/main">
               <a:ext uri="{FF2B5EF4-FFF2-40B4-BE49-F238E27FC236}">
-                <a16:creationId xmlns:a16="http://schemas.microsoft.com/office/drawing/2014/main" id="{F2F72B1A-73A7-46FE-8D5D-A703DC2B4A52}"/>
+                <a16:creationId xmlns:a16="http://schemas.microsoft.com/office/drawing/2014/main" id="{42CBD186-7323-42B3-BBF6-96716D776C43}"/>
               </a:ext>
             </a:extLst>
           </p:cNvPr>
@@ -7200,7 +7200,7 @@
           <p:cNvPr id="6" name="">
             <a:extLst xmlns:a="http://schemas.openxmlformats.org/drawingml/2006/main">
               <a:ext uri="{FF2B5EF4-FFF2-40B4-BE49-F238E27FC236}">
-                <a16:creationId xmlns:a16="http://schemas.microsoft.com/office/drawing/2014/main" id="{0387CB7F-BA05-4820-BFEC-D948564C8A8C}"/>
+                <a16:creationId xmlns:a16="http://schemas.microsoft.com/office/drawing/2014/main" id="{9373449E-067C-49FE-BBB2-0DC1B06548A6}"/>
               </a:ext>
             </a:extLst>
           </p:cNvPr>
@@ -7357,7 +7357,7 @@
           <p:cNvPr id="7" name="">
             <a:extLst xmlns:a="http://schemas.openxmlformats.org/drawingml/2006/main">
               <a:ext uri="{FF2B5EF4-FFF2-40B4-BE49-F238E27FC236}">
-                <a16:creationId xmlns:a16="http://schemas.microsoft.com/office/drawing/2014/main" id="{B8CDDEDA-EE39-4739-8289-9F930C2C5C4F}"/>
+                <a16:creationId xmlns:a16="http://schemas.microsoft.com/office/drawing/2014/main" id="{74FE441A-C974-4BD5-883F-970E65E14087}"/>
               </a:ext>
             </a:extLst>
           </p:cNvPr>
@@ -7390,7 +7390,7 @@
           <p:cNvPr id="8" name="">
             <a:extLst xmlns:a="http://schemas.openxmlformats.org/drawingml/2006/main">
               <a:ext uri="{FF2B5EF4-FFF2-40B4-BE49-F238E27FC236}">
-                <a16:creationId xmlns:a16="http://schemas.microsoft.com/office/drawing/2014/main" id="{A9516DD7-C3DF-4B4A-90B5-10B1325CBDB1}"/>
+                <a16:creationId xmlns:a16="http://schemas.microsoft.com/office/drawing/2014/main" id="{92C0EDCB-EFFB-4E43-B318-7E2FD4F3D2C3}"/>
               </a:ext>
             </a:extLst>
           </p:cNvPr>
@@ -7547,7 +7547,7 @@
           <p:cNvPr id="9" name="">
             <a:extLst xmlns:a="http://schemas.openxmlformats.org/drawingml/2006/main">
               <a:ext uri="{FF2B5EF4-FFF2-40B4-BE49-F238E27FC236}">
-                <a16:creationId xmlns:a16="http://schemas.microsoft.com/office/drawing/2014/main" id="{CBFFC2DC-428A-4D48-A561-686DE79C8B5E}"/>
+                <a16:creationId xmlns:a16="http://schemas.microsoft.com/office/drawing/2014/main" id="{E15F80FA-1B4D-4C0B-B56B-A3B11539C61A}"/>
               </a:ext>
             </a:extLst>
           </p:cNvPr>
@@ -7704,7 +7704,7 @@
           <p:cNvPr id="10" name="">
             <a:extLst xmlns:a="http://schemas.openxmlformats.org/drawingml/2006/main">
               <a:ext uri="{FF2B5EF4-FFF2-40B4-BE49-F238E27FC236}">
-                <a16:creationId xmlns:a16="http://schemas.microsoft.com/office/drawing/2014/main" id="{42751B8C-1EDC-42A6-941E-7FF2D9E40609}"/>
+                <a16:creationId xmlns:a16="http://schemas.microsoft.com/office/drawing/2014/main" id="{0C41EF02-1B9C-47AA-8F8E-108F9FC21E95}"/>
               </a:ext>
             </a:extLst>
           </p:cNvPr>
@@ -7861,7 +7861,7 @@
           <p:cNvPr id="11" name="">
             <a:extLst xmlns:a="http://schemas.openxmlformats.org/drawingml/2006/main">
               <a:ext uri="{FF2B5EF4-FFF2-40B4-BE49-F238E27FC236}">
-                <a16:creationId xmlns:a16="http://schemas.microsoft.com/office/drawing/2014/main" id="{33E03CB1-8C66-41AB-A7A1-0E30C74E454F}"/>
+                <a16:creationId xmlns:a16="http://schemas.microsoft.com/office/drawing/2014/main" id="{1E05D7AE-F30C-4ECC-A792-053E659D68EF}"/>
               </a:ext>
             </a:extLst>
           </p:cNvPr>
@@ -7894,7 +7894,7 @@
           <p:cNvPr id="12" name="">
             <a:extLst xmlns:a="http://schemas.openxmlformats.org/drawingml/2006/main">
               <a:ext uri="{FF2B5EF4-FFF2-40B4-BE49-F238E27FC236}">
-                <a16:creationId xmlns:a16="http://schemas.microsoft.com/office/drawing/2014/main" id="{8A44D572-69F8-41B1-93A8-E3A11D616F88}"/>
+                <a16:creationId xmlns:a16="http://schemas.microsoft.com/office/drawing/2014/main" id="{B95F7300-60BA-426D-9CF9-E8AA8C1C4740}"/>
               </a:ext>
             </a:extLst>
           </p:cNvPr>
@@ -8051,7 +8051,7 @@
           <p:cNvPr id="13" name="">
             <a:extLst xmlns:a="http://schemas.openxmlformats.org/drawingml/2006/main">
               <a:ext uri="{FF2B5EF4-FFF2-40B4-BE49-F238E27FC236}">
-                <a16:creationId xmlns:a16="http://schemas.microsoft.com/office/drawing/2014/main" id="{DDFDA221-68FC-4579-B09E-845AF25A6094}"/>
+                <a16:creationId xmlns:a16="http://schemas.microsoft.com/office/drawing/2014/main" id="{89CF09C2-44FB-45DA-9514-91CF0D20B7A0}"/>
               </a:ext>
             </a:extLst>
           </p:cNvPr>
@@ -8208,7 +8208,7 @@
           <p:cNvPr id="14" name="">
             <a:extLst xmlns:a="http://schemas.openxmlformats.org/drawingml/2006/main">
               <a:ext uri="{FF2B5EF4-FFF2-40B4-BE49-F238E27FC236}">
-                <a16:creationId xmlns:a16="http://schemas.microsoft.com/office/drawing/2014/main" id="{CC37196E-76DC-40F4-B1E9-139386E248C9}"/>
+                <a16:creationId xmlns:a16="http://schemas.microsoft.com/office/drawing/2014/main" id="{B3534337-76E0-486F-BBB3-2770692AC61F}"/>
               </a:ext>
             </a:extLst>
           </p:cNvPr>
@@ -8365,7 +8365,7 @@
           <p:cNvPr id="15" name="">
             <a:extLst xmlns:a="http://schemas.openxmlformats.org/drawingml/2006/main">
               <a:ext uri="{FF2B5EF4-FFF2-40B4-BE49-F238E27FC236}">
-                <a16:creationId xmlns:a16="http://schemas.microsoft.com/office/drawing/2014/main" id="{40CF7A08-7491-4543-9C4A-888CCDC144B6}"/>
+                <a16:creationId xmlns:a16="http://schemas.microsoft.com/office/drawing/2014/main" id="{5FFB1B25-D25A-425D-A5AF-113EB9E69614}"/>
               </a:ext>
             </a:extLst>
           </p:cNvPr>
@@ -8522,7 +8522,7 @@
           <p:cNvPr id="16" name="">
             <a:extLst xmlns:a="http://schemas.openxmlformats.org/drawingml/2006/main">
               <a:ext uri="{FF2B5EF4-FFF2-40B4-BE49-F238E27FC236}">
-                <a16:creationId xmlns:a16="http://schemas.microsoft.com/office/drawing/2014/main" id="{7DAC09DF-9167-4859-99AC-9B34123A7B13}"/>
+                <a16:creationId xmlns:a16="http://schemas.microsoft.com/office/drawing/2014/main" id="{226149A3-A445-49CC-9C0B-8920F08BB845}"/>
               </a:ext>
             </a:extLst>
           </p:cNvPr>
@@ -8677,7 +8677,7 @@
     </p:spTree>
     <p:extLst>
       <p:ext uri="{BB962C8B-B14F-4D97-AF65-F5344CB8AC3E}">
-        <p14:creationId xmlns:p14="http://schemas.microsoft.com/office/powerpoint/2010/main" val="841004259"/>
+        <p14:creationId xmlns:p14="http://schemas.microsoft.com/office/powerpoint/2010/main" val="55867974"/>
       </p:ext>
     </p:extLst>
   </p:cSld>
@@ -8708,7 +8708,7 @@
           <p:cNvPr id="13" name="">
             <a:extLst xmlns:a="http://schemas.openxmlformats.org/drawingml/2006/main">
               <a:ext uri="{FF2B5EF4-FFF2-40B4-BE49-F238E27FC236}">
-                <a16:creationId xmlns:a16="http://schemas.microsoft.com/office/drawing/2014/main" id="{B9AFBD7D-BF9B-4487-9421-D4D61E14E12D}"/>
+                <a16:creationId xmlns:a16="http://schemas.microsoft.com/office/drawing/2014/main" id="{05CAFFD5-F27A-4C28-B3A7-53777454AB34}"/>
               </a:ext>
             </a:extLst>
           </p:cNvPr>
@@ -8865,7 +8865,7 @@
           <p:cNvPr id="2" name="">
             <a:extLst xmlns:a="http://schemas.openxmlformats.org/drawingml/2006/main">
               <a:ext uri="{FF2B5EF4-FFF2-40B4-BE49-F238E27FC236}">
-                <a16:creationId xmlns:a16="http://schemas.microsoft.com/office/drawing/2014/main" id="{C8EB1F88-A505-4B4D-BDC0-78592BC89D71}"/>
+                <a16:creationId xmlns:a16="http://schemas.microsoft.com/office/drawing/2014/main" id="{7460B324-96A7-45CC-B840-8FB7C6A5CE22}"/>
               </a:ext>
             </a:extLst>
           </p:cNvPr>
@@ -9022,7 +9022,7 @@
           <p:cNvPr id="3" name="">
             <a:extLst xmlns:a="http://schemas.openxmlformats.org/drawingml/2006/main">
               <a:ext uri="{FF2B5EF4-FFF2-40B4-BE49-F238E27FC236}">
-                <a16:creationId xmlns:a16="http://schemas.microsoft.com/office/drawing/2014/main" id="{EA4A445C-E091-4F34-9F84-5951DC8E0657}"/>
+                <a16:creationId xmlns:a16="http://schemas.microsoft.com/office/drawing/2014/main" id="{90FFA6B7-7F5A-45BA-A7ED-4A3A4B45EFFF}"/>
               </a:ext>
             </a:extLst>
           </p:cNvPr>
@@ -9055,7 +9055,7 @@
           <p:cNvPr id="4" name="Chart">
             <a:extLst xmlns:a="http://schemas.openxmlformats.org/drawingml/2006/main">
               <a:ext uri="{FF2B5EF4-FFF2-40B4-BE49-F238E27FC236}">
-                <a16:creationId xmlns:a16="http://schemas.microsoft.com/office/drawing/2014/main" id="{A6634840-2026-46BA-BC0D-50950F1124A2}"/>
+                <a16:creationId xmlns:a16="http://schemas.microsoft.com/office/drawing/2014/main" id="{0652919E-0236-49CE-A663-ACF9C3025DA2}"/>
               </a:ext>
             </a:extLst>
           </p:cNvPr>
@@ -9068,7 +9068,7 @@
         </p:xfrm>
         <a:graphic xmlns:a="http://schemas.openxmlformats.org/drawingml/2006/main">
           <a:graphicData uri="http://schemas.openxmlformats.org/drawingml/2006/chart">
-            <c:chart xmlns:r="http://schemas.openxmlformats.org/officeDocument/2006/relationships" xmlns:c="http://schemas.openxmlformats.org/drawingml/2006/chart" r:id="Rf70aa44efdfe4f1a"/>
+            <c:chart xmlns:r="http://schemas.openxmlformats.org/officeDocument/2006/relationships" xmlns:c="http://schemas.openxmlformats.org/drawingml/2006/chart" r:id="Refabeacf96154715"/>
           </a:graphicData>
         </a:graphic>
       </p:graphicFrame>
@@ -9077,7 +9077,7 @@
           <p:cNvPr id="5" name="">
             <a:extLst xmlns:a="http://schemas.openxmlformats.org/drawingml/2006/main">
               <a:ext uri="{FF2B5EF4-FFF2-40B4-BE49-F238E27FC236}">
-                <a16:creationId xmlns:a16="http://schemas.microsoft.com/office/drawing/2014/main" id="{87800A9D-C030-4C72-80EE-1A3A4AB37821}"/>
+                <a16:creationId xmlns:a16="http://schemas.microsoft.com/office/drawing/2014/main" id="{6E24400D-367C-4D0A-956B-374D05BD9420}"/>
               </a:ext>
             </a:extLst>
           </p:cNvPr>
@@ -9234,7 +9234,7 @@
           <p:cNvPr id="6" name="">
             <a:extLst xmlns:a="http://schemas.openxmlformats.org/drawingml/2006/main">
               <a:ext uri="{FF2B5EF4-FFF2-40B4-BE49-F238E27FC236}">
-                <a16:creationId xmlns:a16="http://schemas.microsoft.com/office/drawing/2014/main" id="{9035EC07-A278-47F2-ACDA-B3C2032B3324}"/>
+                <a16:creationId xmlns:a16="http://schemas.microsoft.com/office/drawing/2014/main" id="{BE0BCD4F-240B-4694-8472-4C6144CAEF86}"/>
               </a:ext>
             </a:extLst>
           </p:cNvPr>
@@ -9391,7 +9391,7 @@
           <p:cNvPr id="7" name="">
             <a:extLst xmlns:a="http://schemas.openxmlformats.org/drawingml/2006/main">
               <a:ext uri="{FF2B5EF4-FFF2-40B4-BE49-F238E27FC236}">
-                <a16:creationId xmlns:a16="http://schemas.microsoft.com/office/drawing/2014/main" id="{9E27E6CD-E1E6-49D1-9D6C-92A2389D1E42}"/>
+                <a16:creationId xmlns:a16="http://schemas.microsoft.com/office/drawing/2014/main" id="{AF4F2F5C-0E37-4210-BE4C-BA87E239AF28}"/>
               </a:ext>
             </a:extLst>
           </p:cNvPr>
@@ -9424,7 +9424,7 @@
           <p:cNvPr id="8" name="">
             <a:extLst xmlns:a="http://schemas.openxmlformats.org/drawingml/2006/main">
               <a:ext uri="{FF2B5EF4-FFF2-40B4-BE49-F238E27FC236}">
-                <a16:creationId xmlns:a16="http://schemas.microsoft.com/office/drawing/2014/main" id="{40FD9B06-57F3-4C6D-88A3-A79A70DF333C}"/>
+                <a16:creationId xmlns:a16="http://schemas.microsoft.com/office/drawing/2014/main" id="{3EF3802C-2E2C-4596-91F3-DB88C5A6E1C8}"/>
               </a:ext>
             </a:extLst>
           </p:cNvPr>
@@ -9571,7 +9571,7 @@
                 <a:ea typeface="Aptos"/>
                 <a:cs typeface="Aptos"/>
               </a:rPr>
-              <a:t>But the statistical gate was not met (p = 0.0717), and malformed responses increased from 8 to 21.</a:t>
+              <a:t>But the statistical gate was not met (p = 0.0717), and tasks affected by malformed responses increased from 8 to 21.</a:t>
             </a:r>
           </a:p>
         </p:txBody>
@@ -9581,7 +9581,7 @@
           <p:cNvPr id="9" name="">
             <a:extLst xmlns:a="http://schemas.openxmlformats.org/drawingml/2006/main">
               <a:ext uri="{FF2B5EF4-FFF2-40B4-BE49-F238E27FC236}">
-                <a16:creationId xmlns:a16="http://schemas.microsoft.com/office/drawing/2014/main" id="{B5ED01DA-77D2-4605-A0C0-3CEF7219C5D0}"/>
+                <a16:creationId xmlns:a16="http://schemas.microsoft.com/office/drawing/2014/main" id="{070A7A0F-DE1C-4DC2-89B3-2409CDC8D88A}"/>
               </a:ext>
             </a:extLst>
           </p:cNvPr>
@@ -9738,7 +9738,7 @@
           <p:cNvPr id="10" name="">
             <a:extLst xmlns:a="http://schemas.openxmlformats.org/drawingml/2006/main">
               <a:ext uri="{FF2B5EF4-FFF2-40B4-BE49-F238E27FC236}">
-                <a16:creationId xmlns:a16="http://schemas.microsoft.com/office/drawing/2014/main" id="{8891A99B-1680-4615-9F98-E379E9383790}"/>
+                <a16:creationId xmlns:a16="http://schemas.microsoft.com/office/drawing/2014/main" id="{7CD3ADD2-8737-4C69-9047-0714455C88CA}"/>
               </a:ext>
             </a:extLst>
           </p:cNvPr>
@@ -9895,7 +9895,7 @@
           <p:cNvPr id="11" name="">
             <a:extLst xmlns:a="http://schemas.openxmlformats.org/drawingml/2006/main">
               <a:ext uri="{FF2B5EF4-FFF2-40B4-BE49-F238E27FC236}">
-                <a16:creationId xmlns:a16="http://schemas.microsoft.com/office/drawing/2014/main" id="{A184F8C2-CB9C-4B88-8281-DAA5655066D4}"/>
+                <a16:creationId xmlns:a16="http://schemas.microsoft.com/office/drawing/2014/main" id="{8310D3F5-B75E-400B-982C-7AFA09BB1703}"/>
               </a:ext>
             </a:extLst>
           </p:cNvPr>
@@ -10052,7 +10052,7 @@
           <p:cNvPr id="12" name="">
             <a:extLst xmlns:a="http://schemas.openxmlformats.org/drawingml/2006/main">
               <a:ext uri="{FF2B5EF4-FFF2-40B4-BE49-F238E27FC236}">
-                <a16:creationId xmlns:a16="http://schemas.microsoft.com/office/drawing/2014/main" id="{E4DE7F25-A24B-4137-9FEC-6B599C0083DC}"/>
+                <a16:creationId xmlns:a16="http://schemas.microsoft.com/office/drawing/2014/main" id="{D31049AE-E90B-4357-9227-F3F21EF8FF5E}"/>
               </a:ext>
             </a:extLst>
           </p:cNvPr>
@@ -10207,7 +10207,7 @@
     </p:spTree>
     <p:extLst>
       <p:ext uri="{BB962C8B-B14F-4D97-AF65-F5344CB8AC3E}">
-        <p14:creationId xmlns:p14="http://schemas.microsoft.com/office/powerpoint/2010/main" val="1919370726"/>
+        <p14:creationId xmlns:p14="http://schemas.microsoft.com/office/powerpoint/2010/main" val="1242094630"/>
       </p:ext>
     </p:extLst>
   </p:cSld>
@@ -10238,7 +10238,7 @@
           <p:cNvPr id="15" name="">
             <a:extLst xmlns:a="http://schemas.openxmlformats.org/drawingml/2006/main">
               <a:ext uri="{FF2B5EF4-FFF2-40B4-BE49-F238E27FC236}">
-                <a16:creationId xmlns:a16="http://schemas.microsoft.com/office/drawing/2014/main" id="{305961F0-5DF2-4AC6-AF47-8DA069A11DA4}"/>
+                <a16:creationId xmlns:a16="http://schemas.microsoft.com/office/drawing/2014/main" id="{A1DE4218-FB63-435B-85E3-D36C17528CA0}"/>
               </a:ext>
             </a:extLst>
           </p:cNvPr>
@@ -10395,7 +10395,7 @@
           <p:cNvPr id="2" name="">
             <a:extLst xmlns:a="http://schemas.openxmlformats.org/drawingml/2006/main">
               <a:ext uri="{FF2B5EF4-FFF2-40B4-BE49-F238E27FC236}">
-                <a16:creationId xmlns:a16="http://schemas.microsoft.com/office/drawing/2014/main" id="{28A89591-987D-42A3-9281-00BCC024D3AC}"/>
+                <a16:creationId xmlns:a16="http://schemas.microsoft.com/office/drawing/2014/main" id="{E013C939-9CEC-43EB-B492-82985D2D9E72}"/>
               </a:ext>
             </a:extLst>
           </p:cNvPr>
@@ -10552,7 +10552,7 @@
           <p:cNvPr id="3" name="">
             <a:extLst xmlns:a="http://schemas.openxmlformats.org/drawingml/2006/main">
               <a:ext uri="{FF2B5EF4-FFF2-40B4-BE49-F238E27FC236}">
-                <a16:creationId xmlns:a16="http://schemas.microsoft.com/office/drawing/2014/main" id="{A29A3AB7-FA6E-469D-A954-2F37C8E618D9}"/>
+                <a16:creationId xmlns:a16="http://schemas.microsoft.com/office/drawing/2014/main" id="{E5C9DDE7-DD0F-434A-8975-5AEA4025A74C}"/>
               </a:ext>
             </a:extLst>
           </p:cNvPr>
@@ -10585,7 +10585,7 @@
           <p:cNvPr id="4" name="">
             <a:extLst xmlns:a="http://schemas.openxmlformats.org/drawingml/2006/main">
               <a:ext uri="{FF2B5EF4-FFF2-40B4-BE49-F238E27FC236}">
-                <a16:creationId xmlns:a16="http://schemas.microsoft.com/office/drawing/2014/main" id="{D718B634-9495-480D-A613-FD85660F0CA1}"/>
+                <a16:creationId xmlns:a16="http://schemas.microsoft.com/office/drawing/2014/main" id="{08D52B16-BECB-48A7-8E81-DC0B76DA6493}"/>
               </a:ext>
             </a:extLst>
           </p:cNvPr>
@@ -10732,7 +10732,7 @@
                 <a:ea typeface="Aptos Display"/>
                 <a:cs typeface="Aptos Display"/>
               </a:rPr>
-              <a:t>34</a:t>
+              <a:t>456</a:t>
             </a:r>
           </a:p>
         </p:txBody>
@@ -10742,7 +10742,7 @@
           <p:cNvPr id="5" name="">
             <a:extLst xmlns:a="http://schemas.openxmlformats.org/drawingml/2006/main">
               <a:ext uri="{FF2B5EF4-FFF2-40B4-BE49-F238E27FC236}">
-                <a16:creationId xmlns:a16="http://schemas.microsoft.com/office/drawing/2014/main" id="{EF8D8CE1-6DF4-4E32-9507-54C3E417B8F1}"/>
+                <a16:creationId xmlns:a16="http://schemas.microsoft.com/office/drawing/2014/main" id="{C1A8A01B-CEA2-4ACF-A60B-90DE6C2686D2}"/>
               </a:ext>
             </a:extLst>
           </p:cNvPr>
@@ -10889,7 +10889,7 @@
                 <a:ea typeface="Aptos"/>
                 <a:cs typeface="Aptos"/>
               </a:rPr>
-              <a:t>of 456 checked</a:t>
+              <a:t>planned packages</a:t>
             </a:r>
           </a:p>
         </p:txBody>
@@ -10899,7 +10899,7 @@
           <p:cNvPr id="6" name="">
             <a:extLst xmlns:a="http://schemas.openxmlformats.org/drawingml/2006/main">
               <a:ext uri="{FF2B5EF4-FFF2-40B4-BE49-F238E27FC236}">
-                <a16:creationId xmlns:a16="http://schemas.microsoft.com/office/drawing/2014/main" id="{67026A0B-B4E7-4805-8381-55C28C662BF7}"/>
+                <a16:creationId xmlns:a16="http://schemas.microsoft.com/office/drawing/2014/main" id="{CF2347AD-AB09-4BEB-9983-146BE82E72D0}"/>
               </a:ext>
             </a:extLst>
           </p:cNvPr>
@@ -11046,7 +11046,7 @@
                 <a:ea typeface="Aptos Display"/>
                 <a:cs typeface="Aptos Display"/>
               </a:rPr>
-              <a:t>30</a:t>
+              <a:t>0</a:t>
             </a:r>
           </a:p>
         </p:txBody>
@@ -11056,7 +11056,7 @@
           <p:cNvPr id="7" name="">
             <a:extLst xmlns:a="http://schemas.openxmlformats.org/drawingml/2006/main">
               <a:ext uri="{FF2B5EF4-FFF2-40B4-BE49-F238E27FC236}">
-                <a16:creationId xmlns:a16="http://schemas.microsoft.com/office/drawing/2014/main" id="{568DF811-EA8F-4C46-80DD-5B8C0A0023CD}"/>
+                <a16:creationId xmlns:a16="http://schemas.microsoft.com/office/drawing/2014/main" id="{FD7A1A00-67BA-43B4-8485-47464E2D7A04}"/>
               </a:ext>
             </a:extLst>
           </p:cNvPr>
@@ -11203,7 +11203,7 @@
                 <a:ea typeface="Aptos"/>
                 <a:cs typeface="Aptos"/>
               </a:rPr>
-              <a:t>compatible</a:t>
+              <a:t>new model runs</a:t>
             </a:r>
           </a:p>
         </p:txBody>
@@ -11213,7 +11213,7 @@
           <p:cNvPr id="8" name="">
             <a:extLst xmlns:a="http://schemas.openxmlformats.org/drawingml/2006/main">
               <a:ext uri="{FF2B5EF4-FFF2-40B4-BE49-F238E27FC236}">
-                <a16:creationId xmlns:a16="http://schemas.microsoft.com/office/drawing/2014/main" id="{53452C5E-C103-4C45-B894-5FE175290D4C}"/>
+                <a16:creationId xmlns:a16="http://schemas.microsoft.com/office/drawing/2014/main" id="{4CEF00A1-C771-4BCB-BBF9-99265B8A5C71}"/>
               </a:ext>
             </a:extLst>
           </p:cNvPr>
@@ -11360,7 +11360,7 @@
                 <a:ea typeface="Aptos Display"/>
                 <a:cs typeface="Aptos Display"/>
               </a:rPr>
-              <a:t>4</a:t>
+              <a:t>35</a:t>
             </a:r>
           </a:p>
         </p:txBody>
@@ -11370,7 +11370,7 @@
           <p:cNvPr id="9" name="">
             <a:extLst xmlns:a="http://schemas.openxmlformats.org/drawingml/2006/main">
               <a:ext uri="{FF2B5EF4-FFF2-40B4-BE49-F238E27FC236}">
-                <a16:creationId xmlns:a16="http://schemas.microsoft.com/office/drawing/2014/main" id="{A7450E37-1130-48E3-B7DD-E5B9B601A75A}"/>
+                <a16:creationId xmlns:a16="http://schemas.microsoft.com/office/drawing/2014/main" id="{BDA7319C-56CD-4ED5-8042-751FD80BE82C}"/>
               </a:ext>
             </a:extLst>
           </p:cNvPr>
@@ -11517,7 +11517,7 @@
                 <a:ea typeface="Aptos"/>
                 <a:cs typeface="Aptos"/>
               </a:rPr>
-              <a:t>incompatible</a:t>
+              <a:t>holdout tasks sealed</a:t>
             </a:r>
           </a:p>
         </p:txBody>
@@ -11527,7 +11527,7 @@
           <p:cNvPr id="10" name="">
             <a:extLst xmlns:a="http://schemas.openxmlformats.org/drawingml/2006/main">
               <a:ext uri="{FF2B5EF4-FFF2-40B4-BE49-F238E27FC236}">
-                <a16:creationId xmlns:a16="http://schemas.microsoft.com/office/drawing/2014/main" id="{33A1EFE8-22EB-4EC5-BB28-67865CA1D807}"/>
+                <a16:creationId xmlns:a16="http://schemas.microsoft.com/office/drawing/2014/main" id="{195BCA54-16C0-453D-9159-D3BA93BE8A23}"/>
               </a:ext>
             </a:extLst>
           </p:cNvPr>
@@ -11560,7 +11560,7 @@
           <p:cNvPr id="11" name="">
             <a:extLst xmlns:a="http://schemas.openxmlformats.org/drawingml/2006/main">
               <a:ext uri="{FF2B5EF4-FFF2-40B4-BE49-F238E27FC236}">
-                <a16:creationId xmlns:a16="http://schemas.microsoft.com/office/drawing/2014/main" id="{5BA745EC-7949-4FF9-BC70-25E31D2C67E0}"/>
+                <a16:creationId xmlns:a16="http://schemas.microsoft.com/office/drawing/2014/main" id="{36B5FFCF-5360-4982-B570-12B26670FC03}"/>
               </a:ext>
             </a:extLst>
           </p:cNvPr>
@@ -11707,7 +11707,7 @@
                 <a:ea typeface="Aptos Display"/>
                 <a:cs typeface="Aptos Display"/>
               </a:rPr>
-              <a:t>At least one incompatibility already guarantees a stop before qualification, training, or model evaluation. The full 456-task matrix must finish before the terminal package is sealed.</a:t>
+              <a:t>The compatibility screen is still running. Incompatibilities already recorded prevent new training or model evaluation. The full matrix is not yet a terminal result.</a:t>
             </a:r>
           </a:p>
         </p:txBody>
@@ -11717,7 +11717,7 @@
           <p:cNvPr id="12" name="">
             <a:extLst xmlns:a="http://schemas.openxmlformats.org/drawingml/2006/main">
               <a:ext uri="{FF2B5EF4-FFF2-40B4-BE49-F238E27FC236}">
-                <a16:creationId xmlns:a16="http://schemas.microsoft.com/office/drawing/2014/main" id="{DAD57BBD-4DEE-48C9-A29A-290FAF128744}"/>
+                <a16:creationId xmlns:a16="http://schemas.microsoft.com/office/drawing/2014/main" id="{4B16DE82-736A-469B-B0C0-138FC8A40E99}"/>
               </a:ext>
             </a:extLst>
           </p:cNvPr>
@@ -11864,7 +11864,7 @@
                 <a:ea typeface="Aptos"/>
                 <a:cs typeface="Aptos"/>
               </a:rPr>
-              <a:t>The 35-task final holdout remains sealed. This preflight measures evaluator compatibility, not model quality.</a:t>
+              <a:t>The public 35-task final holdout remains operationally sealed and unconsumed. This preflight measures evaluator compatibility, not model quality.</a:t>
             </a:r>
           </a:p>
         </p:txBody>
@@ -11874,7 +11874,7 @@
           <p:cNvPr id="13" name="">
             <a:extLst xmlns:a="http://schemas.openxmlformats.org/drawingml/2006/main">
               <a:ext uri="{FF2B5EF4-FFF2-40B4-BE49-F238E27FC236}">
-                <a16:creationId xmlns:a16="http://schemas.microsoft.com/office/drawing/2014/main" id="{95745407-7A47-4507-AD7D-5BE37713E163}"/>
+                <a16:creationId xmlns:a16="http://schemas.microsoft.com/office/drawing/2014/main" id="{2A0FA241-CAC4-4ADE-84D8-8EBBF9C7CE0E}"/>
               </a:ext>
             </a:extLst>
           </p:cNvPr>
@@ -12031,7 +12031,7 @@
           <p:cNvPr id="14" name="">
             <a:extLst xmlns:a="http://schemas.openxmlformats.org/drawingml/2006/main">
               <a:ext uri="{FF2B5EF4-FFF2-40B4-BE49-F238E27FC236}">
-                <a16:creationId xmlns:a16="http://schemas.microsoft.com/office/drawing/2014/main" id="{A668EBB8-EC15-40AB-B314-2F3DD6DC2364}"/>
+                <a16:creationId xmlns:a16="http://schemas.microsoft.com/office/drawing/2014/main" id="{7ECF5D9E-FE42-4D06-B706-86483EF673D1}"/>
               </a:ext>
             </a:extLst>
           </p:cNvPr>
@@ -12186,7 +12186,7 @@
     </p:spTree>
     <p:extLst>
       <p:ext uri="{BB962C8B-B14F-4D97-AF65-F5344CB8AC3E}">
-        <p14:creationId xmlns:p14="http://schemas.microsoft.com/office/powerpoint/2010/main" val="1033256955"/>
+        <p14:creationId xmlns:p14="http://schemas.microsoft.com/office/powerpoint/2010/main" val="1539469604"/>
       </p:ext>
     </p:extLst>
   </p:cSld>
@@ -12214,10 +12214,10 @@
       </p:grpSpPr>
       <p:sp>
         <p:nvSpPr>
-          <p:cNvPr id="16" name="">
+          <p:cNvPr id="17" name="">
             <a:extLst xmlns:a="http://schemas.openxmlformats.org/drawingml/2006/main">
               <a:ext uri="{FF2B5EF4-FFF2-40B4-BE49-F238E27FC236}">
-                <a16:creationId xmlns:a16="http://schemas.microsoft.com/office/drawing/2014/main" id="{8E50FCFA-BF78-4475-8E9F-848CE7723F7F}"/>
+                <a16:creationId xmlns:a16="http://schemas.microsoft.com/office/drawing/2014/main" id="{D7B85EED-157E-4485-BEE5-C173B5027981}"/>
               </a:ext>
             </a:extLst>
           </p:cNvPr>
@@ -12374,7 +12374,7 @@
           <p:cNvPr id="2" name="">
             <a:extLst xmlns:a="http://schemas.openxmlformats.org/drawingml/2006/main">
               <a:ext uri="{FF2B5EF4-FFF2-40B4-BE49-F238E27FC236}">
-                <a16:creationId xmlns:a16="http://schemas.microsoft.com/office/drawing/2014/main" id="{A953F04F-44B6-448B-9514-476C7F71582F}"/>
+                <a16:creationId xmlns:a16="http://schemas.microsoft.com/office/drawing/2014/main" id="{E77316B2-ACD8-45F2-937A-14EFB816E5FA}"/>
               </a:ext>
             </a:extLst>
           </p:cNvPr>
@@ -12531,7 +12531,7 @@
           <p:cNvPr id="3" name="">
             <a:extLst xmlns:a="http://schemas.openxmlformats.org/drawingml/2006/main">
               <a:ext uri="{FF2B5EF4-FFF2-40B4-BE49-F238E27FC236}">
-                <a16:creationId xmlns:a16="http://schemas.microsoft.com/office/drawing/2014/main" id="{A99F669D-6F5B-41DB-A94C-AAE1D44FC4CF}"/>
+                <a16:creationId xmlns:a16="http://schemas.microsoft.com/office/drawing/2014/main" id="{00D9BE37-8815-44F2-A3FB-030EECC026D5}"/>
               </a:ext>
             </a:extLst>
           </p:cNvPr>
@@ -12564,7 +12564,7 @@
           <p:cNvPr id="4" name="">
             <a:extLst xmlns:a="http://schemas.openxmlformats.org/drawingml/2006/main">
               <a:ext uri="{FF2B5EF4-FFF2-40B4-BE49-F238E27FC236}">
-                <a16:creationId xmlns:a16="http://schemas.microsoft.com/office/drawing/2014/main" id="{A8A0A1BA-53DE-4967-844D-A2923FD9C9C4}"/>
+                <a16:creationId xmlns:a16="http://schemas.microsoft.com/office/drawing/2014/main" id="{CDDEF5CD-8AF2-4893-9D99-2682BF4757C9}"/>
               </a:ext>
             </a:extLst>
           </p:cNvPr>
@@ -12721,7 +12721,7 @@
           <p:cNvPr id="5" name="">
             <a:extLst xmlns:a="http://schemas.openxmlformats.org/drawingml/2006/main">
               <a:ext uri="{FF2B5EF4-FFF2-40B4-BE49-F238E27FC236}">
-                <a16:creationId xmlns:a16="http://schemas.microsoft.com/office/drawing/2014/main" id="{11C66DD7-69B8-4BDA-A493-D9157D9AD743}"/>
+                <a16:creationId xmlns:a16="http://schemas.microsoft.com/office/drawing/2014/main" id="{CE338345-6952-44F8-89BA-3A025FD24053}"/>
               </a:ext>
             </a:extLst>
           </p:cNvPr>
@@ -12878,7 +12878,7 @@
           <p:cNvPr id="6" name="">
             <a:extLst xmlns:a="http://schemas.openxmlformats.org/drawingml/2006/main">
               <a:ext uri="{FF2B5EF4-FFF2-40B4-BE49-F238E27FC236}">
-                <a16:creationId xmlns:a16="http://schemas.microsoft.com/office/drawing/2014/main" id="{2F97C364-1C3B-4A62-B1E0-C7F605E818FC}"/>
+                <a16:creationId xmlns:a16="http://schemas.microsoft.com/office/drawing/2014/main" id="{A4750F86-0FAD-481B-8E0A-1998DE3ACBA2}"/>
               </a:ext>
             </a:extLst>
           </p:cNvPr>
@@ -13035,7 +13035,7 @@
           <p:cNvPr id="7" name="">
             <a:extLst xmlns:a="http://schemas.openxmlformats.org/drawingml/2006/main">
               <a:ext uri="{FF2B5EF4-FFF2-40B4-BE49-F238E27FC236}">
-                <a16:creationId xmlns:a16="http://schemas.microsoft.com/office/drawing/2014/main" id="{BA9CB420-DE21-4637-A111-4D09A9F6C3BC}"/>
+                <a16:creationId xmlns:a16="http://schemas.microsoft.com/office/drawing/2014/main" id="{F7DAB5A4-9C6D-4DA3-801F-9EE4D58DD3F0}"/>
               </a:ext>
             </a:extLst>
           </p:cNvPr>
@@ -13192,7 +13192,7 @@
           <p:cNvPr id="8" name="">
             <a:extLst xmlns:a="http://schemas.openxmlformats.org/drawingml/2006/main">
               <a:ext uri="{FF2B5EF4-FFF2-40B4-BE49-F238E27FC236}">
-                <a16:creationId xmlns:a16="http://schemas.microsoft.com/office/drawing/2014/main" id="{FD1223DA-0ADC-4B87-B662-3B46E483A270}"/>
+                <a16:creationId xmlns:a16="http://schemas.microsoft.com/office/drawing/2014/main" id="{41188A3E-455C-4512-9F00-F3C7668148E0}"/>
               </a:ext>
             </a:extLst>
           </p:cNvPr>
@@ -13349,7 +13349,7 @@
           <p:cNvPr id="9" name="">
             <a:extLst xmlns:a="http://schemas.openxmlformats.org/drawingml/2006/main">
               <a:ext uri="{FF2B5EF4-FFF2-40B4-BE49-F238E27FC236}">
-                <a16:creationId xmlns:a16="http://schemas.microsoft.com/office/drawing/2014/main" id="{0A0DAAE3-48D9-49C1-A312-BE1836D59A22}"/>
+                <a16:creationId xmlns:a16="http://schemas.microsoft.com/office/drawing/2014/main" id="{08295D5F-CCA8-4DA3-BC86-31AA32578C28}"/>
               </a:ext>
             </a:extLst>
           </p:cNvPr>
@@ -13506,7 +13506,7 @@
           <p:cNvPr id="10" name="">
             <a:extLst xmlns:a="http://schemas.openxmlformats.org/drawingml/2006/main">
               <a:ext uri="{FF2B5EF4-FFF2-40B4-BE49-F238E27FC236}">
-                <a16:creationId xmlns:a16="http://schemas.microsoft.com/office/drawing/2014/main" id="{164C1A7E-355A-458A-A0A6-202FA7C7E3AA}"/>
+                <a16:creationId xmlns:a16="http://schemas.microsoft.com/office/drawing/2014/main" id="{22C4ABDD-0056-4487-BD9E-26BB1B512683}"/>
               </a:ext>
             </a:extLst>
           </p:cNvPr>
@@ -13516,7 +13516,38 @@
           <p:nvPr/>
         </p:nvPicPr>
         <p:blipFill>
-          <a:blip xmlns:r="http://schemas.openxmlformats.org/officeDocument/2006/relationships" xmlns:a="http://schemas.openxmlformats.org/drawingml/2006/main" r:embed="R730cfea1d6a14b42"/>
+          <a:blip xmlns:r="http://schemas.openxmlformats.org/officeDocument/2006/relationships" xmlns:a="http://schemas.openxmlformats.org/drawingml/2006/main" r:embed="Raec655f4845a4e4f"/>
+          <a:srcRect xmlns:a="http://schemas.openxmlformats.org/drawingml/2006/main" l="32479" t="0" r="32479" b="0"/>
+          <a:stretch xmlns:a="http://schemas.openxmlformats.org/drawingml/2006/main">
+            <a:fillRect l="0" t="0" r="0" b="0"/>
+          </a:stretch>
+        </p:blipFill>
+        <p:spPr>
+          <a:xfrm xmlns:a="http://schemas.openxmlformats.org/drawingml/2006/main">
+            <a:off x="8382000" y="1066800"/>
+            <a:ext cx="3143250" cy="5048250"/>
+          </a:xfrm>
+          <a:prstGeom xmlns:a="http://schemas.openxmlformats.org/drawingml/2006/main" prst="rect">
+            <a:avLst/>
+          </a:prstGeom>
+        </p:spPr>
+      </p:pic>
+      <p:pic>
+        <p:nvPicPr>
+          <p:cNvPr id="11" name="">
+            <a:extLst xmlns:a="http://schemas.openxmlformats.org/drawingml/2006/main">
+              <a:ext uri="{FF2B5EF4-FFF2-40B4-BE49-F238E27FC236}">
+                <a16:creationId xmlns:a16="http://schemas.microsoft.com/office/drawing/2014/main" id="{C2604EE1-43B4-4696-A2A3-231E677DC938}"/>
+              </a:ext>
+            </a:extLst>
+          </p:cNvPr>
+          <p:cNvPicPr>
+            <a:picLocks xmlns:a="http://schemas.openxmlformats.org/drawingml/2006/main" noChangeAspect="1"/>
+          </p:cNvPicPr>
+          <p:nvPr/>
+        </p:nvPicPr>
+        <p:blipFill>
+          <a:blip xmlns:r="http://schemas.openxmlformats.org/officeDocument/2006/relationships" xmlns:a="http://schemas.openxmlformats.org/drawingml/2006/main" r:embed="R28a007d0950d4302"/>
           <a:stretch xmlns:a="http://schemas.openxmlformats.org/drawingml/2006/main"/>
         </p:blipFill>
         <p:spPr>
@@ -13531,10 +13562,10 @@
       </p:pic>
       <p:pic>
         <p:nvPicPr>
-          <p:cNvPr id="11" name="">
+          <p:cNvPr id="12" name="">
             <a:extLst xmlns:a="http://schemas.openxmlformats.org/drawingml/2006/main">
               <a:ext uri="{FF2B5EF4-FFF2-40B4-BE49-F238E27FC236}">
-                <a16:creationId xmlns:a16="http://schemas.microsoft.com/office/drawing/2014/main" id="{90FE6EFF-040D-45AF-A3DC-EBB555508BBF}"/>
+                <a16:creationId xmlns:a16="http://schemas.microsoft.com/office/drawing/2014/main" id="{A23843B8-B8E8-4F3A-9C4E-67ABA66C2D1D}"/>
               </a:ext>
             </a:extLst>
           </p:cNvPr>
@@ -13544,7 +13575,7 @@
           <p:nvPr/>
         </p:nvPicPr>
         <p:blipFill>
-          <a:blip xmlns:r="http://schemas.openxmlformats.org/officeDocument/2006/relationships" xmlns:a="http://schemas.openxmlformats.org/drawingml/2006/main" r:embed="Rcd692d95defe448f"/>
+          <a:blip xmlns:r="http://schemas.openxmlformats.org/officeDocument/2006/relationships" xmlns:a="http://schemas.openxmlformats.org/drawingml/2006/main" r:embed="R9d44cdfbb4ed408c"/>
           <a:stretch xmlns:a="http://schemas.openxmlformats.org/drawingml/2006/main"/>
         </p:blipFill>
         <p:spPr>
@@ -13559,10 +13590,10 @@
       </p:pic>
       <p:sp>
         <p:nvSpPr>
-          <p:cNvPr id="12" name="">
+          <p:cNvPr id="13" name="">
             <a:extLst xmlns:a="http://schemas.openxmlformats.org/drawingml/2006/main">
               <a:ext uri="{FF2B5EF4-FFF2-40B4-BE49-F238E27FC236}">
-                <a16:creationId xmlns:a16="http://schemas.microsoft.com/office/drawing/2014/main" id="{B9469648-BEAE-470C-ABF9-F82EC230BECB}"/>
+                <a16:creationId xmlns:a16="http://schemas.microsoft.com/office/drawing/2014/main" id="{9542B711-105B-405A-8386-5646956A37BF}"/>
               </a:ext>
             </a:extLst>
           </p:cNvPr>
@@ -13592,10 +13623,10 @@
       </p:sp>
       <p:sp>
         <p:nvSpPr>
-          <p:cNvPr id="13" name="">
+          <p:cNvPr id="14" name="">
             <a:extLst xmlns:a="http://schemas.openxmlformats.org/drawingml/2006/main">
               <a:ext uri="{FF2B5EF4-FFF2-40B4-BE49-F238E27FC236}">
-                <a16:creationId xmlns:a16="http://schemas.microsoft.com/office/drawing/2014/main" id="{2C956444-3030-46EB-BB88-1CCE0D0123C0}"/>
+                <a16:creationId xmlns:a16="http://schemas.microsoft.com/office/drawing/2014/main" id="{AE8EF024-3C0A-4E06-A068-CCB9F5A87D60}"/>
               </a:ext>
             </a:extLst>
           </p:cNvPr>
@@ -13624,7 +13655,7 @@
             <a:defPPr algn="ctr">
               <a:defRPr sz="1425" b="1">
                 <a:solidFill>
-                  <a:srgbClr val="08101E"/>
+                  <a:srgbClr val="FFFFFF"/>
                 </a:solidFill>
                 <a:latin typeface="Aptos"/>
                 <a:ea typeface="Aptos"/>
@@ -13634,7 +13665,7 @@
             <a:lvl1pPr algn="ctr">
               <a:defRPr sz="1425" b="1">
                 <a:solidFill>
-                  <a:srgbClr val="08101E"/>
+                  <a:srgbClr val="FFFFFF"/>
                 </a:solidFill>
                 <a:latin typeface="Aptos"/>
                 <a:ea typeface="Aptos"/>
@@ -13644,7 +13675,7 @@
             <a:lvl2pPr algn="ctr">
               <a:defRPr sz="1425" b="1">
                 <a:solidFill>
-                  <a:srgbClr val="08101E"/>
+                  <a:srgbClr val="FFFFFF"/>
                 </a:solidFill>
                 <a:latin typeface="Aptos"/>
                 <a:ea typeface="Aptos"/>
@@ -13654,7 +13685,7 @@
             <a:lvl3pPr algn="ctr">
               <a:defRPr sz="1425" b="1">
                 <a:solidFill>
-                  <a:srgbClr val="08101E"/>
+                  <a:srgbClr val="FFFFFF"/>
                 </a:solidFill>
                 <a:latin typeface="Aptos"/>
                 <a:ea typeface="Aptos"/>
@@ -13664,7 +13695,7 @@
             <a:lvl4pPr algn="ctr">
               <a:defRPr sz="1425" b="1">
                 <a:solidFill>
-                  <a:srgbClr val="08101E"/>
+                  <a:srgbClr val="FFFFFF"/>
                 </a:solidFill>
                 <a:latin typeface="Aptos"/>
                 <a:ea typeface="Aptos"/>
@@ -13674,7 +13705,7 @@
             <a:lvl5pPr algn="ctr">
               <a:defRPr sz="1425" b="1">
                 <a:solidFill>
-                  <a:srgbClr val="08101E"/>
+                  <a:srgbClr val="FFFFFF"/>
                 </a:solidFill>
                 <a:latin typeface="Aptos"/>
                 <a:ea typeface="Aptos"/>
@@ -13684,7 +13715,7 @@
             <a:lvl6pPr algn="ctr">
               <a:defRPr sz="1425" b="1">
                 <a:solidFill>
-                  <a:srgbClr val="08101E"/>
+                  <a:srgbClr val="FFFFFF"/>
                 </a:solidFill>
                 <a:latin typeface="Aptos"/>
                 <a:ea typeface="Aptos"/>
@@ -13694,7 +13725,7 @@
             <a:lvl7pPr algn="ctr">
               <a:defRPr sz="1425" b="1">
                 <a:solidFill>
-                  <a:srgbClr val="08101E"/>
+                  <a:srgbClr val="FFFFFF"/>
                 </a:solidFill>
                 <a:latin typeface="Aptos"/>
                 <a:ea typeface="Aptos"/>
@@ -13704,7 +13735,7 @@
             <a:lvl8pPr algn="ctr">
               <a:defRPr sz="1425" b="1">
                 <a:solidFill>
-                  <a:srgbClr val="08101E"/>
+                  <a:srgbClr val="FFFFFF"/>
                 </a:solidFill>
                 <a:latin typeface="Aptos"/>
                 <a:ea typeface="Aptos"/>
@@ -13714,7 +13745,7 @@
             <a:lvl9pPr algn="ctr">
               <a:defRPr sz="1425" b="1">
                 <a:solidFill>
-                  <a:srgbClr val="08101E"/>
+                  <a:srgbClr val="FFFFFF"/>
                 </a:solidFill>
                 <a:latin typeface="Aptos"/>
                 <a:ea typeface="Aptos"/>
@@ -13726,7 +13757,7 @@
             <a:pPr algn="ctr">
               <a:defRPr sz="1425" b="1">
                 <a:solidFill>
-                  <a:srgbClr val="08101E"/>
+                  <a:srgbClr val="FFFFFF"/>
                 </a:solidFill>
                 <a:latin typeface="Aptos"/>
                 <a:ea typeface="Aptos"/>
@@ -13736,7 +13767,7 @@
             <a:r>
               <a:rPr sz="1425" b="1">
                 <a:solidFill>
-                  <a:srgbClr val="08101E"/>
+                  <a:srgbClr val="FFFFFF"/>
                 </a:solidFill>
                 <a:latin typeface="Aptos"/>
                 <a:ea typeface="Aptos"/>
@@ -13749,10 +13780,10 @@
       </p:sp>
       <p:sp>
         <p:nvSpPr>
-          <p:cNvPr id="14" name="">
+          <p:cNvPr id="15" name="">
             <a:extLst xmlns:a="http://schemas.openxmlformats.org/drawingml/2006/main">
               <a:ext uri="{FF2B5EF4-FFF2-40B4-BE49-F238E27FC236}">
-                <a16:creationId xmlns:a16="http://schemas.microsoft.com/office/drawing/2014/main" id="{7DD31FE0-9FDB-4ABF-9EFE-FC9CFA882F65}"/>
+                <a16:creationId xmlns:a16="http://schemas.microsoft.com/office/drawing/2014/main" id="{A93CB527-92DD-4AAF-B895-8F199ABD09DE}"/>
               </a:ext>
             </a:extLst>
           </p:cNvPr>
@@ -13906,10 +13937,10 @@
       </p:sp>
       <p:sp>
         <p:nvSpPr>
-          <p:cNvPr id="15" name="">
+          <p:cNvPr id="16" name="">
             <a:extLst xmlns:a="http://schemas.openxmlformats.org/drawingml/2006/main">
               <a:ext uri="{FF2B5EF4-FFF2-40B4-BE49-F238E27FC236}">
-                <a16:creationId xmlns:a16="http://schemas.microsoft.com/office/drawing/2014/main" id="{F41EA4F9-AB55-422E-9ADD-93727F2F3C49}"/>
+                <a16:creationId xmlns:a16="http://schemas.microsoft.com/office/drawing/2014/main" id="{EB9E4162-7BCD-474B-8F28-533C07D57155}"/>
               </a:ext>
             </a:extLst>
           </p:cNvPr>
@@ -14064,7 +14095,7 @@
     </p:spTree>
     <p:extLst>
       <p:ext uri="{BB962C8B-B14F-4D97-AF65-F5344CB8AC3E}">
-        <p14:creationId xmlns:p14="http://schemas.microsoft.com/office/powerpoint/2010/main" val="815137790"/>
+        <p14:creationId xmlns:p14="http://schemas.microsoft.com/office/powerpoint/2010/main" val="598657892"/>
       </p:ext>
     </p:extLst>
   </p:cSld>

</xml_diff>

<commit_message>
Publish terminal R3 compatibility findings and final demo
Agent-Vendor: Codex
</commit_message>
<xml_diff>
--- a/presentation/final-findings/mini-gibson-final-findings.pptx
+++ b/presentation/final-findings/mini-gibson-final-findings.pptx
@@ -2,18 +2,18 @@
 <file path=ppt/presentation.xml><?xml version="1.0" encoding="utf-8"?>
 <p:presentation xmlns:p="http://schemas.openxmlformats.org/presentationml/2006/main">
   <p:sldMasterIdLst>
-    <p:sldMasterId xmlns:r="http://schemas.openxmlformats.org/officeDocument/2006/relationships" id="2147483648" r:id="Rd92df3121d94483d"/>
+    <p:sldMasterId xmlns:r="http://schemas.openxmlformats.org/officeDocument/2006/relationships" id="2147483648" r:id="R228e00e7d04d4b82"/>
   </p:sldMasterIdLst>
   <p:notesMasterIdLst>
-    <p:notesMasterId xmlns:r="http://schemas.openxmlformats.org/officeDocument/2006/relationships" r:id="R04424d0d45e54960"/>
+    <p:notesMasterId xmlns:r="http://schemas.openxmlformats.org/officeDocument/2006/relationships" r:id="R335f6d91bb6d4037"/>
   </p:notesMasterIdLst>
   <p:sldIdLst>
-    <p:sldId xmlns:r="http://schemas.openxmlformats.org/officeDocument/2006/relationships" id="256" r:id="R0087295a337c410c"/>
-    <p:sldId xmlns:r="http://schemas.openxmlformats.org/officeDocument/2006/relationships" id="257" r:id="Rd14cb8d24efb4352"/>
-    <p:sldId xmlns:r="http://schemas.openxmlformats.org/officeDocument/2006/relationships" id="258" r:id="R958eb2264ada438b"/>
-    <p:sldId xmlns:r="http://schemas.openxmlformats.org/officeDocument/2006/relationships" id="259" r:id="Rb22d64c770754630"/>
-    <p:sldId xmlns:r="http://schemas.openxmlformats.org/officeDocument/2006/relationships" id="260" r:id="R2790cfa1a22c46a4"/>
-    <p:sldId xmlns:r="http://schemas.openxmlformats.org/officeDocument/2006/relationships" id="261" r:id="R08c86a6463014750"/>
+    <p:sldId xmlns:r="http://schemas.openxmlformats.org/officeDocument/2006/relationships" id="256" r:id="R28229b615e8e4112"/>
+    <p:sldId xmlns:r="http://schemas.openxmlformats.org/officeDocument/2006/relationships" id="257" r:id="R9766d6578311410e"/>
+    <p:sldId xmlns:r="http://schemas.openxmlformats.org/officeDocument/2006/relationships" id="258" r:id="R3adbb34cfcea4278"/>
+    <p:sldId xmlns:r="http://schemas.openxmlformats.org/officeDocument/2006/relationships" id="259" r:id="R65b136299f1d4c7e"/>
+    <p:sldId xmlns:r="http://schemas.openxmlformats.org/officeDocument/2006/relationships" id="260" r:id="R4eaf2ec2aa6d4899"/>
+    <p:sldId xmlns:r="http://schemas.openxmlformats.org/officeDocument/2006/relationships" id="261" r:id="Rf55cb5d7e5f347c8"/>
   </p:sldIdLst>
   <p:sldSz cx="12192000" cy="6858000"/>
   <p:notesSz cx="6858000" cy="9144000"/>
@@ -727,7 +727,7 @@
           <a:lstStyle xmlns:a="http://schemas.openxmlformats.org/drawingml/2006/main"/>
           <a:p xmlns:a="http://schemas.openxmlformats.org/drawingml/2006/main">
             <a:r>
-              <a:t>Interim submission: the frozen plan has 456 task packages, the 35-task final holdout is sealed, and the active compatibility preflight has produced no new model result. The matrix is not terminal; live compatibility counts are intentionally omitted. Source: docs/evidence/mini-gibson-successor-2026-10-18/PROTOCOL.md and the public R3 progress note.</a:t>
+              <a:t>Source: docs/evidence/mini-gibson-successor-2026-10-18/. Verified terminal values are 456/456 checked, 406 compatible, 50 incompatible. This compatibility preflight ran no models, agents, parsers, tests, or formal comparisons.</a:t>
             </a:r>
           </a:p>
         </p:txBody>
@@ -844,7 +844,7 @@
           <p:cNvPr id="3" name="Title">
             <a:extLst xmlns:a="http://schemas.openxmlformats.org/drawingml/2006/main">
               <a:ext uri="{FF2B5EF4-FFF2-40B4-BE49-F238E27FC236}">
-                <a16:creationId xmlns:a16="http://schemas.microsoft.com/office/drawing/2014/main" id="{CEA52C54-FF71-4B9A-8ED4-7DBDCDA9922F}"/>
+                <a16:creationId xmlns:a16="http://schemas.microsoft.com/office/drawing/2014/main" id="{0CECD57B-461E-4036-A885-5078CAAEAEF0}"/>
               </a:ext>
             </a:extLst>
           </p:cNvPr>
@@ -1073,7 +1073,7 @@
           <p:cNvPr id="2" name="Subtitle">
             <a:extLst xmlns:a="http://schemas.openxmlformats.org/drawingml/2006/main">
               <a:ext uri="{FF2B5EF4-FFF2-40B4-BE49-F238E27FC236}">
-                <a16:creationId xmlns:a16="http://schemas.microsoft.com/office/drawing/2014/main" id="{29011579-E047-47A2-93A9-50E88E02C75D}"/>
+                <a16:creationId xmlns:a16="http://schemas.microsoft.com/office/drawing/2014/main" id="{D59789C0-02F5-4784-9140-6E0D9A54EAE8}"/>
               </a:ext>
             </a:extLst>
           </p:cNvPr>
@@ -1319,7 +1319,7 @@
           <p:cNvPr id="2" name="Section title">
             <a:extLst xmlns:a="http://schemas.openxmlformats.org/drawingml/2006/main">
               <a:ext uri="{FF2B5EF4-FFF2-40B4-BE49-F238E27FC236}">
-                <a16:creationId xmlns:a16="http://schemas.microsoft.com/office/drawing/2014/main" id="{E2E25C63-6FF2-4DE6-B7BB-E95F55E1798E}"/>
+                <a16:creationId xmlns:a16="http://schemas.microsoft.com/office/drawing/2014/main" id="{01259C17-048C-420F-B1A0-03E10C179408}"/>
               </a:ext>
             </a:extLst>
           </p:cNvPr>
@@ -1565,7 +1565,7 @@
           <p:cNvPr id="3" name="Title">
             <a:extLst xmlns:a="http://schemas.openxmlformats.org/drawingml/2006/main">
               <a:ext uri="{FF2B5EF4-FFF2-40B4-BE49-F238E27FC236}">
-                <a16:creationId xmlns:a16="http://schemas.microsoft.com/office/drawing/2014/main" id="{0498A94E-C513-44E0-8091-304BC5C2E18A}"/>
+                <a16:creationId xmlns:a16="http://schemas.microsoft.com/office/drawing/2014/main" id="{F1E791F1-32AB-4E77-8359-519091BA50D0}"/>
               </a:ext>
             </a:extLst>
           </p:cNvPr>
@@ -1794,7 +1794,7 @@
           <p:cNvPr id="2" name="Body">
             <a:extLst xmlns:a="http://schemas.openxmlformats.org/drawingml/2006/main">
               <a:ext uri="{FF2B5EF4-FFF2-40B4-BE49-F238E27FC236}">
-                <a16:creationId xmlns:a16="http://schemas.microsoft.com/office/drawing/2014/main" id="{8885E0DA-51F9-4A61-BA93-AE6A83910D3F}"/>
+                <a16:creationId xmlns:a16="http://schemas.microsoft.com/office/drawing/2014/main" id="{2D986528-63B7-4611-B7FB-E446A6A5FEAC}"/>
               </a:ext>
             </a:extLst>
           </p:cNvPr>
@@ -2040,7 +2040,7 @@
           <p:cNvPr id="4" name="Title">
             <a:extLst xmlns:a="http://schemas.openxmlformats.org/drawingml/2006/main">
               <a:ext uri="{FF2B5EF4-FFF2-40B4-BE49-F238E27FC236}">
-                <a16:creationId xmlns:a16="http://schemas.microsoft.com/office/drawing/2014/main" id="{C27CDF30-41C2-49D7-A33F-D6AD3203107D}"/>
+                <a16:creationId xmlns:a16="http://schemas.microsoft.com/office/drawing/2014/main" id="{A38D6F1D-4E56-438B-8E46-96B2E9A88CF3}"/>
               </a:ext>
             </a:extLst>
           </p:cNvPr>
@@ -2269,7 +2269,7 @@
           <p:cNvPr id="2" name="Left column">
             <a:extLst xmlns:a="http://schemas.openxmlformats.org/drawingml/2006/main">
               <a:ext uri="{FF2B5EF4-FFF2-40B4-BE49-F238E27FC236}">
-                <a16:creationId xmlns:a16="http://schemas.microsoft.com/office/drawing/2014/main" id="{B46854A0-D4E5-4A23-A9A7-E2BBD8E20301}"/>
+                <a16:creationId xmlns:a16="http://schemas.microsoft.com/office/drawing/2014/main" id="{E2926DB4-607F-4AE8-8378-76AE0163C4EF}"/>
               </a:ext>
             </a:extLst>
           </p:cNvPr>
@@ -2498,7 +2498,7 @@
           <p:cNvPr id="3" name="Right column">
             <a:extLst xmlns:a="http://schemas.openxmlformats.org/drawingml/2006/main">
               <a:ext uri="{FF2B5EF4-FFF2-40B4-BE49-F238E27FC236}">
-                <a16:creationId xmlns:a16="http://schemas.microsoft.com/office/drawing/2014/main" id="{4B54952A-9C4B-4490-B495-C6F44EEEB429}"/>
+                <a16:creationId xmlns:a16="http://schemas.microsoft.com/office/drawing/2014/main" id="{B182E208-C9FB-4283-A963-4EF5A9D3E670}"/>
               </a:ext>
             </a:extLst>
           </p:cNvPr>
@@ -2744,7 +2744,7 @@
           <p:cNvPr id="3" name="Title">
             <a:extLst xmlns:a="http://schemas.openxmlformats.org/drawingml/2006/main">
               <a:ext uri="{FF2B5EF4-FFF2-40B4-BE49-F238E27FC236}">
-                <a16:creationId xmlns:a16="http://schemas.microsoft.com/office/drawing/2014/main" id="{26C486F4-5743-410E-A0BE-DAA390F44BCD}"/>
+                <a16:creationId xmlns:a16="http://schemas.microsoft.com/office/drawing/2014/main" id="{1554577F-6D17-4D89-9EE1-8A2996A462EE}"/>
               </a:ext>
             </a:extLst>
           </p:cNvPr>
@@ -2973,7 +2973,7 @@
           <p:cNvPr id="2" name="Left column">
             <a:extLst xmlns:a="http://schemas.openxmlformats.org/drawingml/2006/main">
               <a:ext uri="{FF2B5EF4-FFF2-40B4-BE49-F238E27FC236}">
-                <a16:creationId xmlns:a16="http://schemas.microsoft.com/office/drawing/2014/main" id="{9F65DE71-6B6A-4728-B697-731C75437DF9}"/>
+                <a16:creationId xmlns:a16="http://schemas.microsoft.com/office/drawing/2014/main" id="{52A5D8A3-B692-4895-8361-578E7803D53C}"/>
               </a:ext>
             </a:extLst>
           </p:cNvPr>
@@ -3240,12 +3240,12 @@
   </p:cSld>
   <p:clrMap bg1="lt1" tx1="dk1" bg2="lt2" tx2="dk2" accent1="accent1" accent2="accent2" accent3="accent3" accent4="accent4" accent5="accent5" accent6="accent6" hlink="hlink" folHlink="folHlink"/>
   <p:sldLayoutIdLst>
-    <p:sldLayoutId xmlns:r="http://schemas.openxmlformats.org/officeDocument/2006/relationships" id="2147483649" r:id="Rf0a83f315a384925"/>
-    <p:sldLayoutId xmlns:r="http://schemas.openxmlformats.org/officeDocument/2006/relationships" id="2147483650" r:id="R72e724291e6245bd"/>
-    <p:sldLayoutId xmlns:r="http://schemas.openxmlformats.org/officeDocument/2006/relationships" id="2147483651" r:id="R60022d6f99214611"/>
-    <p:sldLayoutId xmlns:r="http://schemas.openxmlformats.org/officeDocument/2006/relationships" id="2147483652" r:id="R758234c3cc974ad1"/>
-    <p:sldLayoutId xmlns:r="http://schemas.openxmlformats.org/officeDocument/2006/relationships" id="2147483653" r:id="Rb19b1f9f2c064f95"/>
-    <p:sldLayoutId xmlns:r="http://schemas.openxmlformats.org/officeDocument/2006/relationships" id="2147483654" r:id="Ra7e793e2cb7a40a8"/>
+    <p:sldLayoutId xmlns:r="http://schemas.openxmlformats.org/officeDocument/2006/relationships" id="2147483649" r:id="R4f76108fd85a4c68"/>
+    <p:sldLayoutId xmlns:r="http://schemas.openxmlformats.org/officeDocument/2006/relationships" id="2147483650" r:id="Rdfe6280cdbe84cfd"/>
+    <p:sldLayoutId xmlns:r="http://schemas.openxmlformats.org/officeDocument/2006/relationships" id="2147483651" r:id="R32eb3d615d7f4794"/>
+    <p:sldLayoutId xmlns:r="http://schemas.openxmlformats.org/officeDocument/2006/relationships" id="2147483652" r:id="Rc4d26a27de314d37"/>
+    <p:sldLayoutId xmlns:r="http://schemas.openxmlformats.org/officeDocument/2006/relationships" id="2147483653" r:id="R771485174862431f"/>
+    <p:sldLayoutId xmlns:r="http://schemas.openxmlformats.org/officeDocument/2006/relationships" id="2147483654" r:id="R64660e3ba88b4002"/>
   </p:sldLayoutIdLst>
   <p:txStyles>
     <p:titleStyle>
@@ -4092,7 +4092,7 @@
           <p:cNvPr id="9" name="">
             <a:extLst xmlns:a="http://schemas.openxmlformats.org/drawingml/2006/main">
               <a:ext uri="{FF2B5EF4-FFF2-40B4-BE49-F238E27FC236}">
-                <a16:creationId xmlns:a16="http://schemas.microsoft.com/office/drawing/2014/main" id="{57FFEFF9-C4E0-499E-A225-72D982568A38}"/>
+                <a16:creationId xmlns:a16="http://schemas.microsoft.com/office/drawing/2014/main" id="{D9F82EB2-7232-46CF-B20D-58EE29D06926}"/>
               </a:ext>
             </a:extLst>
           </p:cNvPr>
@@ -4102,7 +4102,7 @@
           <p:nvPr/>
         </p:nvPicPr>
         <p:blipFill>
-          <a:blip xmlns:r="http://schemas.openxmlformats.org/officeDocument/2006/relationships" xmlns:a="http://schemas.openxmlformats.org/drawingml/2006/main" r:embed="Rc8a0d434e4ab4d87"/>
+          <a:blip xmlns:r="http://schemas.openxmlformats.org/officeDocument/2006/relationships" xmlns:a="http://schemas.openxmlformats.org/drawingml/2006/main" r:embed="R7d3720c212ea4360"/>
           <a:srcRect xmlns:a="http://schemas.openxmlformats.org/drawingml/2006/main" l="0" t="27" r="0" b="27"/>
           <a:stretch xmlns:a="http://schemas.openxmlformats.org/drawingml/2006/main">
             <a:fillRect l="0" t="0" r="0" b="0"/>
@@ -4123,7 +4123,7 @@
           <p:cNvPr id="2" name="">
             <a:extLst xmlns:a="http://schemas.openxmlformats.org/drawingml/2006/main">
               <a:ext uri="{FF2B5EF4-FFF2-40B4-BE49-F238E27FC236}">
-                <a16:creationId xmlns:a16="http://schemas.microsoft.com/office/drawing/2014/main" id="{9FCF48CA-131F-4812-BAE0-6F7C8A34D5CE}"/>
+                <a16:creationId xmlns:a16="http://schemas.microsoft.com/office/drawing/2014/main" id="{F33968B4-BB05-4530-8ADC-E3AAB9C6E7FA}"/>
               </a:ext>
             </a:extLst>
           </p:cNvPr>
@@ -4133,7 +4133,7 @@
           <p:nvPr/>
         </p:nvPicPr>
         <p:blipFill>
-          <a:blip xmlns:r="http://schemas.openxmlformats.org/officeDocument/2006/relationships" xmlns:a="http://schemas.openxmlformats.org/drawingml/2006/main" r:embed="R59f84bd9c3bb41e6"/>
+          <a:blip xmlns:r="http://schemas.openxmlformats.org/officeDocument/2006/relationships" xmlns:a="http://schemas.openxmlformats.org/drawingml/2006/main" r:embed="Rca37b0cb31624831"/>
           <a:stretch xmlns:a="http://schemas.openxmlformats.org/drawingml/2006/main"/>
         </p:blipFill>
         <p:spPr>
@@ -4151,7 +4151,7 @@
           <p:cNvPr id="3" name="">
             <a:extLst xmlns:a="http://schemas.openxmlformats.org/drawingml/2006/main">
               <a:ext uri="{FF2B5EF4-FFF2-40B4-BE49-F238E27FC236}">
-                <a16:creationId xmlns:a16="http://schemas.microsoft.com/office/drawing/2014/main" id="{B6C797A1-12FB-49DA-A432-8FEE02615F79}"/>
+                <a16:creationId xmlns:a16="http://schemas.microsoft.com/office/drawing/2014/main" id="{312B65BA-EF7D-4C0C-8069-312C52EDDDA3}"/>
               </a:ext>
             </a:extLst>
           </p:cNvPr>
@@ -4308,7 +4308,7 @@
           <p:cNvPr id="4" name="">
             <a:extLst xmlns:a="http://schemas.openxmlformats.org/drawingml/2006/main">
               <a:ext uri="{FF2B5EF4-FFF2-40B4-BE49-F238E27FC236}">
-                <a16:creationId xmlns:a16="http://schemas.microsoft.com/office/drawing/2014/main" id="{E629CAAF-B0D9-4205-8E3B-E373F41EC800}"/>
+                <a16:creationId xmlns:a16="http://schemas.microsoft.com/office/drawing/2014/main" id="{5F177454-F102-4644-A2AE-998299A5EE3A}"/>
               </a:ext>
             </a:extLst>
           </p:cNvPr>
@@ -4465,7 +4465,7 @@
           <p:cNvPr id="5" name="">
             <a:extLst xmlns:a="http://schemas.openxmlformats.org/drawingml/2006/main">
               <a:ext uri="{FF2B5EF4-FFF2-40B4-BE49-F238E27FC236}">
-                <a16:creationId xmlns:a16="http://schemas.microsoft.com/office/drawing/2014/main" id="{C0AEEFCD-D739-48C0-9654-F2DCE00BE693}"/>
+                <a16:creationId xmlns:a16="http://schemas.microsoft.com/office/drawing/2014/main" id="{B76B1F77-6D31-4F0A-851D-1C9B1739B820}"/>
               </a:ext>
             </a:extLst>
           </p:cNvPr>
@@ -4622,7 +4622,7 @@
           <p:cNvPr id="6" name="">
             <a:extLst xmlns:a="http://schemas.openxmlformats.org/drawingml/2006/main">
               <a:ext uri="{FF2B5EF4-FFF2-40B4-BE49-F238E27FC236}">
-                <a16:creationId xmlns:a16="http://schemas.microsoft.com/office/drawing/2014/main" id="{2742784F-5694-442E-81DD-9E9324344DEC}"/>
+                <a16:creationId xmlns:a16="http://schemas.microsoft.com/office/drawing/2014/main" id="{2C61AF16-4813-4152-B4B3-FE65B87BD8C4}"/>
               </a:ext>
             </a:extLst>
           </p:cNvPr>
@@ -4655,7 +4655,7 @@
           <p:cNvPr id="7" name="">
             <a:extLst xmlns:a="http://schemas.openxmlformats.org/drawingml/2006/main">
               <a:ext uri="{FF2B5EF4-FFF2-40B4-BE49-F238E27FC236}">
-                <a16:creationId xmlns:a16="http://schemas.microsoft.com/office/drawing/2014/main" id="{26B94FA8-8E2A-4C17-B876-E398E2CBE629}"/>
+                <a16:creationId xmlns:a16="http://schemas.microsoft.com/office/drawing/2014/main" id="{5EC8AD85-18A7-45AD-9235-DBB6D3271339}"/>
               </a:ext>
             </a:extLst>
           </p:cNvPr>
@@ -4667,7 +4667,7 @@
         <p:spPr>
           <a:xfrm xmlns:a="http://schemas.openxmlformats.org/drawingml/2006/main">
             <a:off x="723900" y="4524375"/>
-            <a:ext cx="5810250" cy="381000"/>
+            <a:ext cx="6477000" cy="381000"/>
           </a:xfrm>
           <a:prstGeom xmlns:a="http://schemas.openxmlformats.org/drawingml/2006/main" prst="rect">
             <a:avLst/>
@@ -4802,7 +4802,7 @@
                 <a:ea typeface="Aptos"/>
                 <a:cs typeface="Aptos"/>
               </a:rPr>
-              <a:t>Mark Hinkle  /  John Willis</a:t>
+              <a:t>Merge-Geezers  /  Mark Hinkle + John Willis</a:t>
             </a:r>
           </a:p>
         </p:txBody>
@@ -4812,7 +4812,7 @@
           <p:cNvPr id="8" name="">
             <a:extLst xmlns:a="http://schemas.openxmlformats.org/drawingml/2006/main">
               <a:ext uri="{FF2B5EF4-FFF2-40B4-BE49-F238E27FC236}">
-                <a16:creationId xmlns:a16="http://schemas.microsoft.com/office/drawing/2014/main" id="{EEBD5D67-E833-4539-8FA5-70C9B7199703}"/>
+                <a16:creationId xmlns:a16="http://schemas.microsoft.com/office/drawing/2014/main" id="{1DA8B479-27DE-44F2-8E03-43268E700AAF}"/>
               </a:ext>
             </a:extLst>
           </p:cNvPr>
@@ -4967,7 +4967,7 @@
     </p:spTree>
     <p:extLst>
       <p:ext uri="{BB962C8B-B14F-4D97-AF65-F5344CB8AC3E}">
-        <p14:creationId xmlns:p14="http://schemas.microsoft.com/office/powerpoint/2010/main" val="2063065042"/>
+        <p14:creationId xmlns:p14="http://schemas.microsoft.com/office/powerpoint/2010/main" val="1868102783"/>
       </p:ext>
     </p:extLst>
   </p:cSld>
@@ -4998,7 +4998,7 @@
           <p:cNvPr id="13" name="">
             <a:extLst xmlns:a="http://schemas.openxmlformats.org/drawingml/2006/main">
               <a:ext uri="{FF2B5EF4-FFF2-40B4-BE49-F238E27FC236}">
-                <a16:creationId xmlns:a16="http://schemas.microsoft.com/office/drawing/2014/main" id="{49A3B2E7-09CB-4877-AFCC-1A1BC2A47E9A}"/>
+                <a16:creationId xmlns:a16="http://schemas.microsoft.com/office/drawing/2014/main" id="{703127A8-91FC-47CF-A5C6-E12570BB65EF}"/>
               </a:ext>
             </a:extLst>
           </p:cNvPr>
@@ -5155,7 +5155,7 @@
           <p:cNvPr id="2" name="">
             <a:extLst xmlns:a="http://schemas.openxmlformats.org/drawingml/2006/main">
               <a:ext uri="{FF2B5EF4-FFF2-40B4-BE49-F238E27FC236}">
-                <a16:creationId xmlns:a16="http://schemas.microsoft.com/office/drawing/2014/main" id="{A2290C93-74A8-4918-B3EB-ADF40B7BC6C2}"/>
+                <a16:creationId xmlns:a16="http://schemas.microsoft.com/office/drawing/2014/main" id="{95251026-80EB-4355-80F7-B2DD57A976E4}"/>
               </a:ext>
             </a:extLst>
           </p:cNvPr>
@@ -5312,7 +5312,7 @@
           <p:cNvPr id="3" name="">
             <a:extLst xmlns:a="http://schemas.openxmlformats.org/drawingml/2006/main">
               <a:ext uri="{FF2B5EF4-FFF2-40B4-BE49-F238E27FC236}">
-                <a16:creationId xmlns:a16="http://schemas.microsoft.com/office/drawing/2014/main" id="{70ED0BCE-352F-4D3D-990E-027CDC8276AE}"/>
+                <a16:creationId xmlns:a16="http://schemas.microsoft.com/office/drawing/2014/main" id="{0E99374D-F971-4B75-932C-B9250B52A370}"/>
               </a:ext>
             </a:extLst>
           </p:cNvPr>
@@ -5345,7 +5345,7 @@
           <p:cNvPr id="4" name="">
             <a:extLst xmlns:a="http://schemas.openxmlformats.org/drawingml/2006/main">
               <a:ext uri="{FF2B5EF4-FFF2-40B4-BE49-F238E27FC236}">
-                <a16:creationId xmlns:a16="http://schemas.microsoft.com/office/drawing/2014/main" id="{B32D7DA9-30E7-449E-8B92-0DCECBC58EA7}"/>
+                <a16:creationId xmlns:a16="http://schemas.microsoft.com/office/drawing/2014/main" id="{274C81EB-1795-437B-A23D-08F2E40EDCB0}"/>
               </a:ext>
             </a:extLst>
           </p:cNvPr>
@@ -5502,7 +5502,7 @@
           <p:cNvPr id="5" name="">
             <a:extLst xmlns:a="http://schemas.openxmlformats.org/drawingml/2006/main">
               <a:ext uri="{FF2B5EF4-FFF2-40B4-BE49-F238E27FC236}">
-                <a16:creationId xmlns:a16="http://schemas.microsoft.com/office/drawing/2014/main" id="{FC32FF9E-CFF9-4455-ABEC-CAC9E6ED0FA6}"/>
+                <a16:creationId xmlns:a16="http://schemas.microsoft.com/office/drawing/2014/main" id="{D033C042-C4CA-4B70-962F-E3FEACC59CA5}"/>
               </a:ext>
             </a:extLst>
           </p:cNvPr>
@@ -5659,7 +5659,7 @@
           <p:cNvPr id="6" name="">
             <a:extLst xmlns:a="http://schemas.openxmlformats.org/drawingml/2006/main">
               <a:ext uri="{FF2B5EF4-FFF2-40B4-BE49-F238E27FC236}">
-                <a16:creationId xmlns:a16="http://schemas.microsoft.com/office/drawing/2014/main" id="{515605CD-3A31-47C0-97F8-259C544943A9}"/>
+                <a16:creationId xmlns:a16="http://schemas.microsoft.com/office/drawing/2014/main" id="{88424B99-09CB-4299-8487-34AF516BED6A}"/>
               </a:ext>
             </a:extLst>
           </p:cNvPr>
@@ -5816,7 +5816,7 @@
           <p:cNvPr id="7" name="">
             <a:extLst xmlns:a="http://schemas.openxmlformats.org/drawingml/2006/main">
               <a:ext uri="{FF2B5EF4-FFF2-40B4-BE49-F238E27FC236}">
-                <a16:creationId xmlns:a16="http://schemas.microsoft.com/office/drawing/2014/main" id="{3A63A7EC-001E-4A92-BA59-A4E7D412FA66}"/>
+                <a16:creationId xmlns:a16="http://schemas.microsoft.com/office/drawing/2014/main" id="{4856BDD0-1E2C-41A5-B4B6-2ADEFF461AE2}"/>
               </a:ext>
             </a:extLst>
           </p:cNvPr>
@@ -5973,7 +5973,7 @@
           <p:cNvPr id="8" name="">
             <a:extLst xmlns:a="http://schemas.openxmlformats.org/drawingml/2006/main">
               <a:ext uri="{FF2B5EF4-FFF2-40B4-BE49-F238E27FC236}">
-                <a16:creationId xmlns:a16="http://schemas.microsoft.com/office/drawing/2014/main" id="{37FAEA42-E5BC-4024-BC02-0580B955722B}"/>
+                <a16:creationId xmlns:a16="http://schemas.microsoft.com/office/drawing/2014/main" id="{3D362AC6-13D7-4EC5-93C4-C4E8417C0F09}"/>
               </a:ext>
             </a:extLst>
           </p:cNvPr>
@@ -5983,7 +5983,7 @@
           <p:nvPr/>
         </p:nvPicPr>
         <p:blipFill>
-          <a:blip xmlns:r="http://schemas.openxmlformats.org/officeDocument/2006/relationships" xmlns:a="http://schemas.openxmlformats.org/drawingml/2006/main" r:embed="Rfa4a458091a04434"/>
+          <a:blip xmlns:r="http://schemas.openxmlformats.org/officeDocument/2006/relationships" xmlns:a="http://schemas.openxmlformats.org/drawingml/2006/main" r:embed="R54ca73df49284ca1"/>
           <a:srcRect xmlns:a="http://schemas.openxmlformats.org/drawingml/2006/main" l="0" t="8654" r="0" b="8654"/>
           <a:stretch xmlns:a="http://schemas.openxmlformats.org/drawingml/2006/main">
             <a:fillRect l="0" t="0" r="0" b="0"/>
@@ -6006,7 +6006,7 @@
           <p:cNvPr id="9" name="">
             <a:extLst xmlns:a="http://schemas.openxmlformats.org/drawingml/2006/main">
               <a:ext uri="{FF2B5EF4-FFF2-40B4-BE49-F238E27FC236}">
-                <a16:creationId xmlns:a16="http://schemas.microsoft.com/office/drawing/2014/main" id="{E4DFFE1B-F9BA-4EE7-BA77-FB9ADA8A395C}"/>
+                <a16:creationId xmlns:a16="http://schemas.microsoft.com/office/drawing/2014/main" id="{1A4C0C10-F02A-4693-AE7C-949B6F699D83}"/>
               </a:ext>
             </a:extLst>
           </p:cNvPr>
@@ -6039,7 +6039,7 @@
           <p:cNvPr id="10" name="">
             <a:extLst xmlns:a="http://schemas.openxmlformats.org/drawingml/2006/main">
               <a:ext uri="{FF2B5EF4-FFF2-40B4-BE49-F238E27FC236}">
-                <a16:creationId xmlns:a16="http://schemas.microsoft.com/office/drawing/2014/main" id="{3FB4FD6C-4DC2-4A46-8DAC-1C5F091755E9}"/>
+                <a16:creationId xmlns:a16="http://schemas.microsoft.com/office/drawing/2014/main" id="{5CDCEB0F-8E90-4561-9E8A-6A08E3533792}"/>
               </a:ext>
             </a:extLst>
           </p:cNvPr>
@@ -6196,7 +6196,7 @@
           <p:cNvPr id="11" name="">
             <a:extLst xmlns:a="http://schemas.openxmlformats.org/drawingml/2006/main">
               <a:ext uri="{FF2B5EF4-FFF2-40B4-BE49-F238E27FC236}">
-                <a16:creationId xmlns:a16="http://schemas.microsoft.com/office/drawing/2014/main" id="{4CFC3403-5635-4B92-9F40-ECC2B9B6969C}"/>
+                <a16:creationId xmlns:a16="http://schemas.microsoft.com/office/drawing/2014/main" id="{EDF4A9C5-530F-4FB2-A790-60A4353323ED}"/>
               </a:ext>
             </a:extLst>
           </p:cNvPr>
@@ -6353,7 +6353,7 @@
           <p:cNvPr id="12" name="">
             <a:extLst xmlns:a="http://schemas.openxmlformats.org/drawingml/2006/main">
               <a:ext uri="{FF2B5EF4-FFF2-40B4-BE49-F238E27FC236}">
-                <a16:creationId xmlns:a16="http://schemas.microsoft.com/office/drawing/2014/main" id="{38149202-A256-4449-B17B-D1091485B5B5}"/>
+                <a16:creationId xmlns:a16="http://schemas.microsoft.com/office/drawing/2014/main" id="{C5898C01-C774-4276-8022-4457681632FB}"/>
               </a:ext>
             </a:extLst>
           </p:cNvPr>
@@ -6508,7 +6508,7 @@
     </p:spTree>
     <p:extLst>
       <p:ext uri="{BB962C8B-B14F-4D97-AF65-F5344CB8AC3E}">
-        <p14:creationId xmlns:p14="http://schemas.microsoft.com/office/powerpoint/2010/main" val="1523180938"/>
+        <p14:creationId xmlns:p14="http://schemas.microsoft.com/office/powerpoint/2010/main" val="646596424"/>
       </p:ext>
     </p:extLst>
   </p:cSld>
@@ -6539,7 +6539,7 @@
           <p:cNvPr id="17" name="">
             <a:extLst xmlns:a="http://schemas.openxmlformats.org/drawingml/2006/main">
               <a:ext uri="{FF2B5EF4-FFF2-40B4-BE49-F238E27FC236}">
-                <a16:creationId xmlns:a16="http://schemas.microsoft.com/office/drawing/2014/main" id="{3A06CBB6-21D8-4F2B-9A44-53DF482C1D16}"/>
+                <a16:creationId xmlns:a16="http://schemas.microsoft.com/office/drawing/2014/main" id="{31DAFFA8-909B-4E34-B6D7-047A72EB39B6}"/>
               </a:ext>
             </a:extLst>
           </p:cNvPr>
@@ -6696,7 +6696,7 @@
           <p:cNvPr id="2" name="">
             <a:extLst xmlns:a="http://schemas.openxmlformats.org/drawingml/2006/main">
               <a:ext uri="{FF2B5EF4-FFF2-40B4-BE49-F238E27FC236}">
-                <a16:creationId xmlns:a16="http://schemas.microsoft.com/office/drawing/2014/main" id="{D9D1C3EB-6EF1-463F-8303-3A028F3582BA}"/>
+                <a16:creationId xmlns:a16="http://schemas.microsoft.com/office/drawing/2014/main" id="{540AE624-B989-4514-A31B-327BAF37C5D1}"/>
               </a:ext>
             </a:extLst>
           </p:cNvPr>
@@ -6853,7 +6853,7 @@
           <p:cNvPr id="3" name="">
             <a:extLst xmlns:a="http://schemas.openxmlformats.org/drawingml/2006/main">
               <a:ext uri="{FF2B5EF4-FFF2-40B4-BE49-F238E27FC236}">
-                <a16:creationId xmlns:a16="http://schemas.microsoft.com/office/drawing/2014/main" id="{6AC2BB3A-B706-403F-A4A4-1E19F16621F7}"/>
+                <a16:creationId xmlns:a16="http://schemas.microsoft.com/office/drawing/2014/main" id="{19A1683A-05AC-4530-848C-9354BC0B6190}"/>
               </a:ext>
             </a:extLst>
           </p:cNvPr>
@@ -6886,7 +6886,7 @@
           <p:cNvPr id="4" name="">
             <a:extLst xmlns:a="http://schemas.openxmlformats.org/drawingml/2006/main">
               <a:ext uri="{FF2B5EF4-FFF2-40B4-BE49-F238E27FC236}">
-                <a16:creationId xmlns:a16="http://schemas.microsoft.com/office/drawing/2014/main" id="{3324F6E9-CEAC-4BA3-8662-FC7FAE5A27BE}"/>
+                <a16:creationId xmlns:a16="http://schemas.microsoft.com/office/drawing/2014/main" id="{4DE1219F-E275-4377-B484-B2783EF6432E}"/>
               </a:ext>
             </a:extLst>
           </p:cNvPr>
@@ -7043,7 +7043,7 @@
           <p:cNvPr id="5" name="">
             <a:extLst xmlns:a="http://schemas.openxmlformats.org/drawingml/2006/main">
               <a:ext uri="{FF2B5EF4-FFF2-40B4-BE49-F238E27FC236}">
-                <a16:creationId xmlns:a16="http://schemas.microsoft.com/office/drawing/2014/main" id="{42CBD186-7323-42B3-BBF6-96716D776C43}"/>
+                <a16:creationId xmlns:a16="http://schemas.microsoft.com/office/drawing/2014/main" id="{CC4CBBA9-6C4C-4A28-93A7-0B2F99FD647E}"/>
               </a:ext>
             </a:extLst>
           </p:cNvPr>
@@ -7200,7 +7200,7 @@
           <p:cNvPr id="6" name="">
             <a:extLst xmlns:a="http://schemas.openxmlformats.org/drawingml/2006/main">
               <a:ext uri="{FF2B5EF4-FFF2-40B4-BE49-F238E27FC236}">
-                <a16:creationId xmlns:a16="http://schemas.microsoft.com/office/drawing/2014/main" id="{9373449E-067C-49FE-BBB2-0DC1B06548A6}"/>
+                <a16:creationId xmlns:a16="http://schemas.microsoft.com/office/drawing/2014/main" id="{212A0990-26E9-4053-87A5-F3E2624914E9}"/>
               </a:ext>
             </a:extLst>
           </p:cNvPr>
@@ -7357,7 +7357,7 @@
           <p:cNvPr id="7" name="">
             <a:extLst xmlns:a="http://schemas.openxmlformats.org/drawingml/2006/main">
               <a:ext uri="{FF2B5EF4-FFF2-40B4-BE49-F238E27FC236}">
-                <a16:creationId xmlns:a16="http://schemas.microsoft.com/office/drawing/2014/main" id="{74FE441A-C974-4BD5-883F-970E65E14087}"/>
+                <a16:creationId xmlns:a16="http://schemas.microsoft.com/office/drawing/2014/main" id="{7E6BF202-2661-4406-B63A-13037727DF37}"/>
               </a:ext>
             </a:extLst>
           </p:cNvPr>
@@ -7390,7 +7390,7 @@
           <p:cNvPr id="8" name="">
             <a:extLst xmlns:a="http://schemas.openxmlformats.org/drawingml/2006/main">
               <a:ext uri="{FF2B5EF4-FFF2-40B4-BE49-F238E27FC236}">
-                <a16:creationId xmlns:a16="http://schemas.microsoft.com/office/drawing/2014/main" id="{92C0EDCB-EFFB-4E43-B318-7E2FD4F3D2C3}"/>
+                <a16:creationId xmlns:a16="http://schemas.microsoft.com/office/drawing/2014/main" id="{B0BF0B05-A9A0-4F02-A6C8-EEC8A2D3D701}"/>
               </a:ext>
             </a:extLst>
           </p:cNvPr>
@@ -7547,7 +7547,7 @@
           <p:cNvPr id="9" name="">
             <a:extLst xmlns:a="http://schemas.openxmlformats.org/drawingml/2006/main">
               <a:ext uri="{FF2B5EF4-FFF2-40B4-BE49-F238E27FC236}">
-                <a16:creationId xmlns:a16="http://schemas.microsoft.com/office/drawing/2014/main" id="{E15F80FA-1B4D-4C0B-B56B-A3B11539C61A}"/>
+                <a16:creationId xmlns:a16="http://schemas.microsoft.com/office/drawing/2014/main" id="{8407C5B9-6E6B-4CE6-8E73-075F5D4B1846}"/>
               </a:ext>
             </a:extLst>
           </p:cNvPr>
@@ -7704,7 +7704,7 @@
           <p:cNvPr id="10" name="">
             <a:extLst xmlns:a="http://schemas.openxmlformats.org/drawingml/2006/main">
               <a:ext uri="{FF2B5EF4-FFF2-40B4-BE49-F238E27FC236}">
-                <a16:creationId xmlns:a16="http://schemas.microsoft.com/office/drawing/2014/main" id="{0C41EF02-1B9C-47AA-8F8E-108F9FC21E95}"/>
+                <a16:creationId xmlns:a16="http://schemas.microsoft.com/office/drawing/2014/main" id="{7BA20054-96C8-48C5-A858-421C244B540C}"/>
               </a:ext>
             </a:extLst>
           </p:cNvPr>
@@ -7861,7 +7861,7 @@
           <p:cNvPr id="11" name="">
             <a:extLst xmlns:a="http://schemas.openxmlformats.org/drawingml/2006/main">
               <a:ext uri="{FF2B5EF4-FFF2-40B4-BE49-F238E27FC236}">
-                <a16:creationId xmlns:a16="http://schemas.microsoft.com/office/drawing/2014/main" id="{1E05D7AE-F30C-4ECC-A792-053E659D68EF}"/>
+                <a16:creationId xmlns:a16="http://schemas.microsoft.com/office/drawing/2014/main" id="{0FDA132E-CD9E-44ED-9B27-D4436F434B61}"/>
               </a:ext>
             </a:extLst>
           </p:cNvPr>
@@ -7894,7 +7894,7 @@
           <p:cNvPr id="12" name="">
             <a:extLst xmlns:a="http://schemas.openxmlformats.org/drawingml/2006/main">
               <a:ext uri="{FF2B5EF4-FFF2-40B4-BE49-F238E27FC236}">
-                <a16:creationId xmlns:a16="http://schemas.microsoft.com/office/drawing/2014/main" id="{B95F7300-60BA-426D-9CF9-E8AA8C1C4740}"/>
+                <a16:creationId xmlns:a16="http://schemas.microsoft.com/office/drawing/2014/main" id="{8A6D5A98-AAE8-4C8B-A634-1C4919263C94}"/>
               </a:ext>
             </a:extLst>
           </p:cNvPr>
@@ -8051,7 +8051,7 @@
           <p:cNvPr id="13" name="">
             <a:extLst xmlns:a="http://schemas.openxmlformats.org/drawingml/2006/main">
               <a:ext uri="{FF2B5EF4-FFF2-40B4-BE49-F238E27FC236}">
-                <a16:creationId xmlns:a16="http://schemas.microsoft.com/office/drawing/2014/main" id="{89CF09C2-44FB-45DA-9514-91CF0D20B7A0}"/>
+                <a16:creationId xmlns:a16="http://schemas.microsoft.com/office/drawing/2014/main" id="{539D3989-F36D-42FD-BBC8-7D4248F00C46}"/>
               </a:ext>
             </a:extLst>
           </p:cNvPr>
@@ -8208,7 +8208,7 @@
           <p:cNvPr id="14" name="">
             <a:extLst xmlns:a="http://schemas.openxmlformats.org/drawingml/2006/main">
               <a:ext uri="{FF2B5EF4-FFF2-40B4-BE49-F238E27FC236}">
-                <a16:creationId xmlns:a16="http://schemas.microsoft.com/office/drawing/2014/main" id="{B3534337-76E0-486F-BBB3-2770692AC61F}"/>
+                <a16:creationId xmlns:a16="http://schemas.microsoft.com/office/drawing/2014/main" id="{FC73F5D2-A952-49DC-AF28-FF026B1E0312}"/>
               </a:ext>
             </a:extLst>
           </p:cNvPr>
@@ -8365,7 +8365,7 @@
           <p:cNvPr id="15" name="">
             <a:extLst xmlns:a="http://schemas.openxmlformats.org/drawingml/2006/main">
               <a:ext uri="{FF2B5EF4-FFF2-40B4-BE49-F238E27FC236}">
-                <a16:creationId xmlns:a16="http://schemas.microsoft.com/office/drawing/2014/main" id="{5FFB1B25-D25A-425D-A5AF-113EB9E69614}"/>
+                <a16:creationId xmlns:a16="http://schemas.microsoft.com/office/drawing/2014/main" id="{8401454B-DECB-41FB-AF20-3753D4208F10}"/>
               </a:ext>
             </a:extLst>
           </p:cNvPr>
@@ -8522,7 +8522,7 @@
           <p:cNvPr id="16" name="">
             <a:extLst xmlns:a="http://schemas.openxmlformats.org/drawingml/2006/main">
               <a:ext uri="{FF2B5EF4-FFF2-40B4-BE49-F238E27FC236}">
-                <a16:creationId xmlns:a16="http://schemas.microsoft.com/office/drawing/2014/main" id="{226149A3-A445-49CC-9C0B-8920F08BB845}"/>
+                <a16:creationId xmlns:a16="http://schemas.microsoft.com/office/drawing/2014/main" id="{F97B9FFD-060F-408A-B96B-250061888351}"/>
               </a:ext>
             </a:extLst>
           </p:cNvPr>
@@ -8677,7 +8677,7 @@
     </p:spTree>
     <p:extLst>
       <p:ext uri="{BB962C8B-B14F-4D97-AF65-F5344CB8AC3E}">
-        <p14:creationId xmlns:p14="http://schemas.microsoft.com/office/powerpoint/2010/main" val="55867974"/>
+        <p14:creationId xmlns:p14="http://schemas.microsoft.com/office/powerpoint/2010/main" val="1482637090"/>
       </p:ext>
     </p:extLst>
   </p:cSld>
@@ -8708,7 +8708,7 @@
           <p:cNvPr id="13" name="">
             <a:extLst xmlns:a="http://schemas.openxmlformats.org/drawingml/2006/main">
               <a:ext uri="{FF2B5EF4-FFF2-40B4-BE49-F238E27FC236}">
-                <a16:creationId xmlns:a16="http://schemas.microsoft.com/office/drawing/2014/main" id="{05CAFFD5-F27A-4C28-B3A7-53777454AB34}"/>
+                <a16:creationId xmlns:a16="http://schemas.microsoft.com/office/drawing/2014/main" id="{2DF543AA-FD22-4672-93BA-079ABBF1E742}"/>
               </a:ext>
             </a:extLst>
           </p:cNvPr>
@@ -8865,7 +8865,7 @@
           <p:cNvPr id="2" name="">
             <a:extLst xmlns:a="http://schemas.openxmlformats.org/drawingml/2006/main">
               <a:ext uri="{FF2B5EF4-FFF2-40B4-BE49-F238E27FC236}">
-                <a16:creationId xmlns:a16="http://schemas.microsoft.com/office/drawing/2014/main" id="{7460B324-96A7-45CC-B840-8FB7C6A5CE22}"/>
+                <a16:creationId xmlns:a16="http://schemas.microsoft.com/office/drawing/2014/main" id="{F20DD2A8-EEDF-4535-9DC7-2B619561EB15}"/>
               </a:ext>
             </a:extLst>
           </p:cNvPr>
@@ -9022,7 +9022,7 @@
           <p:cNvPr id="3" name="">
             <a:extLst xmlns:a="http://schemas.openxmlformats.org/drawingml/2006/main">
               <a:ext uri="{FF2B5EF4-FFF2-40B4-BE49-F238E27FC236}">
-                <a16:creationId xmlns:a16="http://schemas.microsoft.com/office/drawing/2014/main" id="{90FFA6B7-7F5A-45BA-A7ED-4A3A4B45EFFF}"/>
+                <a16:creationId xmlns:a16="http://schemas.microsoft.com/office/drawing/2014/main" id="{21AD0936-EB4B-4875-BD42-87FA51862760}"/>
               </a:ext>
             </a:extLst>
           </p:cNvPr>
@@ -9055,7 +9055,7 @@
           <p:cNvPr id="4" name="Chart">
             <a:extLst xmlns:a="http://schemas.openxmlformats.org/drawingml/2006/main">
               <a:ext uri="{FF2B5EF4-FFF2-40B4-BE49-F238E27FC236}">
-                <a16:creationId xmlns:a16="http://schemas.microsoft.com/office/drawing/2014/main" id="{0652919E-0236-49CE-A663-ACF9C3025DA2}"/>
+                <a16:creationId xmlns:a16="http://schemas.microsoft.com/office/drawing/2014/main" id="{014D7BE8-6D2A-4080-B2CA-6E25D628E555}"/>
               </a:ext>
             </a:extLst>
           </p:cNvPr>
@@ -9068,7 +9068,7 @@
         </p:xfrm>
         <a:graphic xmlns:a="http://schemas.openxmlformats.org/drawingml/2006/main">
           <a:graphicData uri="http://schemas.openxmlformats.org/drawingml/2006/chart">
-            <c:chart xmlns:r="http://schemas.openxmlformats.org/officeDocument/2006/relationships" xmlns:c="http://schemas.openxmlformats.org/drawingml/2006/chart" r:id="Refabeacf96154715"/>
+            <c:chart xmlns:r="http://schemas.openxmlformats.org/officeDocument/2006/relationships" xmlns:c="http://schemas.openxmlformats.org/drawingml/2006/chart" r:id="R5fa62f13c83a4150"/>
           </a:graphicData>
         </a:graphic>
       </p:graphicFrame>
@@ -9077,7 +9077,7 @@
           <p:cNvPr id="5" name="">
             <a:extLst xmlns:a="http://schemas.openxmlformats.org/drawingml/2006/main">
               <a:ext uri="{FF2B5EF4-FFF2-40B4-BE49-F238E27FC236}">
-                <a16:creationId xmlns:a16="http://schemas.microsoft.com/office/drawing/2014/main" id="{6E24400D-367C-4D0A-956B-374D05BD9420}"/>
+                <a16:creationId xmlns:a16="http://schemas.microsoft.com/office/drawing/2014/main" id="{5DE9EEF0-8418-4679-BF50-7B42AABC0C43}"/>
               </a:ext>
             </a:extLst>
           </p:cNvPr>
@@ -9234,7 +9234,7 @@
           <p:cNvPr id="6" name="">
             <a:extLst xmlns:a="http://schemas.openxmlformats.org/drawingml/2006/main">
               <a:ext uri="{FF2B5EF4-FFF2-40B4-BE49-F238E27FC236}">
-                <a16:creationId xmlns:a16="http://schemas.microsoft.com/office/drawing/2014/main" id="{BE0BCD4F-240B-4694-8472-4C6144CAEF86}"/>
+                <a16:creationId xmlns:a16="http://schemas.microsoft.com/office/drawing/2014/main" id="{DBEC85EA-535B-4B71-9688-22B376B6FB2A}"/>
               </a:ext>
             </a:extLst>
           </p:cNvPr>
@@ -9391,7 +9391,7 @@
           <p:cNvPr id="7" name="">
             <a:extLst xmlns:a="http://schemas.openxmlformats.org/drawingml/2006/main">
               <a:ext uri="{FF2B5EF4-FFF2-40B4-BE49-F238E27FC236}">
-                <a16:creationId xmlns:a16="http://schemas.microsoft.com/office/drawing/2014/main" id="{AF4F2F5C-0E37-4210-BE4C-BA87E239AF28}"/>
+                <a16:creationId xmlns:a16="http://schemas.microsoft.com/office/drawing/2014/main" id="{1553E03D-B65C-45BD-B82C-2E84F22044A9}"/>
               </a:ext>
             </a:extLst>
           </p:cNvPr>
@@ -9424,7 +9424,7 @@
           <p:cNvPr id="8" name="">
             <a:extLst xmlns:a="http://schemas.openxmlformats.org/drawingml/2006/main">
               <a:ext uri="{FF2B5EF4-FFF2-40B4-BE49-F238E27FC236}">
-                <a16:creationId xmlns:a16="http://schemas.microsoft.com/office/drawing/2014/main" id="{3EF3802C-2E2C-4596-91F3-DB88C5A6E1C8}"/>
+                <a16:creationId xmlns:a16="http://schemas.microsoft.com/office/drawing/2014/main" id="{0F998B18-B413-493E-9B12-0BB53BD9BC95}"/>
               </a:ext>
             </a:extLst>
           </p:cNvPr>
@@ -9581,7 +9581,7 @@
           <p:cNvPr id="9" name="">
             <a:extLst xmlns:a="http://schemas.openxmlformats.org/drawingml/2006/main">
               <a:ext uri="{FF2B5EF4-FFF2-40B4-BE49-F238E27FC236}">
-                <a16:creationId xmlns:a16="http://schemas.microsoft.com/office/drawing/2014/main" id="{070A7A0F-DE1C-4DC2-89B3-2409CDC8D88A}"/>
+                <a16:creationId xmlns:a16="http://schemas.microsoft.com/office/drawing/2014/main" id="{20413F30-76BA-49EA-8B1B-51DECA36EE0F}"/>
               </a:ext>
             </a:extLst>
           </p:cNvPr>
@@ -9738,7 +9738,7 @@
           <p:cNvPr id="10" name="">
             <a:extLst xmlns:a="http://schemas.openxmlformats.org/drawingml/2006/main">
               <a:ext uri="{FF2B5EF4-FFF2-40B4-BE49-F238E27FC236}">
-                <a16:creationId xmlns:a16="http://schemas.microsoft.com/office/drawing/2014/main" id="{7CD3ADD2-8737-4C69-9047-0714455C88CA}"/>
+                <a16:creationId xmlns:a16="http://schemas.microsoft.com/office/drawing/2014/main" id="{AB18C6C6-AB4B-4F5E-AF78-114705CE9213}"/>
               </a:ext>
             </a:extLst>
           </p:cNvPr>
@@ -9895,7 +9895,7 @@
           <p:cNvPr id="11" name="">
             <a:extLst xmlns:a="http://schemas.openxmlformats.org/drawingml/2006/main">
               <a:ext uri="{FF2B5EF4-FFF2-40B4-BE49-F238E27FC236}">
-                <a16:creationId xmlns:a16="http://schemas.microsoft.com/office/drawing/2014/main" id="{8310D3F5-B75E-400B-982C-7AFA09BB1703}"/>
+                <a16:creationId xmlns:a16="http://schemas.microsoft.com/office/drawing/2014/main" id="{35C24D6A-56C9-4C7D-8F74-0091EC783177}"/>
               </a:ext>
             </a:extLst>
           </p:cNvPr>
@@ -10052,7 +10052,7 @@
           <p:cNvPr id="12" name="">
             <a:extLst xmlns:a="http://schemas.openxmlformats.org/drawingml/2006/main">
               <a:ext uri="{FF2B5EF4-FFF2-40B4-BE49-F238E27FC236}">
-                <a16:creationId xmlns:a16="http://schemas.microsoft.com/office/drawing/2014/main" id="{D31049AE-E90B-4357-9227-F3F21EF8FF5E}"/>
+                <a16:creationId xmlns:a16="http://schemas.microsoft.com/office/drawing/2014/main" id="{261C1578-A401-4BFA-9CE6-AC13E63F7075}"/>
               </a:ext>
             </a:extLst>
           </p:cNvPr>
@@ -10207,7 +10207,7 @@
     </p:spTree>
     <p:extLst>
       <p:ext uri="{BB962C8B-B14F-4D97-AF65-F5344CB8AC3E}">
-        <p14:creationId xmlns:p14="http://schemas.microsoft.com/office/powerpoint/2010/main" val="1242094630"/>
+        <p14:creationId xmlns:p14="http://schemas.microsoft.com/office/powerpoint/2010/main" val="448543944"/>
       </p:ext>
     </p:extLst>
   </p:cSld>
@@ -10238,7 +10238,7 @@
           <p:cNvPr id="15" name="">
             <a:extLst xmlns:a="http://schemas.openxmlformats.org/drawingml/2006/main">
               <a:ext uri="{FF2B5EF4-FFF2-40B4-BE49-F238E27FC236}">
-                <a16:creationId xmlns:a16="http://schemas.microsoft.com/office/drawing/2014/main" id="{A1DE4218-FB63-435B-85E3-D36C17528CA0}"/>
+                <a16:creationId xmlns:a16="http://schemas.microsoft.com/office/drawing/2014/main" id="{71DC93A6-7DF8-41AA-A7A4-1F37BAAA36E2}"/>
               </a:ext>
             </a:extLst>
           </p:cNvPr>
@@ -10395,7 +10395,7 @@
           <p:cNvPr id="2" name="">
             <a:extLst xmlns:a="http://schemas.openxmlformats.org/drawingml/2006/main">
               <a:ext uri="{FF2B5EF4-FFF2-40B4-BE49-F238E27FC236}">
-                <a16:creationId xmlns:a16="http://schemas.microsoft.com/office/drawing/2014/main" id="{E013C939-9CEC-43EB-B492-82985D2D9E72}"/>
+                <a16:creationId xmlns:a16="http://schemas.microsoft.com/office/drawing/2014/main" id="{EA66B133-C86C-4F5B-9006-D1418D747435}"/>
               </a:ext>
             </a:extLst>
           </p:cNvPr>
@@ -10542,7 +10542,7 @@
                 <a:ea typeface="Aptos Display"/>
                 <a:cs typeface="Aptos Display"/>
               </a:rPr>
-              <a:t>The successor compatibility screen is still running</a:t>
+              <a:t>The successor run found a cohort problem before training</a:t>
             </a:r>
           </a:p>
         </p:txBody>
@@ -10552,7 +10552,7 @@
           <p:cNvPr id="3" name="">
             <a:extLst xmlns:a="http://schemas.openxmlformats.org/drawingml/2006/main">
               <a:ext uri="{FF2B5EF4-FFF2-40B4-BE49-F238E27FC236}">
-                <a16:creationId xmlns:a16="http://schemas.microsoft.com/office/drawing/2014/main" id="{E5C9DDE7-DD0F-434A-8975-5AEA4025A74C}"/>
+                <a16:creationId xmlns:a16="http://schemas.microsoft.com/office/drawing/2014/main" id="{D0BBD783-85F1-4925-B3DA-3AF45BC5805B}"/>
               </a:ext>
             </a:extLst>
           </p:cNvPr>
@@ -10585,7 +10585,7 @@
           <p:cNvPr id="4" name="">
             <a:extLst xmlns:a="http://schemas.openxmlformats.org/drawingml/2006/main">
               <a:ext uri="{FF2B5EF4-FFF2-40B4-BE49-F238E27FC236}">
-                <a16:creationId xmlns:a16="http://schemas.microsoft.com/office/drawing/2014/main" id="{08D52B16-BECB-48A7-8E81-DC0B76DA6493}"/>
+                <a16:creationId xmlns:a16="http://schemas.microsoft.com/office/drawing/2014/main" id="{C568DED7-91A4-4683-A486-DF83CBEE3429}"/>
               </a:ext>
             </a:extLst>
           </p:cNvPr>
@@ -10742,7 +10742,7 @@
           <p:cNvPr id="5" name="">
             <a:extLst xmlns:a="http://schemas.openxmlformats.org/drawingml/2006/main">
               <a:ext uri="{FF2B5EF4-FFF2-40B4-BE49-F238E27FC236}">
-                <a16:creationId xmlns:a16="http://schemas.microsoft.com/office/drawing/2014/main" id="{C1A8A01B-CEA2-4ACF-A60B-90DE6C2686D2}"/>
+                <a16:creationId xmlns:a16="http://schemas.microsoft.com/office/drawing/2014/main" id="{7306156A-5CF6-4625-843E-69FC019EEEDC}"/>
               </a:ext>
             </a:extLst>
           </p:cNvPr>
@@ -10889,7 +10889,7 @@
                 <a:ea typeface="Aptos"/>
                 <a:cs typeface="Aptos"/>
               </a:rPr>
-              <a:t>planned packages</a:t>
+              <a:t>of 456 checked</a:t>
             </a:r>
           </a:p>
         </p:txBody>
@@ -10899,7 +10899,7 @@
           <p:cNvPr id="6" name="">
             <a:extLst xmlns:a="http://schemas.openxmlformats.org/drawingml/2006/main">
               <a:ext uri="{FF2B5EF4-FFF2-40B4-BE49-F238E27FC236}">
-                <a16:creationId xmlns:a16="http://schemas.microsoft.com/office/drawing/2014/main" id="{CF2347AD-AB09-4BEB-9983-146BE82E72D0}"/>
+                <a16:creationId xmlns:a16="http://schemas.microsoft.com/office/drawing/2014/main" id="{2E629606-60D5-4EB3-A990-22D8C14CF65A}"/>
               </a:ext>
             </a:extLst>
           </p:cNvPr>
@@ -11046,7 +11046,7 @@
                 <a:ea typeface="Aptos Display"/>
                 <a:cs typeface="Aptos Display"/>
               </a:rPr>
-              <a:t>0</a:t>
+              <a:t>406</a:t>
             </a:r>
           </a:p>
         </p:txBody>
@@ -11056,7 +11056,7 @@
           <p:cNvPr id="7" name="">
             <a:extLst xmlns:a="http://schemas.openxmlformats.org/drawingml/2006/main">
               <a:ext uri="{FF2B5EF4-FFF2-40B4-BE49-F238E27FC236}">
-                <a16:creationId xmlns:a16="http://schemas.microsoft.com/office/drawing/2014/main" id="{FD7A1A00-67BA-43B4-8485-47464E2D7A04}"/>
+                <a16:creationId xmlns:a16="http://schemas.microsoft.com/office/drawing/2014/main" id="{F7787D1C-5033-4AAA-A7C1-C9F23FAAA90D}"/>
               </a:ext>
             </a:extLst>
           </p:cNvPr>
@@ -11203,7 +11203,7 @@
                 <a:ea typeface="Aptos"/>
                 <a:cs typeface="Aptos"/>
               </a:rPr>
-              <a:t>new model runs</a:t>
+              <a:t>compatible</a:t>
             </a:r>
           </a:p>
         </p:txBody>
@@ -11213,7 +11213,7 @@
           <p:cNvPr id="8" name="">
             <a:extLst xmlns:a="http://schemas.openxmlformats.org/drawingml/2006/main">
               <a:ext uri="{FF2B5EF4-FFF2-40B4-BE49-F238E27FC236}">
-                <a16:creationId xmlns:a16="http://schemas.microsoft.com/office/drawing/2014/main" id="{4CEF00A1-C771-4BCB-BBF9-99265B8A5C71}"/>
+                <a16:creationId xmlns:a16="http://schemas.microsoft.com/office/drawing/2014/main" id="{75C71EC0-2EB0-4D7D-8990-D175C3154F58}"/>
               </a:ext>
             </a:extLst>
           </p:cNvPr>
@@ -11360,7 +11360,7 @@
                 <a:ea typeface="Aptos Display"/>
                 <a:cs typeface="Aptos Display"/>
               </a:rPr>
-              <a:t>35</a:t>
+              <a:t>50</a:t>
             </a:r>
           </a:p>
         </p:txBody>
@@ -11370,7 +11370,7 @@
           <p:cNvPr id="9" name="">
             <a:extLst xmlns:a="http://schemas.openxmlformats.org/drawingml/2006/main">
               <a:ext uri="{FF2B5EF4-FFF2-40B4-BE49-F238E27FC236}">
-                <a16:creationId xmlns:a16="http://schemas.microsoft.com/office/drawing/2014/main" id="{BDA7319C-56CD-4ED5-8042-751FD80BE82C}"/>
+                <a16:creationId xmlns:a16="http://schemas.microsoft.com/office/drawing/2014/main" id="{0C052983-9419-4B2F-9008-06370D02F0F1}"/>
               </a:ext>
             </a:extLst>
           </p:cNvPr>
@@ -11517,7 +11517,7 @@
                 <a:ea typeface="Aptos"/>
                 <a:cs typeface="Aptos"/>
               </a:rPr>
-              <a:t>holdout tasks sealed</a:t>
+              <a:t>incompatible</a:t>
             </a:r>
           </a:p>
         </p:txBody>
@@ -11527,7 +11527,7 @@
           <p:cNvPr id="10" name="">
             <a:extLst xmlns:a="http://schemas.openxmlformats.org/drawingml/2006/main">
               <a:ext uri="{FF2B5EF4-FFF2-40B4-BE49-F238E27FC236}">
-                <a16:creationId xmlns:a16="http://schemas.microsoft.com/office/drawing/2014/main" id="{195BCA54-16C0-453D-9159-D3BA93BE8A23}"/>
+                <a16:creationId xmlns:a16="http://schemas.microsoft.com/office/drawing/2014/main" id="{356BFA59-0C84-4CA1-BF95-211BB58B8509}"/>
               </a:ext>
             </a:extLst>
           </p:cNvPr>
@@ -11560,7 +11560,7 @@
           <p:cNvPr id="11" name="">
             <a:extLst xmlns:a="http://schemas.openxmlformats.org/drawingml/2006/main">
               <a:ext uri="{FF2B5EF4-FFF2-40B4-BE49-F238E27FC236}">
-                <a16:creationId xmlns:a16="http://schemas.microsoft.com/office/drawing/2014/main" id="{36B5FFCF-5360-4982-B570-12B26670FC03}"/>
+                <a16:creationId xmlns:a16="http://schemas.microsoft.com/office/drawing/2014/main" id="{FB6DAA6B-ED27-4E18-8588-F86F6E0A4EDA}"/>
               </a:ext>
             </a:extLst>
           </p:cNvPr>
@@ -11707,7 +11707,7 @@
                 <a:ea typeface="Aptos Display"/>
                 <a:cs typeface="Aptos Display"/>
               </a:rPr>
-              <a:t>The compatibility screen is still running. Incompatibilities already recorded prevent new training or model evaluation. The full matrix is not yet a terminal result.</a:t>
+              <a:t>Because at least one task package was incompatible, the registered protocol stopped before qualification, training, or model evaluation.</a:t>
             </a:r>
           </a:p>
         </p:txBody>
@@ -11717,7 +11717,7 @@
           <p:cNvPr id="12" name="">
             <a:extLst xmlns:a="http://schemas.openxmlformats.org/drawingml/2006/main">
               <a:ext uri="{FF2B5EF4-FFF2-40B4-BE49-F238E27FC236}">
-                <a16:creationId xmlns:a16="http://schemas.microsoft.com/office/drawing/2014/main" id="{4B16DE82-736A-469B-B0C0-138FC8A40E99}"/>
+                <a16:creationId xmlns:a16="http://schemas.microsoft.com/office/drawing/2014/main" id="{E005BFC5-9386-4D08-8BB4-4C30D5FB0A60}"/>
               </a:ext>
             </a:extLst>
           </p:cNvPr>
@@ -11874,7 +11874,7 @@
           <p:cNvPr id="13" name="">
             <a:extLst xmlns:a="http://schemas.openxmlformats.org/drawingml/2006/main">
               <a:ext uri="{FF2B5EF4-FFF2-40B4-BE49-F238E27FC236}">
-                <a16:creationId xmlns:a16="http://schemas.microsoft.com/office/drawing/2014/main" id="{2A0FA241-CAC4-4ADE-84D8-8EBBF9C7CE0E}"/>
+                <a16:creationId xmlns:a16="http://schemas.microsoft.com/office/drawing/2014/main" id="{AE585819-1B23-4C62-ABCB-2AD76165EE24}"/>
               </a:ext>
             </a:extLst>
           </p:cNvPr>
@@ -12031,7 +12031,7 @@
           <p:cNvPr id="14" name="">
             <a:extLst xmlns:a="http://schemas.openxmlformats.org/drawingml/2006/main">
               <a:ext uri="{FF2B5EF4-FFF2-40B4-BE49-F238E27FC236}">
-                <a16:creationId xmlns:a16="http://schemas.microsoft.com/office/drawing/2014/main" id="{7ECF5D9E-FE42-4D06-B706-86483EF673D1}"/>
+                <a16:creationId xmlns:a16="http://schemas.microsoft.com/office/drawing/2014/main" id="{EACFA2F8-BE84-4636-937F-318715FE7D8A}"/>
               </a:ext>
             </a:extLst>
           </p:cNvPr>
@@ -12186,7 +12186,7 @@
     </p:spTree>
     <p:extLst>
       <p:ext uri="{BB962C8B-B14F-4D97-AF65-F5344CB8AC3E}">
-        <p14:creationId xmlns:p14="http://schemas.microsoft.com/office/powerpoint/2010/main" val="1539469604"/>
+        <p14:creationId xmlns:p14="http://schemas.microsoft.com/office/powerpoint/2010/main" val="882448876"/>
       </p:ext>
     </p:extLst>
   </p:cSld>
@@ -12217,7 +12217,7 @@
           <p:cNvPr id="17" name="">
             <a:extLst xmlns:a="http://schemas.openxmlformats.org/drawingml/2006/main">
               <a:ext uri="{FF2B5EF4-FFF2-40B4-BE49-F238E27FC236}">
-                <a16:creationId xmlns:a16="http://schemas.microsoft.com/office/drawing/2014/main" id="{D7B85EED-157E-4485-BEE5-C173B5027981}"/>
+                <a16:creationId xmlns:a16="http://schemas.microsoft.com/office/drawing/2014/main" id="{E69B719E-E643-4EBB-92C8-0C5BF59D8798}"/>
               </a:ext>
             </a:extLst>
           </p:cNvPr>
@@ -12374,7 +12374,7 @@
           <p:cNvPr id="2" name="">
             <a:extLst xmlns:a="http://schemas.openxmlformats.org/drawingml/2006/main">
               <a:ext uri="{FF2B5EF4-FFF2-40B4-BE49-F238E27FC236}">
-                <a16:creationId xmlns:a16="http://schemas.microsoft.com/office/drawing/2014/main" id="{E77316B2-ACD8-45F2-937A-14EFB816E5FA}"/>
+                <a16:creationId xmlns:a16="http://schemas.microsoft.com/office/drawing/2014/main" id="{203AA3E3-0144-431D-AA51-CD875D3C1BF7}"/>
               </a:ext>
             </a:extLst>
           </p:cNvPr>
@@ -12531,7 +12531,7 @@
           <p:cNvPr id="3" name="">
             <a:extLst xmlns:a="http://schemas.openxmlformats.org/drawingml/2006/main">
               <a:ext uri="{FF2B5EF4-FFF2-40B4-BE49-F238E27FC236}">
-                <a16:creationId xmlns:a16="http://schemas.microsoft.com/office/drawing/2014/main" id="{00D9BE37-8815-44F2-A3FB-030EECC026D5}"/>
+                <a16:creationId xmlns:a16="http://schemas.microsoft.com/office/drawing/2014/main" id="{F8B21C9C-77EE-44E7-A426-FD55BC41D9C7}"/>
               </a:ext>
             </a:extLst>
           </p:cNvPr>
@@ -12564,7 +12564,7 @@
           <p:cNvPr id="4" name="">
             <a:extLst xmlns:a="http://schemas.openxmlformats.org/drawingml/2006/main">
               <a:ext uri="{FF2B5EF4-FFF2-40B4-BE49-F238E27FC236}">
-                <a16:creationId xmlns:a16="http://schemas.microsoft.com/office/drawing/2014/main" id="{CDDEF5CD-8AF2-4893-9D99-2682BF4757C9}"/>
+                <a16:creationId xmlns:a16="http://schemas.microsoft.com/office/drawing/2014/main" id="{1DC9BF80-EBA2-4B16-80B8-9AC6C5C88529}"/>
               </a:ext>
             </a:extLst>
           </p:cNvPr>
@@ -12721,7 +12721,7 @@
           <p:cNvPr id="5" name="">
             <a:extLst xmlns:a="http://schemas.openxmlformats.org/drawingml/2006/main">
               <a:ext uri="{FF2B5EF4-FFF2-40B4-BE49-F238E27FC236}">
-                <a16:creationId xmlns:a16="http://schemas.microsoft.com/office/drawing/2014/main" id="{CE338345-6952-44F8-89BA-3A025FD24053}"/>
+                <a16:creationId xmlns:a16="http://schemas.microsoft.com/office/drawing/2014/main" id="{46EB4A1F-FD39-47CE-AC9C-B5132238AE8D}"/>
               </a:ext>
             </a:extLst>
           </p:cNvPr>
@@ -12878,7 +12878,7 @@
           <p:cNvPr id="6" name="">
             <a:extLst xmlns:a="http://schemas.openxmlformats.org/drawingml/2006/main">
               <a:ext uri="{FF2B5EF4-FFF2-40B4-BE49-F238E27FC236}">
-                <a16:creationId xmlns:a16="http://schemas.microsoft.com/office/drawing/2014/main" id="{A4750F86-0FAD-481B-8E0A-1998DE3ACBA2}"/>
+                <a16:creationId xmlns:a16="http://schemas.microsoft.com/office/drawing/2014/main" id="{EAA26BF8-EAA9-434C-A21A-0C83F816B089}"/>
               </a:ext>
             </a:extLst>
           </p:cNvPr>
@@ -13035,7 +13035,7 @@
           <p:cNvPr id="7" name="">
             <a:extLst xmlns:a="http://schemas.openxmlformats.org/drawingml/2006/main">
               <a:ext uri="{FF2B5EF4-FFF2-40B4-BE49-F238E27FC236}">
-                <a16:creationId xmlns:a16="http://schemas.microsoft.com/office/drawing/2014/main" id="{F7DAB5A4-9C6D-4DA3-801F-9EE4D58DD3F0}"/>
+                <a16:creationId xmlns:a16="http://schemas.microsoft.com/office/drawing/2014/main" id="{C489600F-791F-4098-93D9-14B7FD8FEF96}"/>
               </a:ext>
             </a:extLst>
           </p:cNvPr>
@@ -13192,7 +13192,7 @@
           <p:cNvPr id="8" name="">
             <a:extLst xmlns:a="http://schemas.openxmlformats.org/drawingml/2006/main">
               <a:ext uri="{FF2B5EF4-FFF2-40B4-BE49-F238E27FC236}">
-                <a16:creationId xmlns:a16="http://schemas.microsoft.com/office/drawing/2014/main" id="{41188A3E-455C-4512-9F00-F3C7668148E0}"/>
+                <a16:creationId xmlns:a16="http://schemas.microsoft.com/office/drawing/2014/main" id="{E54BC07A-0694-439B-BB15-5EC90FA13312}"/>
               </a:ext>
             </a:extLst>
           </p:cNvPr>
@@ -13349,7 +13349,7 @@
           <p:cNvPr id="9" name="">
             <a:extLst xmlns:a="http://schemas.openxmlformats.org/drawingml/2006/main">
               <a:ext uri="{FF2B5EF4-FFF2-40B4-BE49-F238E27FC236}">
-                <a16:creationId xmlns:a16="http://schemas.microsoft.com/office/drawing/2014/main" id="{08295D5F-CCA8-4DA3-BC86-31AA32578C28}"/>
+                <a16:creationId xmlns:a16="http://schemas.microsoft.com/office/drawing/2014/main" id="{265D3CA0-0BA4-4DC3-B49D-5E739240B156}"/>
               </a:ext>
             </a:extLst>
           </p:cNvPr>
@@ -13506,7 +13506,7 @@
           <p:cNvPr id="10" name="">
             <a:extLst xmlns:a="http://schemas.openxmlformats.org/drawingml/2006/main">
               <a:ext uri="{FF2B5EF4-FFF2-40B4-BE49-F238E27FC236}">
-                <a16:creationId xmlns:a16="http://schemas.microsoft.com/office/drawing/2014/main" id="{22C4ABDD-0056-4487-BD9E-26BB1B512683}"/>
+                <a16:creationId xmlns:a16="http://schemas.microsoft.com/office/drawing/2014/main" id="{F0ECEAE9-8C68-4F60-9B91-303818A449BC}"/>
               </a:ext>
             </a:extLst>
           </p:cNvPr>
@@ -13516,7 +13516,7 @@
           <p:nvPr/>
         </p:nvPicPr>
         <p:blipFill>
-          <a:blip xmlns:r="http://schemas.openxmlformats.org/officeDocument/2006/relationships" xmlns:a="http://schemas.openxmlformats.org/drawingml/2006/main" r:embed="Raec655f4845a4e4f"/>
+          <a:blip xmlns:r="http://schemas.openxmlformats.org/officeDocument/2006/relationships" xmlns:a="http://schemas.openxmlformats.org/drawingml/2006/main" r:embed="Rc56cb6b5afd648b0"/>
           <a:srcRect xmlns:a="http://schemas.openxmlformats.org/drawingml/2006/main" l="32479" t="0" r="32479" b="0"/>
           <a:stretch xmlns:a="http://schemas.openxmlformats.org/drawingml/2006/main">
             <a:fillRect l="0" t="0" r="0" b="0"/>
@@ -13537,7 +13537,7 @@
           <p:cNvPr id="11" name="">
             <a:extLst xmlns:a="http://schemas.openxmlformats.org/drawingml/2006/main">
               <a:ext uri="{FF2B5EF4-FFF2-40B4-BE49-F238E27FC236}">
-                <a16:creationId xmlns:a16="http://schemas.microsoft.com/office/drawing/2014/main" id="{C2604EE1-43B4-4696-A2A3-231E677DC938}"/>
+                <a16:creationId xmlns:a16="http://schemas.microsoft.com/office/drawing/2014/main" id="{C9563605-2C5C-4641-9712-AECDD250E537}"/>
               </a:ext>
             </a:extLst>
           </p:cNvPr>
@@ -13547,7 +13547,7 @@
           <p:nvPr/>
         </p:nvPicPr>
         <p:blipFill>
-          <a:blip xmlns:r="http://schemas.openxmlformats.org/officeDocument/2006/relationships" xmlns:a="http://schemas.openxmlformats.org/drawingml/2006/main" r:embed="R28a007d0950d4302"/>
+          <a:blip xmlns:r="http://schemas.openxmlformats.org/officeDocument/2006/relationships" xmlns:a="http://schemas.openxmlformats.org/drawingml/2006/main" r:embed="R4c38dc4919f645ac"/>
           <a:stretch xmlns:a="http://schemas.openxmlformats.org/drawingml/2006/main"/>
         </p:blipFill>
         <p:spPr>
@@ -13565,7 +13565,7 @@
           <p:cNvPr id="12" name="">
             <a:extLst xmlns:a="http://schemas.openxmlformats.org/drawingml/2006/main">
               <a:ext uri="{FF2B5EF4-FFF2-40B4-BE49-F238E27FC236}">
-                <a16:creationId xmlns:a16="http://schemas.microsoft.com/office/drawing/2014/main" id="{A23843B8-B8E8-4F3A-9C4E-67ABA66C2D1D}"/>
+                <a16:creationId xmlns:a16="http://schemas.microsoft.com/office/drawing/2014/main" id="{16AEB497-5F0D-42AE-8729-0B518F502265}"/>
               </a:ext>
             </a:extLst>
           </p:cNvPr>
@@ -13575,7 +13575,7 @@
           <p:nvPr/>
         </p:nvPicPr>
         <p:blipFill>
-          <a:blip xmlns:r="http://schemas.openxmlformats.org/officeDocument/2006/relationships" xmlns:a="http://schemas.openxmlformats.org/drawingml/2006/main" r:embed="R9d44cdfbb4ed408c"/>
+          <a:blip xmlns:r="http://schemas.openxmlformats.org/officeDocument/2006/relationships" xmlns:a="http://schemas.openxmlformats.org/drawingml/2006/main" r:embed="R07b7386f57874cce"/>
           <a:stretch xmlns:a="http://schemas.openxmlformats.org/drawingml/2006/main"/>
         </p:blipFill>
         <p:spPr>
@@ -13593,7 +13593,7 @@
           <p:cNvPr id="13" name="">
             <a:extLst xmlns:a="http://schemas.openxmlformats.org/drawingml/2006/main">
               <a:ext uri="{FF2B5EF4-FFF2-40B4-BE49-F238E27FC236}">
-                <a16:creationId xmlns:a16="http://schemas.microsoft.com/office/drawing/2014/main" id="{9542B711-105B-405A-8386-5646956A37BF}"/>
+                <a16:creationId xmlns:a16="http://schemas.microsoft.com/office/drawing/2014/main" id="{EF9D9822-F928-4749-98F7-B43B574B7C42}"/>
               </a:ext>
             </a:extLst>
           </p:cNvPr>
@@ -13626,7 +13626,7 @@
           <p:cNvPr id="14" name="">
             <a:extLst xmlns:a="http://schemas.openxmlformats.org/drawingml/2006/main">
               <a:ext uri="{FF2B5EF4-FFF2-40B4-BE49-F238E27FC236}">
-                <a16:creationId xmlns:a16="http://schemas.microsoft.com/office/drawing/2014/main" id="{AE8EF024-3C0A-4E06-A068-CCB9F5A87D60}"/>
+                <a16:creationId xmlns:a16="http://schemas.microsoft.com/office/drawing/2014/main" id="{E86F2AE0-8366-41DF-AAB9-FA7C232DDA89}"/>
               </a:ext>
             </a:extLst>
           </p:cNvPr>
@@ -13783,7 +13783,7 @@
           <p:cNvPr id="15" name="">
             <a:extLst xmlns:a="http://schemas.openxmlformats.org/drawingml/2006/main">
               <a:ext uri="{FF2B5EF4-FFF2-40B4-BE49-F238E27FC236}">
-                <a16:creationId xmlns:a16="http://schemas.microsoft.com/office/drawing/2014/main" id="{A93CB527-92DD-4AAF-B895-8F199ABD09DE}"/>
+                <a16:creationId xmlns:a16="http://schemas.microsoft.com/office/drawing/2014/main" id="{7553DBC6-CC5D-44C4-AC7D-D0D38F34A136}"/>
               </a:ext>
             </a:extLst>
           </p:cNvPr>
@@ -13940,7 +13940,7 @@
           <p:cNvPr id="16" name="">
             <a:extLst xmlns:a="http://schemas.openxmlformats.org/drawingml/2006/main">
               <a:ext uri="{FF2B5EF4-FFF2-40B4-BE49-F238E27FC236}">
-                <a16:creationId xmlns:a16="http://schemas.microsoft.com/office/drawing/2014/main" id="{EB9E4162-7BCD-474B-8F28-533C07D57155}"/>
+                <a16:creationId xmlns:a16="http://schemas.microsoft.com/office/drawing/2014/main" id="{D8A7D271-E4CB-44FE-A406-3BE7D88168CF}"/>
               </a:ext>
             </a:extLst>
           </p:cNvPr>
@@ -14095,7 +14095,7 @@
     </p:spTree>
     <p:extLst>
       <p:ext uri="{BB962C8B-B14F-4D97-AF65-F5344CB8AC3E}">
-        <p14:creationId xmlns:p14="http://schemas.microsoft.com/office/powerpoint/2010/main" val="598657892"/>
+        <p14:creationId xmlns:p14="http://schemas.microsoft.com/office/powerpoint/2010/main" val="160816975"/>
       </p:ext>
     </p:extLst>
   </p:cSld>

</xml_diff>

<commit_message>
Publish Mini Gibson terminal R3 findings and final demo
Verified 456-task compatibility preflight, immutable evidence, final deck, and 3:44 demo. V1 not promoted; no new model result; holdout sealed.
</commit_message>
<xml_diff>
--- a/presentation/final-findings/mini-gibson-final-findings.pptx
+++ b/presentation/final-findings/mini-gibson-final-findings.pptx
@@ -2,18 +2,18 @@
 <file path=ppt/presentation.xml><?xml version="1.0" encoding="utf-8"?>
 <p:presentation xmlns:p="http://schemas.openxmlformats.org/presentationml/2006/main">
   <p:sldMasterIdLst>
-    <p:sldMasterId xmlns:r="http://schemas.openxmlformats.org/officeDocument/2006/relationships" id="2147483648" r:id="Rd92df3121d94483d"/>
+    <p:sldMasterId xmlns:r="http://schemas.openxmlformats.org/officeDocument/2006/relationships" id="2147483648" r:id="R228e00e7d04d4b82"/>
   </p:sldMasterIdLst>
   <p:notesMasterIdLst>
-    <p:notesMasterId xmlns:r="http://schemas.openxmlformats.org/officeDocument/2006/relationships" r:id="R04424d0d45e54960"/>
+    <p:notesMasterId xmlns:r="http://schemas.openxmlformats.org/officeDocument/2006/relationships" r:id="R335f6d91bb6d4037"/>
   </p:notesMasterIdLst>
   <p:sldIdLst>
-    <p:sldId xmlns:r="http://schemas.openxmlformats.org/officeDocument/2006/relationships" id="256" r:id="R0087295a337c410c"/>
-    <p:sldId xmlns:r="http://schemas.openxmlformats.org/officeDocument/2006/relationships" id="257" r:id="Rd14cb8d24efb4352"/>
-    <p:sldId xmlns:r="http://schemas.openxmlformats.org/officeDocument/2006/relationships" id="258" r:id="R958eb2264ada438b"/>
-    <p:sldId xmlns:r="http://schemas.openxmlformats.org/officeDocument/2006/relationships" id="259" r:id="Rb22d64c770754630"/>
-    <p:sldId xmlns:r="http://schemas.openxmlformats.org/officeDocument/2006/relationships" id="260" r:id="R2790cfa1a22c46a4"/>
-    <p:sldId xmlns:r="http://schemas.openxmlformats.org/officeDocument/2006/relationships" id="261" r:id="R08c86a6463014750"/>
+    <p:sldId xmlns:r="http://schemas.openxmlformats.org/officeDocument/2006/relationships" id="256" r:id="R28229b615e8e4112"/>
+    <p:sldId xmlns:r="http://schemas.openxmlformats.org/officeDocument/2006/relationships" id="257" r:id="R9766d6578311410e"/>
+    <p:sldId xmlns:r="http://schemas.openxmlformats.org/officeDocument/2006/relationships" id="258" r:id="R3adbb34cfcea4278"/>
+    <p:sldId xmlns:r="http://schemas.openxmlformats.org/officeDocument/2006/relationships" id="259" r:id="R65b136299f1d4c7e"/>
+    <p:sldId xmlns:r="http://schemas.openxmlformats.org/officeDocument/2006/relationships" id="260" r:id="R4eaf2ec2aa6d4899"/>
+    <p:sldId xmlns:r="http://schemas.openxmlformats.org/officeDocument/2006/relationships" id="261" r:id="Rf55cb5d7e5f347c8"/>
   </p:sldIdLst>
   <p:sldSz cx="12192000" cy="6858000"/>
   <p:notesSz cx="6858000" cy="9144000"/>
@@ -727,7 +727,7 @@
           <a:lstStyle xmlns:a="http://schemas.openxmlformats.org/drawingml/2006/main"/>
           <a:p xmlns:a="http://schemas.openxmlformats.org/drawingml/2006/main">
             <a:r>
-              <a:t>Interim submission: the frozen plan has 456 task packages, the 35-task final holdout is sealed, and the active compatibility preflight has produced no new model result. The matrix is not terminal; live compatibility counts are intentionally omitted. Source: docs/evidence/mini-gibson-successor-2026-10-18/PROTOCOL.md and the public R3 progress note.</a:t>
+              <a:t>Source: docs/evidence/mini-gibson-successor-2026-10-18/. Verified terminal values are 456/456 checked, 406 compatible, 50 incompatible. This compatibility preflight ran no models, agents, parsers, tests, or formal comparisons.</a:t>
             </a:r>
           </a:p>
         </p:txBody>
@@ -844,7 +844,7 @@
           <p:cNvPr id="3" name="Title">
             <a:extLst xmlns:a="http://schemas.openxmlformats.org/drawingml/2006/main">
               <a:ext uri="{FF2B5EF4-FFF2-40B4-BE49-F238E27FC236}">
-                <a16:creationId xmlns:a16="http://schemas.microsoft.com/office/drawing/2014/main" id="{CEA52C54-FF71-4B9A-8ED4-7DBDCDA9922F}"/>
+                <a16:creationId xmlns:a16="http://schemas.microsoft.com/office/drawing/2014/main" id="{0CECD57B-461E-4036-A885-5078CAAEAEF0}"/>
               </a:ext>
             </a:extLst>
           </p:cNvPr>
@@ -1073,7 +1073,7 @@
           <p:cNvPr id="2" name="Subtitle">
             <a:extLst xmlns:a="http://schemas.openxmlformats.org/drawingml/2006/main">
               <a:ext uri="{FF2B5EF4-FFF2-40B4-BE49-F238E27FC236}">
-                <a16:creationId xmlns:a16="http://schemas.microsoft.com/office/drawing/2014/main" id="{29011579-E047-47A2-93A9-50E88E02C75D}"/>
+                <a16:creationId xmlns:a16="http://schemas.microsoft.com/office/drawing/2014/main" id="{D59789C0-02F5-4784-9140-6E0D9A54EAE8}"/>
               </a:ext>
             </a:extLst>
           </p:cNvPr>
@@ -1319,7 +1319,7 @@
           <p:cNvPr id="2" name="Section title">
             <a:extLst xmlns:a="http://schemas.openxmlformats.org/drawingml/2006/main">
               <a:ext uri="{FF2B5EF4-FFF2-40B4-BE49-F238E27FC236}">
-                <a16:creationId xmlns:a16="http://schemas.microsoft.com/office/drawing/2014/main" id="{E2E25C63-6FF2-4DE6-B7BB-E95F55E1798E}"/>
+                <a16:creationId xmlns:a16="http://schemas.microsoft.com/office/drawing/2014/main" id="{01259C17-048C-420F-B1A0-03E10C179408}"/>
               </a:ext>
             </a:extLst>
           </p:cNvPr>
@@ -1565,7 +1565,7 @@
           <p:cNvPr id="3" name="Title">
             <a:extLst xmlns:a="http://schemas.openxmlformats.org/drawingml/2006/main">
               <a:ext uri="{FF2B5EF4-FFF2-40B4-BE49-F238E27FC236}">
-                <a16:creationId xmlns:a16="http://schemas.microsoft.com/office/drawing/2014/main" id="{0498A94E-C513-44E0-8091-304BC5C2E18A}"/>
+                <a16:creationId xmlns:a16="http://schemas.microsoft.com/office/drawing/2014/main" id="{F1E791F1-32AB-4E77-8359-519091BA50D0}"/>
               </a:ext>
             </a:extLst>
           </p:cNvPr>
@@ -1794,7 +1794,7 @@
           <p:cNvPr id="2" name="Body">
             <a:extLst xmlns:a="http://schemas.openxmlformats.org/drawingml/2006/main">
               <a:ext uri="{FF2B5EF4-FFF2-40B4-BE49-F238E27FC236}">
-                <a16:creationId xmlns:a16="http://schemas.microsoft.com/office/drawing/2014/main" id="{8885E0DA-51F9-4A61-BA93-AE6A83910D3F}"/>
+                <a16:creationId xmlns:a16="http://schemas.microsoft.com/office/drawing/2014/main" id="{2D986528-63B7-4611-B7FB-E446A6A5FEAC}"/>
               </a:ext>
             </a:extLst>
           </p:cNvPr>
@@ -2040,7 +2040,7 @@
           <p:cNvPr id="4" name="Title">
             <a:extLst xmlns:a="http://schemas.openxmlformats.org/drawingml/2006/main">
               <a:ext uri="{FF2B5EF4-FFF2-40B4-BE49-F238E27FC236}">
-                <a16:creationId xmlns:a16="http://schemas.microsoft.com/office/drawing/2014/main" id="{C27CDF30-41C2-49D7-A33F-D6AD3203107D}"/>
+                <a16:creationId xmlns:a16="http://schemas.microsoft.com/office/drawing/2014/main" id="{A38D6F1D-4E56-438B-8E46-96B2E9A88CF3}"/>
               </a:ext>
             </a:extLst>
           </p:cNvPr>
@@ -2269,7 +2269,7 @@
           <p:cNvPr id="2" name="Left column">
             <a:extLst xmlns:a="http://schemas.openxmlformats.org/drawingml/2006/main">
               <a:ext uri="{FF2B5EF4-FFF2-40B4-BE49-F238E27FC236}">
-                <a16:creationId xmlns:a16="http://schemas.microsoft.com/office/drawing/2014/main" id="{B46854A0-D4E5-4A23-A9A7-E2BBD8E20301}"/>
+                <a16:creationId xmlns:a16="http://schemas.microsoft.com/office/drawing/2014/main" id="{E2926DB4-607F-4AE8-8378-76AE0163C4EF}"/>
               </a:ext>
             </a:extLst>
           </p:cNvPr>
@@ -2498,7 +2498,7 @@
           <p:cNvPr id="3" name="Right column">
             <a:extLst xmlns:a="http://schemas.openxmlformats.org/drawingml/2006/main">
               <a:ext uri="{FF2B5EF4-FFF2-40B4-BE49-F238E27FC236}">
-                <a16:creationId xmlns:a16="http://schemas.microsoft.com/office/drawing/2014/main" id="{4B54952A-9C4B-4490-B495-C6F44EEEB429}"/>
+                <a16:creationId xmlns:a16="http://schemas.microsoft.com/office/drawing/2014/main" id="{B182E208-C9FB-4283-A963-4EF5A9D3E670}"/>
               </a:ext>
             </a:extLst>
           </p:cNvPr>
@@ -2744,7 +2744,7 @@
           <p:cNvPr id="3" name="Title">
             <a:extLst xmlns:a="http://schemas.openxmlformats.org/drawingml/2006/main">
               <a:ext uri="{FF2B5EF4-FFF2-40B4-BE49-F238E27FC236}">
-                <a16:creationId xmlns:a16="http://schemas.microsoft.com/office/drawing/2014/main" id="{26C486F4-5743-410E-A0BE-DAA390F44BCD}"/>
+                <a16:creationId xmlns:a16="http://schemas.microsoft.com/office/drawing/2014/main" id="{1554577F-6D17-4D89-9EE1-8A2996A462EE}"/>
               </a:ext>
             </a:extLst>
           </p:cNvPr>
@@ -2973,7 +2973,7 @@
           <p:cNvPr id="2" name="Left column">
             <a:extLst xmlns:a="http://schemas.openxmlformats.org/drawingml/2006/main">
               <a:ext uri="{FF2B5EF4-FFF2-40B4-BE49-F238E27FC236}">
-                <a16:creationId xmlns:a16="http://schemas.microsoft.com/office/drawing/2014/main" id="{9F65DE71-6B6A-4728-B697-731C75437DF9}"/>
+                <a16:creationId xmlns:a16="http://schemas.microsoft.com/office/drawing/2014/main" id="{52A5D8A3-B692-4895-8361-578E7803D53C}"/>
               </a:ext>
             </a:extLst>
           </p:cNvPr>
@@ -3240,12 +3240,12 @@
   </p:cSld>
   <p:clrMap bg1="lt1" tx1="dk1" bg2="lt2" tx2="dk2" accent1="accent1" accent2="accent2" accent3="accent3" accent4="accent4" accent5="accent5" accent6="accent6" hlink="hlink" folHlink="folHlink"/>
   <p:sldLayoutIdLst>
-    <p:sldLayoutId xmlns:r="http://schemas.openxmlformats.org/officeDocument/2006/relationships" id="2147483649" r:id="Rf0a83f315a384925"/>
-    <p:sldLayoutId xmlns:r="http://schemas.openxmlformats.org/officeDocument/2006/relationships" id="2147483650" r:id="R72e724291e6245bd"/>
-    <p:sldLayoutId xmlns:r="http://schemas.openxmlformats.org/officeDocument/2006/relationships" id="2147483651" r:id="R60022d6f99214611"/>
-    <p:sldLayoutId xmlns:r="http://schemas.openxmlformats.org/officeDocument/2006/relationships" id="2147483652" r:id="R758234c3cc974ad1"/>
-    <p:sldLayoutId xmlns:r="http://schemas.openxmlformats.org/officeDocument/2006/relationships" id="2147483653" r:id="Rb19b1f9f2c064f95"/>
-    <p:sldLayoutId xmlns:r="http://schemas.openxmlformats.org/officeDocument/2006/relationships" id="2147483654" r:id="Ra7e793e2cb7a40a8"/>
+    <p:sldLayoutId xmlns:r="http://schemas.openxmlformats.org/officeDocument/2006/relationships" id="2147483649" r:id="R4f76108fd85a4c68"/>
+    <p:sldLayoutId xmlns:r="http://schemas.openxmlformats.org/officeDocument/2006/relationships" id="2147483650" r:id="Rdfe6280cdbe84cfd"/>
+    <p:sldLayoutId xmlns:r="http://schemas.openxmlformats.org/officeDocument/2006/relationships" id="2147483651" r:id="R32eb3d615d7f4794"/>
+    <p:sldLayoutId xmlns:r="http://schemas.openxmlformats.org/officeDocument/2006/relationships" id="2147483652" r:id="Rc4d26a27de314d37"/>
+    <p:sldLayoutId xmlns:r="http://schemas.openxmlformats.org/officeDocument/2006/relationships" id="2147483653" r:id="R771485174862431f"/>
+    <p:sldLayoutId xmlns:r="http://schemas.openxmlformats.org/officeDocument/2006/relationships" id="2147483654" r:id="R64660e3ba88b4002"/>
   </p:sldLayoutIdLst>
   <p:txStyles>
     <p:titleStyle>
@@ -4092,7 +4092,7 @@
           <p:cNvPr id="9" name="">
             <a:extLst xmlns:a="http://schemas.openxmlformats.org/drawingml/2006/main">
               <a:ext uri="{FF2B5EF4-FFF2-40B4-BE49-F238E27FC236}">
-                <a16:creationId xmlns:a16="http://schemas.microsoft.com/office/drawing/2014/main" id="{57FFEFF9-C4E0-499E-A225-72D982568A38}"/>
+                <a16:creationId xmlns:a16="http://schemas.microsoft.com/office/drawing/2014/main" id="{D9F82EB2-7232-46CF-B20D-58EE29D06926}"/>
               </a:ext>
             </a:extLst>
           </p:cNvPr>
@@ -4102,7 +4102,7 @@
           <p:nvPr/>
         </p:nvPicPr>
         <p:blipFill>
-          <a:blip xmlns:r="http://schemas.openxmlformats.org/officeDocument/2006/relationships" xmlns:a="http://schemas.openxmlformats.org/drawingml/2006/main" r:embed="Rc8a0d434e4ab4d87"/>
+          <a:blip xmlns:r="http://schemas.openxmlformats.org/officeDocument/2006/relationships" xmlns:a="http://schemas.openxmlformats.org/drawingml/2006/main" r:embed="R7d3720c212ea4360"/>
           <a:srcRect xmlns:a="http://schemas.openxmlformats.org/drawingml/2006/main" l="0" t="27" r="0" b="27"/>
           <a:stretch xmlns:a="http://schemas.openxmlformats.org/drawingml/2006/main">
             <a:fillRect l="0" t="0" r="0" b="0"/>
@@ -4123,7 +4123,7 @@
           <p:cNvPr id="2" name="">
             <a:extLst xmlns:a="http://schemas.openxmlformats.org/drawingml/2006/main">
               <a:ext uri="{FF2B5EF4-FFF2-40B4-BE49-F238E27FC236}">
-                <a16:creationId xmlns:a16="http://schemas.microsoft.com/office/drawing/2014/main" id="{9FCF48CA-131F-4812-BAE0-6F7C8A34D5CE}"/>
+                <a16:creationId xmlns:a16="http://schemas.microsoft.com/office/drawing/2014/main" id="{F33968B4-BB05-4530-8ADC-E3AAB9C6E7FA}"/>
               </a:ext>
             </a:extLst>
           </p:cNvPr>
@@ -4133,7 +4133,7 @@
           <p:nvPr/>
         </p:nvPicPr>
         <p:blipFill>
-          <a:blip xmlns:r="http://schemas.openxmlformats.org/officeDocument/2006/relationships" xmlns:a="http://schemas.openxmlformats.org/drawingml/2006/main" r:embed="R59f84bd9c3bb41e6"/>
+          <a:blip xmlns:r="http://schemas.openxmlformats.org/officeDocument/2006/relationships" xmlns:a="http://schemas.openxmlformats.org/drawingml/2006/main" r:embed="Rca37b0cb31624831"/>
           <a:stretch xmlns:a="http://schemas.openxmlformats.org/drawingml/2006/main"/>
         </p:blipFill>
         <p:spPr>
@@ -4151,7 +4151,7 @@
           <p:cNvPr id="3" name="">
             <a:extLst xmlns:a="http://schemas.openxmlformats.org/drawingml/2006/main">
               <a:ext uri="{FF2B5EF4-FFF2-40B4-BE49-F238E27FC236}">
-                <a16:creationId xmlns:a16="http://schemas.microsoft.com/office/drawing/2014/main" id="{B6C797A1-12FB-49DA-A432-8FEE02615F79}"/>
+                <a16:creationId xmlns:a16="http://schemas.microsoft.com/office/drawing/2014/main" id="{312B65BA-EF7D-4C0C-8069-312C52EDDDA3}"/>
               </a:ext>
             </a:extLst>
           </p:cNvPr>
@@ -4308,7 +4308,7 @@
           <p:cNvPr id="4" name="">
             <a:extLst xmlns:a="http://schemas.openxmlformats.org/drawingml/2006/main">
               <a:ext uri="{FF2B5EF4-FFF2-40B4-BE49-F238E27FC236}">
-                <a16:creationId xmlns:a16="http://schemas.microsoft.com/office/drawing/2014/main" id="{E629CAAF-B0D9-4205-8E3B-E373F41EC800}"/>
+                <a16:creationId xmlns:a16="http://schemas.microsoft.com/office/drawing/2014/main" id="{5F177454-F102-4644-A2AE-998299A5EE3A}"/>
               </a:ext>
             </a:extLst>
           </p:cNvPr>
@@ -4465,7 +4465,7 @@
           <p:cNvPr id="5" name="">
             <a:extLst xmlns:a="http://schemas.openxmlformats.org/drawingml/2006/main">
               <a:ext uri="{FF2B5EF4-FFF2-40B4-BE49-F238E27FC236}">
-                <a16:creationId xmlns:a16="http://schemas.microsoft.com/office/drawing/2014/main" id="{C0AEEFCD-D739-48C0-9654-F2DCE00BE693}"/>
+                <a16:creationId xmlns:a16="http://schemas.microsoft.com/office/drawing/2014/main" id="{B76B1F77-6D31-4F0A-851D-1C9B1739B820}"/>
               </a:ext>
             </a:extLst>
           </p:cNvPr>
@@ -4622,7 +4622,7 @@
           <p:cNvPr id="6" name="">
             <a:extLst xmlns:a="http://schemas.openxmlformats.org/drawingml/2006/main">
               <a:ext uri="{FF2B5EF4-FFF2-40B4-BE49-F238E27FC236}">
-                <a16:creationId xmlns:a16="http://schemas.microsoft.com/office/drawing/2014/main" id="{2742784F-5694-442E-81DD-9E9324344DEC}"/>
+                <a16:creationId xmlns:a16="http://schemas.microsoft.com/office/drawing/2014/main" id="{2C61AF16-4813-4152-B4B3-FE65B87BD8C4}"/>
               </a:ext>
             </a:extLst>
           </p:cNvPr>
@@ -4655,7 +4655,7 @@
           <p:cNvPr id="7" name="">
             <a:extLst xmlns:a="http://schemas.openxmlformats.org/drawingml/2006/main">
               <a:ext uri="{FF2B5EF4-FFF2-40B4-BE49-F238E27FC236}">
-                <a16:creationId xmlns:a16="http://schemas.microsoft.com/office/drawing/2014/main" id="{26B94FA8-8E2A-4C17-B876-E398E2CBE629}"/>
+                <a16:creationId xmlns:a16="http://schemas.microsoft.com/office/drawing/2014/main" id="{5EC8AD85-18A7-45AD-9235-DBB6D3271339}"/>
               </a:ext>
             </a:extLst>
           </p:cNvPr>
@@ -4667,7 +4667,7 @@
         <p:spPr>
           <a:xfrm xmlns:a="http://schemas.openxmlformats.org/drawingml/2006/main">
             <a:off x="723900" y="4524375"/>
-            <a:ext cx="5810250" cy="381000"/>
+            <a:ext cx="6477000" cy="381000"/>
           </a:xfrm>
           <a:prstGeom xmlns:a="http://schemas.openxmlformats.org/drawingml/2006/main" prst="rect">
             <a:avLst/>
@@ -4802,7 +4802,7 @@
                 <a:ea typeface="Aptos"/>
                 <a:cs typeface="Aptos"/>
               </a:rPr>
-              <a:t>Mark Hinkle  /  John Willis</a:t>
+              <a:t>Merge-Geezers  /  Mark Hinkle + John Willis</a:t>
             </a:r>
           </a:p>
         </p:txBody>
@@ -4812,7 +4812,7 @@
           <p:cNvPr id="8" name="">
             <a:extLst xmlns:a="http://schemas.openxmlformats.org/drawingml/2006/main">
               <a:ext uri="{FF2B5EF4-FFF2-40B4-BE49-F238E27FC236}">
-                <a16:creationId xmlns:a16="http://schemas.microsoft.com/office/drawing/2014/main" id="{EEBD5D67-E833-4539-8FA5-70C9B7199703}"/>
+                <a16:creationId xmlns:a16="http://schemas.microsoft.com/office/drawing/2014/main" id="{1DA8B479-27DE-44F2-8E03-43268E700AAF}"/>
               </a:ext>
             </a:extLst>
           </p:cNvPr>
@@ -4967,7 +4967,7 @@
     </p:spTree>
     <p:extLst>
       <p:ext uri="{BB962C8B-B14F-4D97-AF65-F5344CB8AC3E}">
-        <p14:creationId xmlns:p14="http://schemas.microsoft.com/office/powerpoint/2010/main" val="2063065042"/>
+        <p14:creationId xmlns:p14="http://schemas.microsoft.com/office/powerpoint/2010/main" val="1868102783"/>
       </p:ext>
     </p:extLst>
   </p:cSld>
@@ -4998,7 +4998,7 @@
           <p:cNvPr id="13" name="">
             <a:extLst xmlns:a="http://schemas.openxmlformats.org/drawingml/2006/main">
               <a:ext uri="{FF2B5EF4-FFF2-40B4-BE49-F238E27FC236}">
-                <a16:creationId xmlns:a16="http://schemas.microsoft.com/office/drawing/2014/main" id="{49A3B2E7-09CB-4877-AFCC-1A1BC2A47E9A}"/>
+                <a16:creationId xmlns:a16="http://schemas.microsoft.com/office/drawing/2014/main" id="{703127A8-91FC-47CF-A5C6-E12570BB65EF}"/>
               </a:ext>
             </a:extLst>
           </p:cNvPr>
@@ -5155,7 +5155,7 @@
           <p:cNvPr id="2" name="">
             <a:extLst xmlns:a="http://schemas.openxmlformats.org/drawingml/2006/main">
               <a:ext uri="{FF2B5EF4-FFF2-40B4-BE49-F238E27FC236}">
-                <a16:creationId xmlns:a16="http://schemas.microsoft.com/office/drawing/2014/main" id="{A2290C93-74A8-4918-B3EB-ADF40B7BC6C2}"/>
+                <a16:creationId xmlns:a16="http://schemas.microsoft.com/office/drawing/2014/main" id="{95251026-80EB-4355-80F7-B2DD57A976E4}"/>
               </a:ext>
             </a:extLst>
           </p:cNvPr>
@@ -5312,7 +5312,7 @@
           <p:cNvPr id="3" name="">
             <a:extLst xmlns:a="http://schemas.openxmlformats.org/drawingml/2006/main">
               <a:ext uri="{FF2B5EF4-FFF2-40B4-BE49-F238E27FC236}">
-                <a16:creationId xmlns:a16="http://schemas.microsoft.com/office/drawing/2014/main" id="{70ED0BCE-352F-4D3D-990E-027CDC8276AE}"/>
+                <a16:creationId xmlns:a16="http://schemas.microsoft.com/office/drawing/2014/main" id="{0E99374D-F971-4B75-932C-B9250B52A370}"/>
               </a:ext>
             </a:extLst>
           </p:cNvPr>
@@ -5345,7 +5345,7 @@
           <p:cNvPr id="4" name="">
             <a:extLst xmlns:a="http://schemas.openxmlformats.org/drawingml/2006/main">
               <a:ext uri="{FF2B5EF4-FFF2-40B4-BE49-F238E27FC236}">
-                <a16:creationId xmlns:a16="http://schemas.microsoft.com/office/drawing/2014/main" id="{B32D7DA9-30E7-449E-8B92-0DCECBC58EA7}"/>
+                <a16:creationId xmlns:a16="http://schemas.microsoft.com/office/drawing/2014/main" id="{274C81EB-1795-437B-A23D-08F2E40EDCB0}"/>
               </a:ext>
             </a:extLst>
           </p:cNvPr>
@@ -5502,7 +5502,7 @@
           <p:cNvPr id="5" name="">
             <a:extLst xmlns:a="http://schemas.openxmlformats.org/drawingml/2006/main">
               <a:ext uri="{FF2B5EF4-FFF2-40B4-BE49-F238E27FC236}">
-                <a16:creationId xmlns:a16="http://schemas.microsoft.com/office/drawing/2014/main" id="{FC32FF9E-CFF9-4455-ABEC-CAC9E6ED0FA6}"/>
+                <a16:creationId xmlns:a16="http://schemas.microsoft.com/office/drawing/2014/main" id="{D033C042-C4CA-4B70-962F-E3FEACC59CA5}"/>
               </a:ext>
             </a:extLst>
           </p:cNvPr>
@@ -5659,7 +5659,7 @@
           <p:cNvPr id="6" name="">
             <a:extLst xmlns:a="http://schemas.openxmlformats.org/drawingml/2006/main">
               <a:ext uri="{FF2B5EF4-FFF2-40B4-BE49-F238E27FC236}">
-                <a16:creationId xmlns:a16="http://schemas.microsoft.com/office/drawing/2014/main" id="{515605CD-3A31-47C0-97F8-259C544943A9}"/>
+                <a16:creationId xmlns:a16="http://schemas.microsoft.com/office/drawing/2014/main" id="{88424B99-09CB-4299-8487-34AF516BED6A}"/>
               </a:ext>
             </a:extLst>
           </p:cNvPr>
@@ -5816,7 +5816,7 @@
           <p:cNvPr id="7" name="">
             <a:extLst xmlns:a="http://schemas.openxmlformats.org/drawingml/2006/main">
               <a:ext uri="{FF2B5EF4-FFF2-40B4-BE49-F238E27FC236}">
-                <a16:creationId xmlns:a16="http://schemas.microsoft.com/office/drawing/2014/main" id="{3A63A7EC-001E-4A92-BA59-A4E7D412FA66}"/>
+                <a16:creationId xmlns:a16="http://schemas.microsoft.com/office/drawing/2014/main" id="{4856BDD0-1E2C-41A5-B4B6-2ADEFF461AE2}"/>
               </a:ext>
             </a:extLst>
           </p:cNvPr>
@@ -5973,7 +5973,7 @@
           <p:cNvPr id="8" name="">
             <a:extLst xmlns:a="http://schemas.openxmlformats.org/drawingml/2006/main">
               <a:ext uri="{FF2B5EF4-FFF2-40B4-BE49-F238E27FC236}">
-                <a16:creationId xmlns:a16="http://schemas.microsoft.com/office/drawing/2014/main" id="{37FAEA42-E5BC-4024-BC02-0580B955722B}"/>
+                <a16:creationId xmlns:a16="http://schemas.microsoft.com/office/drawing/2014/main" id="{3D362AC6-13D7-4EC5-93C4-C4E8417C0F09}"/>
               </a:ext>
             </a:extLst>
           </p:cNvPr>
@@ -5983,7 +5983,7 @@
           <p:nvPr/>
         </p:nvPicPr>
         <p:blipFill>
-          <a:blip xmlns:r="http://schemas.openxmlformats.org/officeDocument/2006/relationships" xmlns:a="http://schemas.openxmlformats.org/drawingml/2006/main" r:embed="Rfa4a458091a04434"/>
+          <a:blip xmlns:r="http://schemas.openxmlformats.org/officeDocument/2006/relationships" xmlns:a="http://schemas.openxmlformats.org/drawingml/2006/main" r:embed="R54ca73df49284ca1"/>
           <a:srcRect xmlns:a="http://schemas.openxmlformats.org/drawingml/2006/main" l="0" t="8654" r="0" b="8654"/>
           <a:stretch xmlns:a="http://schemas.openxmlformats.org/drawingml/2006/main">
             <a:fillRect l="0" t="0" r="0" b="0"/>
@@ -6006,7 +6006,7 @@
           <p:cNvPr id="9" name="">
             <a:extLst xmlns:a="http://schemas.openxmlformats.org/drawingml/2006/main">
               <a:ext uri="{FF2B5EF4-FFF2-40B4-BE49-F238E27FC236}">
-                <a16:creationId xmlns:a16="http://schemas.microsoft.com/office/drawing/2014/main" id="{E4DFFE1B-F9BA-4EE7-BA77-FB9ADA8A395C}"/>
+                <a16:creationId xmlns:a16="http://schemas.microsoft.com/office/drawing/2014/main" id="{1A4C0C10-F02A-4693-AE7C-949B6F699D83}"/>
               </a:ext>
             </a:extLst>
           </p:cNvPr>
@@ -6039,7 +6039,7 @@
           <p:cNvPr id="10" name="">
             <a:extLst xmlns:a="http://schemas.openxmlformats.org/drawingml/2006/main">
               <a:ext uri="{FF2B5EF4-FFF2-40B4-BE49-F238E27FC236}">
-                <a16:creationId xmlns:a16="http://schemas.microsoft.com/office/drawing/2014/main" id="{3FB4FD6C-4DC2-4A46-8DAC-1C5F091755E9}"/>
+                <a16:creationId xmlns:a16="http://schemas.microsoft.com/office/drawing/2014/main" id="{5CDCEB0F-8E90-4561-9E8A-6A08E3533792}"/>
               </a:ext>
             </a:extLst>
           </p:cNvPr>
@@ -6196,7 +6196,7 @@
           <p:cNvPr id="11" name="">
             <a:extLst xmlns:a="http://schemas.openxmlformats.org/drawingml/2006/main">
               <a:ext uri="{FF2B5EF4-FFF2-40B4-BE49-F238E27FC236}">
-                <a16:creationId xmlns:a16="http://schemas.microsoft.com/office/drawing/2014/main" id="{4CFC3403-5635-4B92-9F40-ECC2B9B6969C}"/>
+                <a16:creationId xmlns:a16="http://schemas.microsoft.com/office/drawing/2014/main" id="{EDF4A9C5-530F-4FB2-A790-60A4353323ED}"/>
               </a:ext>
             </a:extLst>
           </p:cNvPr>
@@ -6353,7 +6353,7 @@
           <p:cNvPr id="12" name="">
             <a:extLst xmlns:a="http://schemas.openxmlformats.org/drawingml/2006/main">
               <a:ext uri="{FF2B5EF4-FFF2-40B4-BE49-F238E27FC236}">
-                <a16:creationId xmlns:a16="http://schemas.microsoft.com/office/drawing/2014/main" id="{38149202-A256-4449-B17B-D1091485B5B5}"/>
+                <a16:creationId xmlns:a16="http://schemas.microsoft.com/office/drawing/2014/main" id="{C5898C01-C774-4276-8022-4457681632FB}"/>
               </a:ext>
             </a:extLst>
           </p:cNvPr>
@@ -6508,7 +6508,7 @@
     </p:spTree>
     <p:extLst>
       <p:ext uri="{BB962C8B-B14F-4D97-AF65-F5344CB8AC3E}">
-        <p14:creationId xmlns:p14="http://schemas.microsoft.com/office/powerpoint/2010/main" val="1523180938"/>
+        <p14:creationId xmlns:p14="http://schemas.microsoft.com/office/powerpoint/2010/main" val="646596424"/>
       </p:ext>
     </p:extLst>
   </p:cSld>
@@ -6539,7 +6539,7 @@
           <p:cNvPr id="17" name="">
             <a:extLst xmlns:a="http://schemas.openxmlformats.org/drawingml/2006/main">
               <a:ext uri="{FF2B5EF4-FFF2-40B4-BE49-F238E27FC236}">
-                <a16:creationId xmlns:a16="http://schemas.microsoft.com/office/drawing/2014/main" id="{3A06CBB6-21D8-4F2B-9A44-53DF482C1D16}"/>
+                <a16:creationId xmlns:a16="http://schemas.microsoft.com/office/drawing/2014/main" id="{31DAFFA8-909B-4E34-B6D7-047A72EB39B6}"/>
               </a:ext>
             </a:extLst>
           </p:cNvPr>
@@ -6696,7 +6696,7 @@
           <p:cNvPr id="2" name="">
             <a:extLst xmlns:a="http://schemas.openxmlformats.org/drawingml/2006/main">
               <a:ext uri="{FF2B5EF4-FFF2-40B4-BE49-F238E27FC236}">
-                <a16:creationId xmlns:a16="http://schemas.microsoft.com/office/drawing/2014/main" id="{D9D1C3EB-6EF1-463F-8303-3A028F3582BA}"/>
+                <a16:creationId xmlns:a16="http://schemas.microsoft.com/office/drawing/2014/main" id="{540AE624-B989-4514-A31B-327BAF37C5D1}"/>
               </a:ext>
             </a:extLst>
           </p:cNvPr>
@@ -6853,7 +6853,7 @@
           <p:cNvPr id="3" name="">
             <a:extLst xmlns:a="http://schemas.openxmlformats.org/drawingml/2006/main">
               <a:ext uri="{FF2B5EF4-FFF2-40B4-BE49-F238E27FC236}">
-                <a16:creationId xmlns:a16="http://schemas.microsoft.com/office/drawing/2014/main" id="{6AC2BB3A-B706-403F-A4A4-1E19F16621F7}"/>
+                <a16:creationId xmlns:a16="http://schemas.microsoft.com/office/drawing/2014/main" id="{19A1683A-05AC-4530-848C-9354BC0B6190}"/>
               </a:ext>
             </a:extLst>
           </p:cNvPr>
@@ -6886,7 +6886,7 @@
           <p:cNvPr id="4" name="">
             <a:extLst xmlns:a="http://schemas.openxmlformats.org/drawingml/2006/main">
               <a:ext uri="{FF2B5EF4-FFF2-40B4-BE49-F238E27FC236}">
-                <a16:creationId xmlns:a16="http://schemas.microsoft.com/office/drawing/2014/main" id="{3324F6E9-CEAC-4BA3-8662-FC7FAE5A27BE}"/>
+                <a16:creationId xmlns:a16="http://schemas.microsoft.com/office/drawing/2014/main" id="{4DE1219F-E275-4377-B484-B2783EF6432E}"/>
               </a:ext>
             </a:extLst>
           </p:cNvPr>
@@ -7043,7 +7043,7 @@
           <p:cNvPr id="5" name="">
             <a:extLst xmlns:a="http://schemas.openxmlformats.org/drawingml/2006/main">
               <a:ext uri="{FF2B5EF4-FFF2-40B4-BE49-F238E27FC236}">
-                <a16:creationId xmlns:a16="http://schemas.microsoft.com/office/drawing/2014/main" id="{42CBD186-7323-42B3-BBF6-96716D776C43}"/>
+                <a16:creationId xmlns:a16="http://schemas.microsoft.com/office/drawing/2014/main" id="{CC4CBBA9-6C4C-4A28-93A7-0B2F99FD647E}"/>
               </a:ext>
             </a:extLst>
           </p:cNvPr>
@@ -7200,7 +7200,7 @@
           <p:cNvPr id="6" name="">
             <a:extLst xmlns:a="http://schemas.openxmlformats.org/drawingml/2006/main">
               <a:ext uri="{FF2B5EF4-FFF2-40B4-BE49-F238E27FC236}">
-                <a16:creationId xmlns:a16="http://schemas.microsoft.com/office/drawing/2014/main" id="{9373449E-067C-49FE-BBB2-0DC1B06548A6}"/>
+                <a16:creationId xmlns:a16="http://schemas.microsoft.com/office/drawing/2014/main" id="{212A0990-26E9-4053-87A5-F3E2624914E9}"/>
               </a:ext>
             </a:extLst>
           </p:cNvPr>
@@ -7357,7 +7357,7 @@
           <p:cNvPr id="7" name="">
             <a:extLst xmlns:a="http://schemas.openxmlformats.org/drawingml/2006/main">
               <a:ext uri="{FF2B5EF4-FFF2-40B4-BE49-F238E27FC236}">
-                <a16:creationId xmlns:a16="http://schemas.microsoft.com/office/drawing/2014/main" id="{74FE441A-C974-4BD5-883F-970E65E14087}"/>
+                <a16:creationId xmlns:a16="http://schemas.microsoft.com/office/drawing/2014/main" id="{7E6BF202-2661-4406-B63A-13037727DF37}"/>
               </a:ext>
             </a:extLst>
           </p:cNvPr>
@@ -7390,7 +7390,7 @@
           <p:cNvPr id="8" name="">
             <a:extLst xmlns:a="http://schemas.openxmlformats.org/drawingml/2006/main">
               <a:ext uri="{FF2B5EF4-FFF2-40B4-BE49-F238E27FC236}">
-                <a16:creationId xmlns:a16="http://schemas.microsoft.com/office/drawing/2014/main" id="{92C0EDCB-EFFB-4E43-B318-7E2FD4F3D2C3}"/>
+                <a16:creationId xmlns:a16="http://schemas.microsoft.com/office/drawing/2014/main" id="{B0BF0B05-A9A0-4F02-A6C8-EEC8A2D3D701}"/>
               </a:ext>
             </a:extLst>
           </p:cNvPr>
@@ -7547,7 +7547,7 @@
           <p:cNvPr id="9" name="">
             <a:extLst xmlns:a="http://schemas.openxmlformats.org/drawingml/2006/main">
               <a:ext uri="{FF2B5EF4-FFF2-40B4-BE49-F238E27FC236}">
-                <a16:creationId xmlns:a16="http://schemas.microsoft.com/office/drawing/2014/main" id="{E15F80FA-1B4D-4C0B-B56B-A3B11539C61A}"/>
+                <a16:creationId xmlns:a16="http://schemas.microsoft.com/office/drawing/2014/main" id="{8407C5B9-6E6B-4CE6-8E73-075F5D4B1846}"/>
               </a:ext>
             </a:extLst>
           </p:cNvPr>
@@ -7704,7 +7704,7 @@
           <p:cNvPr id="10" name="">
             <a:extLst xmlns:a="http://schemas.openxmlformats.org/drawingml/2006/main">
               <a:ext uri="{FF2B5EF4-FFF2-40B4-BE49-F238E27FC236}">
-                <a16:creationId xmlns:a16="http://schemas.microsoft.com/office/drawing/2014/main" id="{0C41EF02-1B9C-47AA-8F8E-108F9FC21E95}"/>
+                <a16:creationId xmlns:a16="http://schemas.microsoft.com/office/drawing/2014/main" id="{7BA20054-96C8-48C5-A858-421C244B540C}"/>
               </a:ext>
             </a:extLst>
           </p:cNvPr>
@@ -7861,7 +7861,7 @@
           <p:cNvPr id="11" name="">
             <a:extLst xmlns:a="http://schemas.openxmlformats.org/drawingml/2006/main">
               <a:ext uri="{FF2B5EF4-FFF2-40B4-BE49-F238E27FC236}">
-                <a16:creationId xmlns:a16="http://schemas.microsoft.com/office/drawing/2014/main" id="{1E05D7AE-F30C-4ECC-A792-053E659D68EF}"/>
+                <a16:creationId xmlns:a16="http://schemas.microsoft.com/office/drawing/2014/main" id="{0FDA132E-CD9E-44ED-9B27-D4436F434B61}"/>
               </a:ext>
             </a:extLst>
           </p:cNvPr>
@@ -7894,7 +7894,7 @@
           <p:cNvPr id="12" name="">
             <a:extLst xmlns:a="http://schemas.openxmlformats.org/drawingml/2006/main">
               <a:ext uri="{FF2B5EF4-FFF2-40B4-BE49-F238E27FC236}">
-                <a16:creationId xmlns:a16="http://schemas.microsoft.com/office/drawing/2014/main" id="{B95F7300-60BA-426D-9CF9-E8AA8C1C4740}"/>
+                <a16:creationId xmlns:a16="http://schemas.microsoft.com/office/drawing/2014/main" id="{8A6D5A98-AAE8-4C8B-A634-1C4919263C94}"/>
               </a:ext>
             </a:extLst>
           </p:cNvPr>
@@ -8051,7 +8051,7 @@
           <p:cNvPr id="13" name="">
             <a:extLst xmlns:a="http://schemas.openxmlformats.org/drawingml/2006/main">
               <a:ext uri="{FF2B5EF4-FFF2-40B4-BE49-F238E27FC236}">
-                <a16:creationId xmlns:a16="http://schemas.microsoft.com/office/drawing/2014/main" id="{89CF09C2-44FB-45DA-9514-91CF0D20B7A0}"/>
+                <a16:creationId xmlns:a16="http://schemas.microsoft.com/office/drawing/2014/main" id="{539D3989-F36D-42FD-BBC8-7D4248F00C46}"/>
               </a:ext>
             </a:extLst>
           </p:cNvPr>
@@ -8208,7 +8208,7 @@
           <p:cNvPr id="14" name="">
             <a:extLst xmlns:a="http://schemas.openxmlformats.org/drawingml/2006/main">
               <a:ext uri="{FF2B5EF4-FFF2-40B4-BE49-F238E27FC236}">
-                <a16:creationId xmlns:a16="http://schemas.microsoft.com/office/drawing/2014/main" id="{B3534337-76E0-486F-BBB3-2770692AC61F}"/>
+                <a16:creationId xmlns:a16="http://schemas.microsoft.com/office/drawing/2014/main" id="{FC73F5D2-A952-49DC-AF28-FF026B1E0312}"/>
               </a:ext>
             </a:extLst>
           </p:cNvPr>
@@ -8365,7 +8365,7 @@
           <p:cNvPr id="15" name="">
             <a:extLst xmlns:a="http://schemas.openxmlformats.org/drawingml/2006/main">
               <a:ext uri="{FF2B5EF4-FFF2-40B4-BE49-F238E27FC236}">
-                <a16:creationId xmlns:a16="http://schemas.microsoft.com/office/drawing/2014/main" id="{5FFB1B25-D25A-425D-A5AF-113EB9E69614}"/>
+                <a16:creationId xmlns:a16="http://schemas.microsoft.com/office/drawing/2014/main" id="{8401454B-DECB-41FB-AF20-3753D4208F10}"/>
               </a:ext>
             </a:extLst>
           </p:cNvPr>
@@ -8522,7 +8522,7 @@
           <p:cNvPr id="16" name="">
             <a:extLst xmlns:a="http://schemas.openxmlformats.org/drawingml/2006/main">
               <a:ext uri="{FF2B5EF4-FFF2-40B4-BE49-F238E27FC236}">
-                <a16:creationId xmlns:a16="http://schemas.microsoft.com/office/drawing/2014/main" id="{226149A3-A445-49CC-9C0B-8920F08BB845}"/>
+                <a16:creationId xmlns:a16="http://schemas.microsoft.com/office/drawing/2014/main" id="{F97B9FFD-060F-408A-B96B-250061888351}"/>
               </a:ext>
             </a:extLst>
           </p:cNvPr>
@@ -8677,7 +8677,7 @@
     </p:spTree>
     <p:extLst>
       <p:ext uri="{BB962C8B-B14F-4D97-AF65-F5344CB8AC3E}">
-        <p14:creationId xmlns:p14="http://schemas.microsoft.com/office/powerpoint/2010/main" val="55867974"/>
+        <p14:creationId xmlns:p14="http://schemas.microsoft.com/office/powerpoint/2010/main" val="1482637090"/>
       </p:ext>
     </p:extLst>
   </p:cSld>
@@ -8708,7 +8708,7 @@
           <p:cNvPr id="13" name="">
             <a:extLst xmlns:a="http://schemas.openxmlformats.org/drawingml/2006/main">
               <a:ext uri="{FF2B5EF4-FFF2-40B4-BE49-F238E27FC236}">
-                <a16:creationId xmlns:a16="http://schemas.microsoft.com/office/drawing/2014/main" id="{05CAFFD5-F27A-4C28-B3A7-53777454AB34}"/>
+                <a16:creationId xmlns:a16="http://schemas.microsoft.com/office/drawing/2014/main" id="{2DF543AA-FD22-4672-93BA-079ABBF1E742}"/>
               </a:ext>
             </a:extLst>
           </p:cNvPr>
@@ -8865,7 +8865,7 @@
           <p:cNvPr id="2" name="">
             <a:extLst xmlns:a="http://schemas.openxmlformats.org/drawingml/2006/main">
               <a:ext uri="{FF2B5EF4-FFF2-40B4-BE49-F238E27FC236}">
-                <a16:creationId xmlns:a16="http://schemas.microsoft.com/office/drawing/2014/main" id="{7460B324-96A7-45CC-B840-8FB7C6A5CE22}"/>
+                <a16:creationId xmlns:a16="http://schemas.microsoft.com/office/drawing/2014/main" id="{F20DD2A8-EEDF-4535-9DC7-2B619561EB15}"/>
               </a:ext>
             </a:extLst>
           </p:cNvPr>
@@ -9022,7 +9022,7 @@
           <p:cNvPr id="3" name="">
             <a:extLst xmlns:a="http://schemas.openxmlformats.org/drawingml/2006/main">
               <a:ext uri="{FF2B5EF4-FFF2-40B4-BE49-F238E27FC236}">
-                <a16:creationId xmlns:a16="http://schemas.microsoft.com/office/drawing/2014/main" id="{90FFA6B7-7F5A-45BA-A7ED-4A3A4B45EFFF}"/>
+                <a16:creationId xmlns:a16="http://schemas.microsoft.com/office/drawing/2014/main" id="{21AD0936-EB4B-4875-BD42-87FA51862760}"/>
               </a:ext>
             </a:extLst>
           </p:cNvPr>
@@ -9055,7 +9055,7 @@
           <p:cNvPr id="4" name="Chart">
             <a:extLst xmlns:a="http://schemas.openxmlformats.org/drawingml/2006/main">
               <a:ext uri="{FF2B5EF4-FFF2-40B4-BE49-F238E27FC236}">
-                <a16:creationId xmlns:a16="http://schemas.microsoft.com/office/drawing/2014/main" id="{0652919E-0236-49CE-A663-ACF9C3025DA2}"/>
+                <a16:creationId xmlns:a16="http://schemas.microsoft.com/office/drawing/2014/main" id="{014D7BE8-6D2A-4080-B2CA-6E25D628E555}"/>
               </a:ext>
             </a:extLst>
           </p:cNvPr>
@@ -9068,7 +9068,7 @@
         </p:xfrm>
         <a:graphic xmlns:a="http://schemas.openxmlformats.org/drawingml/2006/main">
           <a:graphicData uri="http://schemas.openxmlformats.org/drawingml/2006/chart">
-            <c:chart xmlns:r="http://schemas.openxmlformats.org/officeDocument/2006/relationships" xmlns:c="http://schemas.openxmlformats.org/drawingml/2006/chart" r:id="Refabeacf96154715"/>
+            <c:chart xmlns:r="http://schemas.openxmlformats.org/officeDocument/2006/relationships" xmlns:c="http://schemas.openxmlformats.org/drawingml/2006/chart" r:id="R5fa62f13c83a4150"/>
           </a:graphicData>
         </a:graphic>
       </p:graphicFrame>
@@ -9077,7 +9077,7 @@
           <p:cNvPr id="5" name="">
             <a:extLst xmlns:a="http://schemas.openxmlformats.org/drawingml/2006/main">
               <a:ext uri="{FF2B5EF4-FFF2-40B4-BE49-F238E27FC236}">
-                <a16:creationId xmlns:a16="http://schemas.microsoft.com/office/drawing/2014/main" id="{6E24400D-367C-4D0A-956B-374D05BD9420}"/>
+                <a16:creationId xmlns:a16="http://schemas.microsoft.com/office/drawing/2014/main" id="{5DE9EEF0-8418-4679-BF50-7B42AABC0C43}"/>
               </a:ext>
             </a:extLst>
           </p:cNvPr>
@@ -9234,7 +9234,7 @@
           <p:cNvPr id="6" name="">
             <a:extLst xmlns:a="http://schemas.openxmlformats.org/drawingml/2006/main">
               <a:ext uri="{FF2B5EF4-FFF2-40B4-BE49-F238E27FC236}">
-                <a16:creationId xmlns:a16="http://schemas.microsoft.com/office/drawing/2014/main" id="{BE0BCD4F-240B-4694-8472-4C6144CAEF86}"/>
+                <a16:creationId xmlns:a16="http://schemas.microsoft.com/office/drawing/2014/main" id="{DBEC85EA-535B-4B71-9688-22B376B6FB2A}"/>
               </a:ext>
             </a:extLst>
           </p:cNvPr>
@@ -9391,7 +9391,7 @@
           <p:cNvPr id="7" name="">
             <a:extLst xmlns:a="http://schemas.openxmlformats.org/drawingml/2006/main">
               <a:ext uri="{FF2B5EF4-FFF2-40B4-BE49-F238E27FC236}">
-                <a16:creationId xmlns:a16="http://schemas.microsoft.com/office/drawing/2014/main" id="{AF4F2F5C-0E37-4210-BE4C-BA87E239AF28}"/>
+                <a16:creationId xmlns:a16="http://schemas.microsoft.com/office/drawing/2014/main" id="{1553E03D-B65C-45BD-B82C-2E84F22044A9}"/>
               </a:ext>
             </a:extLst>
           </p:cNvPr>
@@ -9424,7 +9424,7 @@
           <p:cNvPr id="8" name="">
             <a:extLst xmlns:a="http://schemas.openxmlformats.org/drawingml/2006/main">
               <a:ext uri="{FF2B5EF4-FFF2-40B4-BE49-F238E27FC236}">
-                <a16:creationId xmlns:a16="http://schemas.microsoft.com/office/drawing/2014/main" id="{3EF3802C-2E2C-4596-91F3-DB88C5A6E1C8}"/>
+                <a16:creationId xmlns:a16="http://schemas.microsoft.com/office/drawing/2014/main" id="{0F998B18-B413-493E-9B12-0BB53BD9BC95}"/>
               </a:ext>
             </a:extLst>
           </p:cNvPr>
@@ -9581,7 +9581,7 @@
           <p:cNvPr id="9" name="">
             <a:extLst xmlns:a="http://schemas.openxmlformats.org/drawingml/2006/main">
               <a:ext uri="{FF2B5EF4-FFF2-40B4-BE49-F238E27FC236}">
-                <a16:creationId xmlns:a16="http://schemas.microsoft.com/office/drawing/2014/main" id="{070A7A0F-DE1C-4DC2-89B3-2409CDC8D88A}"/>
+                <a16:creationId xmlns:a16="http://schemas.microsoft.com/office/drawing/2014/main" id="{20413F30-76BA-49EA-8B1B-51DECA36EE0F}"/>
               </a:ext>
             </a:extLst>
           </p:cNvPr>
@@ -9738,7 +9738,7 @@
           <p:cNvPr id="10" name="">
             <a:extLst xmlns:a="http://schemas.openxmlformats.org/drawingml/2006/main">
               <a:ext uri="{FF2B5EF4-FFF2-40B4-BE49-F238E27FC236}">
-                <a16:creationId xmlns:a16="http://schemas.microsoft.com/office/drawing/2014/main" id="{7CD3ADD2-8737-4C69-9047-0714455C88CA}"/>
+                <a16:creationId xmlns:a16="http://schemas.microsoft.com/office/drawing/2014/main" id="{AB18C6C6-AB4B-4F5E-AF78-114705CE9213}"/>
               </a:ext>
             </a:extLst>
           </p:cNvPr>
@@ -9895,7 +9895,7 @@
           <p:cNvPr id="11" name="">
             <a:extLst xmlns:a="http://schemas.openxmlformats.org/drawingml/2006/main">
               <a:ext uri="{FF2B5EF4-FFF2-40B4-BE49-F238E27FC236}">
-                <a16:creationId xmlns:a16="http://schemas.microsoft.com/office/drawing/2014/main" id="{8310D3F5-B75E-400B-982C-7AFA09BB1703}"/>
+                <a16:creationId xmlns:a16="http://schemas.microsoft.com/office/drawing/2014/main" id="{35C24D6A-56C9-4C7D-8F74-0091EC783177}"/>
               </a:ext>
             </a:extLst>
           </p:cNvPr>
@@ -10052,7 +10052,7 @@
           <p:cNvPr id="12" name="">
             <a:extLst xmlns:a="http://schemas.openxmlformats.org/drawingml/2006/main">
               <a:ext uri="{FF2B5EF4-FFF2-40B4-BE49-F238E27FC236}">
-                <a16:creationId xmlns:a16="http://schemas.microsoft.com/office/drawing/2014/main" id="{D31049AE-E90B-4357-9227-F3F21EF8FF5E}"/>
+                <a16:creationId xmlns:a16="http://schemas.microsoft.com/office/drawing/2014/main" id="{261C1578-A401-4BFA-9CE6-AC13E63F7075}"/>
               </a:ext>
             </a:extLst>
           </p:cNvPr>
@@ -10207,7 +10207,7 @@
     </p:spTree>
     <p:extLst>
       <p:ext uri="{BB962C8B-B14F-4D97-AF65-F5344CB8AC3E}">
-        <p14:creationId xmlns:p14="http://schemas.microsoft.com/office/powerpoint/2010/main" val="1242094630"/>
+        <p14:creationId xmlns:p14="http://schemas.microsoft.com/office/powerpoint/2010/main" val="448543944"/>
       </p:ext>
     </p:extLst>
   </p:cSld>
@@ -10238,7 +10238,7 @@
           <p:cNvPr id="15" name="">
             <a:extLst xmlns:a="http://schemas.openxmlformats.org/drawingml/2006/main">
               <a:ext uri="{FF2B5EF4-FFF2-40B4-BE49-F238E27FC236}">
-                <a16:creationId xmlns:a16="http://schemas.microsoft.com/office/drawing/2014/main" id="{A1DE4218-FB63-435B-85E3-D36C17528CA0}"/>
+                <a16:creationId xmlns:a16="http://schemas.microsoft.com/office/drawing/2014/main" id="{71DC93A6-7DF8-41AA-A7A4-1F37BAAA36E2}"/>
               </a:ext>
             </a:extLst>
           </p:cNvPr>
@@ -10395,7 +10395,7 @@
           <p:cNvPr id="2" name="">
             <a:extLst xmlns:a="http://schemas.openxmlformats.org/drawingml/2006/main">
               <a:ext uri="{FF2B5EF4-FFF2-40B4-BE49-F238E27FC236}">
-                <a16:creationId xmlns:a16="http://schemas.microsoft.com/office/drawing/2014/main" id="{E013C939-9CEC-43EB-B492-82985D2D9E72}"/>
+                <a16:creationId xmlns:a16="http://schemas.microsoft.com/office/drawing/2014/main" id="{EA66B133-C86C-4F5B-9006-D1418D747435}"/>
               </a:ext>
             </a:extLst>
           </p:cNvPr>
@@ -10542,7 +10542,7 @@
                 <a:ea typeface="Aptos Display"/>
                 <a:cs typeface="Aptos Display"/>
               </a:rPr>
-              <a:t>The successor compatibility screen is still running</a:t>
+              <a:t>The successor run found a cohort problem before training</a:t>
             </a:r>
           </a:p>
         </p:txBody>
@@ -10552,7 +10552,7 @@
           <p:cNvPr id="3" name="">
             <a:extLst xmlns:a="http://schemas.openxmlformats.org/drawingml/2006/main">
               <a:ext uri="{FF2B5EF4-FFF2-40B4-BE49-F238E27FC236}">
-                <a16:creationId xmlns:a16="http://schemas.microsoft.com/office/drawing/2014/main" id="{E5C9DDE7-DD0F-434A-8975-5AEA4025A74C}"/>
+                <a16:creationId xmlns:a16="http://schemas.microsoft.com/office/drawing/2014/main" id="{D0BBD783-85F1-4925-B3DA-3AF45BC5805B}"/>
               </a:ext>
             </a:extLst>
           </p:cNvPr>
@@ -10585,7 +10585,7 @@
           <p:cNvPr id="4" name="">
             <a:extLst xmlns:a="http://schemas.openxmlformats.org/drawingml/2006/main">
               <a:ext uri="{FF2B5EF4-FFF2-40B4-BE49-F238E27FC236}">
-                <a16:creationId xmlns:a16="http://schemas.microsoft.com/office/drawing/2014/main" id="{08D52B16-BECB-48A7-8E81-DC0B76DA6493}"/>
+                <a16:creationId xmlns:a16="http://schemas.microsoft.com/office/drawing/2014/main" id="{C568DED7-91A4-4683-A486-DF83CBEE3429}"/>
               </a:ext>
             </a:extLst>
           </p:cNvPr>
@@ -10742,7 +10742,7 @@
           <p:cNvPr id="5" name="">
             <a:extLst xmlns:a="http://schemas.openxmlformats.org/drawingml/2006/main">
               <a:ext uri="{FF2B5EF4-FFF2-40B4-BE49-F238E27FC236}">
-                <a16:creationId xmlns:a16="http://schemas.microsoft.com/office/drawing/2014/main" id="{C1A8A01B-CEA2-4ACF-A60B-90DE6C2686D2}"/>
+                <a16:creationId xmlns:a16="http://schemas.microsoft.com/office/drawing/2014/main" id="{7306156A-5CF6-4625-843E-69FC019EEEDC}"/>
               </a:ext>
             </a:extLst>
           </p:cNvPr>
@@ -10889,7 +10889,7 @@
                 <a:ea typeface="Aptos"/>
                 <a:cs typeface="Aptos"/>
               </a:rPr>
-              <a:t>planned packages</a:t>
+              <a:t>of 456 checked</a:t>
             </a:r>
           </a:p>
         </p:txBody>
@@ -10899,7 +10899,7 @@
           <p:cNvPr id="6" name="">
             <a:extLst xmlns:a="http://schemas.openxmlformats.org/drawingml/2006/main">
               <a:ext uri="{FF2B5EF4-FFF2-40B4-BE49-F238E27FC236}">
-                <a16:creationId xmlns:a16="http://schemas.microsoft.com/office/drawing/2014/main" id="{CF2347AD-AB09-4BEB-9983-146BE82E72D0}"/>
+                <a16:creationId xmlns:a16="http://schemas.microsoft.com/office/drawing/2014/main" id="{2E629606-60D5-4EB3-A990-22D8C14CF65A}"/>
               </a:ext>
             </a:extLst>
           </p:cNvPr>
@@ -11046,7 +11046,7 @@
                 <a:ea typeface="Aptos Display"/>
                 <a:cs typeface="Aptos Display"/>
               </a:rPr>
-              <a:t>0</a:t>
+              <a:t>406</a:t>
             </a:r>
           </a:p>
         </p:txBody>
@@ -11056,7 +11056,7 @@
           <p:cNvPr id="7" name="">
             <a:extLst xmlns:a="http://schemas.openxmlformats.org/drawingml/2006/main">
               <a:ext uri="{FF2B5EF4-FFF2-40B4-BE49-F238E27FC236}">
-                <a16:creationId xmlns:a16="http://schemas.microsoft.com/office/drawing/2014/main" id="{FD7A1A00-67BA-43B4-8485-47464E2D7A04}"/>
+                <a16:creationId xmlns:a16="http://schemas.microsoft.com/office/drawing/2014/main" id="{F7787D1C-5033-4AAA-A7C1-C9F23FAAA90D}"/>
               </a:ext>
             </a:extLst>
           </p:cNvPr>
@@ -11203,7 +11203,7 @@
                 <a:ea typeface="Aptos"/>
                 <a:cs typeface="Aptos"/>
               </a:rPr>
-              <a:t>new model runs</a:t>
+              <a:t>compatible</a:t>
             </a:r>
           </a:p>
         </p:txBody>
@@ -11213,7 +11213,7 @@
           <p:cNvPr id="8" name="">
             <a:extLst xmlns:a="http://schemas.openxmlformats.org/drawingml/2006/main">
               <a:ext uri="{FF2B5EF4-FFF2-40B4-BE49-F238E27FC236}">
-                <a16:creationId xmlns:a16="http://schemas.microsoft.com/office/drawing/2014/main" id="{4CEF00A1-C771-4BCB-BBF9-99265B8A5C71}"/>
+                <a16:creationId xmlns:a16="http://schemas.microsoft.com/office/drawing/2014/main" id="{75C71EC0-2EB0-4D7D-8990-D175C3154F58}"/>
               </a:ext>
             </a:extLst>
           </p:cNvPr>
@@ -11360,7 +11360,7 @@
                 <a:ea typeface="Aptos Display"/>
                 <a:cs typeface="Aptos Display"/>
               </a:rPr>
-              <a:t>35</a:t>
+              <a:t>50</a:t>
             </a:r>
           </a:p>
         </p:txBody>
@@ -11370,7 +11370,7 @@
           <p:cNvPr id="9" name="">
             <a:extLst xmlns:a="http://schemas.openxmlformats.org/drawingml/2006/main">
               <a:ext uri="{FF2B5EF4-FFF2-40B4-BE49-F238E27FC236}">
-                <a16:creationId xmlns:a16="http://schemas.microsoft.com/office/drawing/2014/main" id="{BDA7319C-56CD-4ED5-8042-751FD80BE82C}"/>
+                <a16:creationId xmlns:a16="http://schemas.microsoft.com/office/drawing/2014/main" id="{0C052983-9419-4B2F-9008-06370D02F0F1}"/>
               </a:ext>
             </a:extLst>
           </p:cNvPr>
@@ -11517,7 +11517,7 @@
                 <a:ea typeface="Aptos"/>
                 <a:cs typeface="Aptos"/>
               </a:rPr>
-              <a:t>holdout tasks sealed</a:t>
+              <a:t>incompatible</a:t>
             </a:r>
           </a:p>
         </p:txBody>
@@ -11527,7 +11527,7 @@
           <p:cNvPr id="10" name="">
             <a:extLst xmlns:a="http://schemas.openxmlformats.org/drawingml/2006/main">
               <a:ext uri="{FF2B5EF4-FFF2-40B4-BE49-F238E27FC236}">
-                <a16:creationId xmlns:a16="http://schemas.microsoft.com/office/drawing/2014/main" id="{195BCA54-16C0-453D-9159-D3BA93BE8A23}"/>
+                <a16:creationId xmlns:a16="http://schemas.microsoft.com/office/drawing/2014/main" id="{356BFA59-0C84-4CA1-BF95-211BB58B8509}"/>
               </a:ext>
             </a:extLst>
           </p:cNvPr>
@@ -11560,7 +11560,7 @@
           <p:cNvPr id="11" name="">
             <a:extLst xmlns:a="http://schemas.openxmlformats.org/drawingml/2006/main">
               <a:ext uri="{FF2B5EF4-FFF2-40B4-BE49-F238E27FC236}">
-                <a16:creationId xmlns:a16="http://schemas.microsoft.com/office/drawing/2014/main" id="{36B5FFCF-5360-4982-B570-12B26670FC03}"/>
+                <a16:creationId xmlns:a16="http://schemas.microsoft.com/office/drawing/2014/main" id="{FB6DAA6B-ED27-4E18-8588-F86F6E0A4EDA}"/>
               </a:ext>
             </a:extLst>
           </p:cNvPr>
@@ -11707,7 +11707,7 @@
                 <a:ea typeface="Aptos Display"/>
                 <a:cs typeface="Aptos Display"/>
               </a:rPr>
-              <a:t>The compatibility screen is still running. Incompatibilities already recorded prevent new training or model evaluation. The full matrix is not yet a terminal result.</a:t>
+              <a:t>Because at least one task package was incompatible, the registered protocol stopped before qualification, training, or model evaluation.</a:t>
             </a:r>
           </a:p>
         </p:txBody>
@@ -11717,7 +11717,7 @@
           <p:cNvPr id="12" name="">
             <a:extLst xmlns:a="http://schemas.openxmlformats.org/drawingml/2006/main">
               <a:ext uri="{FF2B5EF4-FFF2-40B4-BE49-F238E27FC236}">
-                <a16:creationId xmlns:a16="http://schemas.microsoft.com/office/drawing/2014/main" id="{4B16DE82-736A-469B-B0C0-138FC8A40E99}"/>
+                <a16:creationId xmlns:a16="http://schemas.microsoft.com/office/drawing/2014/main" id="{E005BFC5-9386-4D08-8BB4-4C30D5FB0A60}"/>
               </a:ext>
             </a:extLst>
           </p:cNvPr>
@@ -11874,7 +11874,7 @@
           <p:cNvPr id="13" name="">
             <a:extLst xmlns:a="http://schemas.openxmlformats.org/drawingml/2006/main">
               <a:ext uri="{FF2B5EF4-FFF2-40B4-BE49-F238E27FC236}">
-                <a16:creationId xmlns:a16="http://schemas.microsoft.com/office/drawing/2014/main" id="{2A0FA241-CAC4-4ADE-84D8-8EBBF9C7CE0E}"/>
+                <a16:creationId xmlns:a16="http://schemas.microsoft.com/office/drawing/2014/main" id="{AE585819-1B23-4C62-ABCB-2AD76165EE24}"/>
               </a:ext>
             </a:extLst>
           </p:cNvPr>
@@ -12031,7 +12031,7 @@
           <p:cNvPr id="14" name="">
             <a:extLst xmlns:a="http://schemas.openxmlformats.org/drawingml/2006/main">
               <a:ext uri="{FF2B5EF4-FFF2-40B4-BE49-F238E27FC236}">
-                <a16:creationId xmlns:a16="http://schemas.microsoft.com/office/drawing/2014/main" id="{7ECF5D9E-FE42-4D06-B706-86483EF673D1}"/>
+                <a16:creationId xmlns:a16="http://schemas.microsoft.com/office/drawing/2014/main" id="{EACFA2F8-BE84-4636-937F-318715FE7D8A}"/>
               </a:ext>
             </a:extLst>
           </p:cNvPr>
@@ -12186,7 +12186,7 @@
     </p:spTree>
     <p:extLst>
       <p:ext uri="{BB962C8B-B14F-4D97-AF65-F5344CB8AC3E}">
-        <p14:creationId xmlns:p14="http://schemas.microsoft.com/office/powerpoint/2010/main" val="1539469604"/>
+        <p14:creationId xmlns:p14="http://schemas.microsoft.com/office/powerpoint/2010/main" val="882448876"/>
       </p:ext>
     </p:extLst>
   </p:cSld>
@@ -12217,7 +12217,7 @@
           <p:cNvPr id="17" name="">
             <a:extLst xmlns:a="http://schemas.openxmlformats.org/drawingml/2006/main">
               <a:ext uri="{FF2B5EF4-FFF2-40B4-BE49-F238E27FC236}">
-                <a16:creationId xmlns:a16="http://schemas.microsoft.com/office/drawing/2014/main" id="{D7B85EED-157E-4485-BEE5-C173B5027981}"/>
+                <a16:creationId xmlns:a16="http://schemas.microsoft.com/office/drawing/2014/main" id="{E69B719E-E643-4EBB-92C8-0C5BF59D8798}"/>
               </a:ext>
             </a:extLst>
           </p:cNvPr>
@@ -12374,7 +12374,7 @@
           <p:cNvPr id="2" name="">
             <a:extLst xmlns:a="http://schemas.openxmlformats.org/drawingml/2006/main">
               <a:ext uri="{FF2B5EF4-FFF2-40B4-BE49-F238E27FC236}">
-                <a16:creationId xmlns:a16="http://schemas.microsoft.com/office/drawing/2014/main" id="{E77316B2-ACD8-45F2-937A-14EFB816E5FA}"/>
+                <a16:creationId xmlns:a16="http://schemas.microsoft.com/office/drawing/2014/main" id="{203AA3E3-0144-431D-AA51-CD875D3C1BF7}"/>
               </a:ext>
             </a:extLst>
           </p:cNvPr>
@@ -12531,7 +12531,7 @@
           <p:cNvPr id="3" name="">
             <a:extLst xmlns:a="http://schemas.openxmlformats.org/drawingml/2006/main">
               <a:ext uri="{FF2B5EF4-FFF2-40B4-BE49-F238E27FC236}">
-                <a16:creationId xmlns:a16="http://schemas.microsoft.com/office/drawing/2014/main" id="{00D9BE37-8815-44F2-A3FB-030EECC026D5}"/>
+                <a16:creationId xmlns:a16="http://schemas.microsoft.com/office/drawing/2014/main" id="{F8B21C9C-77EE-44E7-A426-FD55BC41D9C7}"/>
               </a:ext>
             </a:extLst>
           </p:cNvPr>
@@ -12564,7 +12564,7 @@
           <p:cNvPr id="4" name="">
             <a:extLst xmlns:a="http://schemas.openxmlformats.org/drawingml/2006/main">
               <a:ext uri="{FF2B5EF4-FFF2-40B4-BE49-F238E27FC236}">
-                <a16:creationId xmlns:a16="http://schemas.microsoft.com/office/drawing/2014/main" id="{CDDEF5CD-8AF2-4893-9D99-2682BF4757C9}"/>
+                <a16:creationId xmlns:a16="http://schemas.microsoft.com/office/drawing/2014/main" id="{1DC9BF80-EBA2-4B16-80B8-9AC6C5C88529}"/>
               </a:ext>
             </a:extLst>
           </p:cNvPr>
@@ -12721,7 +12721,7 @@
           <p:cNvPr id="5" name="">
             <a:extLst xmlns:a="http://schemas.openxmlformats.org/drawingml/2006/main">
               <a:ext uri="{FF2B5EF4-FFF2-40B4-BE49-F238E27FC236}">
-                <a16:creationId xmlns:a16="http://schemas.microsoft.com/office/drawing/2014/main" id="{CE338345-6952-44F8-89BA-3A025FD24053}"/>
+                <a16:creationId xmlns:a16="http://schemas.microsoft.com/office/drawing/2014/main" id="{46EB4A1F-FD39-47CE-AC9C-B5132238AE8D}"/>
               </a:ext>
             </a:extLst>
           </p:cNvPr>
@@ -12878,7 +12878,7 @@
           <p:cNvPr id="6" name="">
             <a:extLst xmlns:a="http://schemas.openxmlformats.org/drawingml/2006/main">
               <a:ext uri="{FF2B5EF4-FFF2-40B4-BE49-F238E27FC236}">
-                <a16:creationId xmlns:a16="http://schemas.microsoft.com/office/drawing/2014/main" id="{A4750F86-0FAD-481B-8E0A-1998DE3ACBA2}"/>
+                <a16:creationId xmlns:a16="http://schemas.microsoft.com/office/drawing/2014/main" id="{EAA26BF8-EAA9-434C-A21A-0C83F816B089}"/>
               </a:ext>
             </a:extLst>
           </p:cNvPr>
@@ -13035,7 +13035,7 @@
           <p:cNvPr id="7" name="">
             <a:extLst xmlns:a="http://schemas.openxmlformats.org/drawingml/2006/main">
               <a:ext uri="{FF2B5EF4-FFF2-40B4-BE49-F238E27FC236}">
-                <a16:creationId xmlns:a16="http://schemas.microsoft.com/office/drawing/2014/main" id="{F7DAB5A4-9C6D-4DA3-801F-9EE4D58DD3F0}"/>
+                <a16:creationId xmlns:a16="http://schemas.microsoft.com/office/drawing/2014/main" id="{C489600F-791F-4098-93D9-14B7FD8FEF96}"/>
               </a:ext>
             </a:extLst>
           </p:cNvPr>
@@ -13192,7 +13192,7 @@
           <p:cNvPr id="8" name="">
             <a:extLst xmlns:a="http://schemas.openxmlformats.org/drawingml/2006/main">
               <a:ext uri="{FF2B5EF4-FFF2-40B4-BE49-F238E27FC236}">
-                <a16:creationId xmlns:a16="http://schemas.microsoft.com/office/drawing/2014/main" id="{41188A3E-455C-4512-9F00-F3C7668148E0}"/>
+                <a16:creationId xmlns:a16="http://schemas.microsoft.com/office/drawing/2014/main" id="{E54BC07A-0694-439B-BB15-5EC90FA13312}"/>
               </a:ext>
             </a:extLst>
           </p:cNvPr>
@@ -13349,7 +13349,7 @@
           <p:cNvPr id="9" name="">
             <a:extLst xmlns:a="http://schemas.openxmlformats.org/drawingml/2006/main">
               <a:ext uri="{FF2B5EF4-FFF2-40B4-BE49-F238E27FC236}">
-                <a16:creationId xmlns:a16="http://schemas.microsoft.com/office/drawing/2014/main" id="{08295D5F-CCA8-4DA3-BC86-31AA32578C28}"/>
+                <a16:creationId xmlns:a16="http://schemas.microsoft.com/office/drawing/2014/main" id="{265D3CA0-0BA4-4DC3-B49D-5E739240B156}"/>
               </a:ext>
             </a:extLst>
           </p:cNvPr>
@@ -13506,7 +13506,7 @@
           <p:cNvPr id="10" name="">
             <a:extLst xmlns:a="http://schemas.openxmlformats.org/drawingml/2006/main">
               <a:ext uri="{FF2B5EF4-FFF2-40B4-BE49-F238E27FC236}">
-                <a16:creationId xmlns:a16="http://schemas.microsoft.com/office/drawing/2014/main" id="{22C4ABDD-0056-4487-BD9E-26BB1B512683}"/>
+                <a16:creationId xmlns:a16="http://schemas.microsoft.com/office/drawing/2014/main" id="{F0ECEAE9-8C68-4F60-9B91-303818A449BC}"/>
               </a:ext>
             </a:extLst>
           </p:cNvPr>
@@ -13516,7 +13516,7 @@
           <p:nvPr/>
         </p:nvPicPr>
         <p:blipFill>
-          <a:blip xmlns:r="http://schemas.openxmlformats.org/officeDocument/2006/relationships" xmlns:a="http://schemas.openxmlformats.org/drawingml/2006/main" r:embed="Raec655f4845a4e4f"/>
+          <a:blip xmlns:r="http://schemas.openxmlformats.org/officeDocument/2006/relationships" xmlns:a="http://schemas.openxmlformats.org/drawingml/2006/main" r:embed="Rc56cb6b5afd648b0"/>
           <a:srcRect xmlns:a="http://schemas.openxmlformats.org/drawingml/2006/main" l="32479" t="0" r="32479" b="0"/>
           <a:stretch xmlns:a="http://schemas.openxmlformats.org/drawingml/2006/main">
             <a:fillRect l="0" t="0" r="0" b="0"/>
@@ -13537,7 +13537,7 @@
           <p:cNvPr id="11" name="">
             <a:extLst xmlns:a="http://schemas.openxmlformats.org/drawingml/2006/main">
               <a:ext uri="{FF2B5EF4-FFF2-40B4-BE49-F238E27FC236}">
-                <a16:creationId xmlns:a16="http://schemas.microsoft.com/office/drawing/2014/main" id="{C2604EE1-43B4-4696-A2A3-231E677DC938}"/>
+                <a16:creationId xmlns:a16="http://schemas.microsoft.com/office/drawing/2014/main" id="{C9563605-2C5C-4641-9712-AECDD250E537}"/>
               </a:ext>
             </a:extLst>
           </p:cNvPr>
@@ -13547,7 +13547,7 @@
           <p:nvPr/>
         </p:nvPicPr>
         <p:blipFill>
-          <a:blip xmlns:r="http://schemas.openxmlformats.org/officeDocument/2006/relationships" xmlns:a="http://schemas.openxmlformats.org/drawingml/2006/main" r:embed="R28a007d0950d4302"/>
+          <a:blip xmlns:r="http://schemas.openxmlformats.org/officeDocument/2006/relationships" xmlns:a="http://schemas.openxmlformats.org/drawingml/2006/main" r:embed="R4c38dc4919f645ac"/>
           <a:stretch xmlns:a="http://schemas.openxmlformats.org/drawingml/2006/main"/>
         </p:blipFill>
         <p:spPr>
@@ -13565,7 +13565,7 @@
           <p:cNvPr id="12" name="">
             <a:extLst xmlns:a="http://schemas.openxmlformats.org/drawingml/2006/main">
               <a:ext uri="{FF2B5EF4-FFF2-40B4-BE49-F238E27FC236}">
-                <a16:creationId xmlns:a16="http://schemas.microsoft.com/office/drawing/2014/main" id="{A23843B8-B8E8-4F3A-9C4E-67ABA66C2D1D}"/>
+                <a16:creationId xmlns:a16="http://schemas.microsoft.com/office/drawing/2014/main" id="{16AEB497-5F0D-42AE-8729-0B518F502265}"/>
               </a:ext>
             </a:extLst>
           </p:cNvPr>
@@ -13575,7 +13575,7 @@
           <p:nvPr/>
         </p:nvPicPr>
         <p:blipFill>
-          <a:blip xmlns:r="http://schemas.openxmlformats.org/officeDocument/2006/relationships" xmlns:a="http://schemas.openxmlformats.org/drawingml/2006/main" r:embed="R9d44cdfbb4ed408c"/>
+          <a:blip xmlns:r="http://schemas.openxmlformats.org/officeDocument/2006/relationships" xmlns:a="http://schemas.openxmlformats.org/drawingml/2006/main" r:embed="R07b7386f57874cce"/>
           <a:stretch xmlns:a="http://schemas.openxmlformats.org/drawingml/2006/main"/>
         </p:blipFill>
         <p:spPr>
@@ -13593,7 +13593,7 @@
           <p:cNvPr id="13" name="">
             <a:extLst xmlns:a="http://schemas.openxmlformats.org/drawingml/2006/main">
               <a:ext uri="{FF2B5EF4-FFF2-40B4-BE49-F238E27FC236}">
-                <a16:creationId xmlns:a16="http://schemas.microsoft.com/office/drawing/2014/main" id="{9542B711-105B-405A-8386-5646956A37BF}"/>
+                <a16:creationId xmlns:a16="http://schemas.microsoft.com/office/drawing/2014/main" id="{EF9D9822-F928-4749-98F7-B43B574B7C42}"/>
               </a:ext>
             </a:extLst>
           </p:cNvPr>
@@ -13626,7 +13626,7 @@
           <p:cNvPr id="14" name="">
             <a:extLst xmlns:a="http://schemas.openxmlformats.org/drawingml/2006/main">
               <a:ext uri="{FF2B5EF4-FFF2-40B4-BE49-F238E27FC236}">
-                <a16:creationId xmlns:a16="http://schemas.microsoft.com/office/drawing/2014/main" id="{AE8EF024-3C0A-4E06-A068-CCB9F5A87D60}"/>
+                <a16:creationId xmlns:a16="http://schemas.microsoft.com/office/drawing/2014/main" id="{E86F2AE0-8366-41DF-AAB9-FA7C232DDA89}"/>
               </a:ext>
             </a:extLst>
           </p:cNvPr>
@@ -13783,7 +13783,7 @@
           <p:cNvPr id="15" name="">
             <a:extLst xmlns:a="http://schemas.openxmlformats.org/drawingml/2006/main">
               <a:ext uri="{FF2B5EF4-FFF2-40B4-BE49-F238E27FC236}">
-                <a16:creationId xmlns:a16="http://schemas.microsoft.com/office/drawing/2014/main" id="{A93CB527-92DD-4AAF-B895-8F199ABD09DE}"/>
+                <a16:creationId xmlns:a16="http://schemas.microsoft.com/office/drawing/2014/main" id="{7553DBC6-CC5D-44C4-AC7D-D0D38F34A136}"/>
               </a:ext>
             </a:extLst>
           </p:cNvPr>
@@ -13940,7 +13940,7 @@
           <p:cNvPr id="16" name="">
             <a:extLst xmlns:a="http://schemas.openxmlformats.org/drawingml/2006/main">
               <a:ext uri="{FF2B5EF4-FFF2-40B4-BE49-F238E27FC236}">
-                <a16:creationId xmlns:a16="http://schemas.microsoft.com/office/drawing/2014/main" id="{EB9E4162-7BCD-474B-8F28-533C07D57155}"/>
+                <a16:creationId xmlns:a16="http://schemas.microsoft.com/office/drawing/2014/main" id="{D8A7D271-E4CB-44FE-A406-3BE7D88168CF}"/>
               </a:ext>
             </a:extLst>
           </p:cNvPr>
@@ -14095,7 +14095,7 @@
     </p:spTree>
     <p:extLst>
       <p:ext uri="{BB962C8B-B14F-4D97-AF65-F5344CB8AC3E}">
-        <p14:creationId xmlns:p14="http://schemas.microsoft.com/office/powerpoint/2010/main" val="598657892"/>
+        <p14:creationId xmlns:p14="http://schemas.microsoft.com/office/powerpoint/2010/main" val="160816975"/>
       </p:ext>
     </p:extLst>
   </p:cSld>

</xml_diff>